<commit_message>
feat(workshop): Npuls-titelslide en tijdlijn in het uitvoeringsdeck
- Titelslide op de echte blauwe Npuls-achtergrond (Slide15.PNG) met het volledige horizontale logo
- 'Zo loopt de middag' als tijdlijn op schaal, met per blok de bijbehorende skill
- Nabewerkingsscript (postprocess_uitvoering.py) en logo-generator (maak_logo.py)

Co-Authored-By: Claude Sonnet 5.5 <noreply@anthropic.com>
</commit_message>
<xml_diff>
--- a/workshop-rad/exports/261005_workshop_rad_uitvoering.pptx
+++ b/workshop-rad/exports/261005_workshop_rad_uitvoering.pptx
@@ -3524,6 +3524,30 @@
           <a:chExt cx="0" cy="0"/>
         </a:xfrm>
       </p:grpSpPr>
+      <p:pic>
+        <p:nvPicPr>
+          <p:cNvPr id="91" name="Npuls achtergrond" descr="Slide15.PNG"/>
+          <p:cNvPicPr>
+            <a:picLocks noChangeAspect="1"/>
+          </p:cNvPicPr>
+          <p:nvPr/>
+        </p:nvPicPr>
+        <p:blipFill>
+          <a:blip r:embed="rId3"/>
+          <a:stretch>
+            <a:fillRect/>
+          </a:stretch>
+        </p:blipFill>
+        <p:spPr>
+          <a:xfrm>
+            <a:off x="0" y="0"/>
+            <a:ext cx="12192000" cy="6858000"/>
+          </a:xfrm>
+          <a:prstGeom prst="rect">
+            <a:avLst/>
+          </a:prstGeom>
+        </p:spPr>
+      </p:pic>
       <p:sp>
         <p:nvSpPr>
           <p:cNvPr id="72" name="Shape 70"/>
@@ -3532,7 +3556,7 @@
         </p:nvSpPr>
         <p:spPr>
           <a:xfrm>
-            <a:off x="1508760" y="621792"/>
+            <a:off x="3840480" y="640080"/>
             <a:ext cx="3072384" cy="402336"/>
           </a:xfrm>
           <a:prstGeom prst="roundRect">
@@ -3545,6 +3569,10 @@
           </a:solidFill>
           <a:ln/>
         </p:spPr>
+        <p:txBody>
+          <a:bodyPr/>
+          <a:p/>
+        </p:txBody>
       </p:sp>
       <p:sp>
         <p:nvSpPr>
@@ -3554,7 +3582,7 @@
         </p:nvSpPr>
         <p:spPr>
           <a:xfrm>
-            <a:off x="1600200" y="621792"/>
+            <a:off x="3931920" y="640080"/>
             <a:ext cx="2889504" cy="402336"/>
           </a:xfrm>
           <a:prstGeom prst="rect">
@@ -3736,6 +3764,10 @@
             <a:prstDash val="dash"/>
           </a:ln>
         </p:spPr>
+        <p:txBody>
+          <a:bodyPr/>
+          <a:p/>
+        </p:txBody>
       </p:sp>
       <p:sp>
         <p:nvSpPr>
@@ -3756,6 +3788,10 @@
           </a:solidFill>
           <a:ln/>
         </p:spPr>
+        <p:txBody>
+          <a:bodyPr/>
+          <a:p/>
+        </p:txBody>
       </p:sp>
       <p:sp>
         <p:nvSpPr>
@@ -3863,6 +3899,10 @@
             <a:prstDash val="dash"/>
           </a:ln>
         </p:spPr>
+        <p:txBody>
+          <a:bodyPr/>
+          <a:p/>
+        </p:txBody>
       </p:sp>
       <p:sp>
         <p:nvSpPr>
@@ -3883,6 +3923,10 @@
           </a:solidFill>
           <a:ln/>
         </p:spPr>
+        <p:txBody>
+          <a:bodyPr/>
+          <a:p/>
+        </p:txBody>
       </p:sp>
       <p:sp>
         <p:nvSpPr>
@@ -3987,6 +4031,10 @@
           </a:solidFill>
           <a:ln/>
         </p:spPr>
+        <p:txBody>
+          <a:bodyPr/>
+          <a:p/>
+        </p:txBody>
       </p:sp>
       <p:sp>
         <p:nvSpPr>
@@ -4114,6 +4162,10 @@
             <a:prstDash val="solid"/>
           </a:ln>
         </p:spPr>
+        <p:txBody>
+          <a:bodyPr/>
+          <a:p/>
+        </p:txBody>
       </p:sp>
       <p:sp>
         <p:nvSpPr>
@@ -4157,6 +4209,10 @@
             <a:prstDash val="solid"/>
           </a:ln>
         </p:spPr>
+        <p:txBody>
+          <a:bodyPr/>
+          <a:p/>
+        </p:txBody>
       </p:sp>
       <p:sp>
         <p:nvSpPr>
@@ -4166,7 +4222,7 @@
         </p:nvSpPr>
         <p:spPr>
           <a:xfrm>
-            <a:off x="7955280" y="6144768"/>
+            <a:off x="548640" y="1325880"/>
             <a:ext cx="3657600" cy="365760"/>
           </a:xfrm>
           <a:prstGeom prst="rect">
@@ -4179,7 +4235,7 @@
           <a:bodyPr wrap="square" lIns="0" tIns="0" rIns="0" bIns="0" rtlCol="0" anchor="t"/>
           <a:lstStyle/>
           <a:p>
-            <a:pPr algn="r" indent="0" marL="0">
+            <a:pPr algn="l" indent="0" marL="0">
               <a:lnSpc>
                 <a:spcPct val="105000"/>
               </a:lnSpc>
@@ -4202,22 +4258,22 @@
       </p:sp>
       <p:pic>
         <p:nvPicPr>
-          <p:cNvPr id="91" name="Npuls beeldmerk" descr="npuls-beeldmerk-wit.png"/>
+          <p:cNvPr id="92" name="Npuls logo" descr="npuls-logo-horizontaal-wit.png"/>
           <p:cNvPicPr>
             <a:picLocks noChangeAspect="1"/>
           </p:cNvPicPr>
           <p:nvPr/>
         </p:nvPicPr>
         <p:blipFill>
-          <a:blip r:embed="rId3"/>
+          <a:blip r:embed="rId4"/>
           <a:stretch>
             <a:fillRect/>
           </a:stretch>
         </p:blipFill>
         <p:spPr>
           <a:xfrm>
-            <a:off x="587248" y="495808"/>
-            <a:ext cx="654304" cy="654304"/>
+            <a:off x="548640" y="457200"/>
+            <a:ext cx="2011680" cy="724596"/>
           </a:xfrm>
           <a:prstGeom prst="rect">
             <a:avLst/>
@@ -11208,6 +11264,10 @@
           </a:solidFill>
           <a:ln/>
         </p:spPr>
+        <p:txBody>
+          <a:bodyPr/>
+          <a:p/>
+        </p:txBody>
       </p:sp>
       <p:sp>
         <p:nvSpPr>
@@ -11270,6 +11330,10 @@
           </a:solidFill>
           <a:ln/>
         </p:spPr>
+        <p:txBody>
+          <a:bodyPr/>
+          <a:p/>
+        </p:txBody>
       </p:sp>
       <p:sp>
         <p:nvSpPr>
@@ -11332,6 +11396,10 @@
           </a:solidFill>
           <a:ln/>
         </p:spPr>
+        <p:txBody>
+          <a:bodyPr/>
+          <a:p/>
+        </p:txBody>
       </p:sp>
       <p:sp>
         <p:nvSpPr>
@@ -18426,1688 +18494,2039 @@
           </a:p>
         </p:txBody>
       </p:sp>
-      <p:graphicFrame>
-        <p:nvGraphicFramePr>
-          <p:cNvPr id="4" name="Table 0"/>
-          <p:cNvGraphicFramePr>
-            <a:graphicFrameLocks noGrp="1"/>
-          </p:cNvGraphicFramePr>
-          <p:nvPr>
-            <p:extLst>
-              <p:ext uri="{D42A27DB-BD31-4B8C-83A1-F6EECF244321}">
-                <p14:modId xmlns:p14="http://schemas.microsoft.com/office/powerpoint/2010/main" val="1579011935"/>
-              </p:ext>
-            </p:extLst>
-          </p:nvPr>
-        </p:nvGraphicFramePr>
-        <p:xfrm>
-          <a:off x="548640" y="1417320"/>
-          <a:ext cx="11094415" cy="914400"/>
-        </p:xfrm>
-        <a:graphic>
-          <a:graphicData uri="http://schemas.openxmlformats.org/drawingml/2006/table">
-            <a:tbl>
-              <a:tblPr/>
-              <a:tblGrid>
-                <a:gridCol w="1664162"/>
-                <a:gridCol w="7766091"/>
-                <a:gridCol w="1664162"/>
-              </a:tblGrid>
-              <a:tr h="0">
-                <a:tc>
-                  <a:txBody>
-                    <a:bodyPr/>
-                    <a:lstStyle/>
-                    <a:p>
-                      <a:pPr indent="0" marL="0">
-                        <a:buNone/>
-                      </a:pPr>
-                      <a:r>
-                        <a:rPr lang="en-US" sz="1400" dirty="0">
-                          <a:solidFill>
-                            <a:srgbClr val="F4D9DC"/>
-                          </a:solidFill>
-                          <a:latin typeface="General Sans Semibold" pitchFamily="34" charset="0"/>
-                          <a:ea typeface="General Sans Semibold" pitchFamily="34" charset="-122"/>
-                          <a:cs typeface="General Sans Semibold" pitchFamily="34" charset="-120"/>
-                        </a:rPr>
-                        <a:t>Tijd</a:t>
-                      </a:r>
-                      <a:endParaRPr lang="en-US" sz="1400" dirty="0">
-                        <a:latin typeface="General Sans Semibold" charset="0"/>
-                        <a:ea typeface="General Sans Semibold" charset="0"/>
-                        <a:cs typeface="General Sans Semibold" charset="0"/>
-                      </a:endParaRPr>
-                    </a:p>
-                  </a:txBody>
-                  <a:tcPr marL="101600" marR="101600" marT="63500" marB="63500" anchor="ctr">
-                    <a:lnL w="9525" cap="flat" cmpd="sng" algn="ctr">
-                      <a:solidFill>
-                        <a:srgbClr val="F4D9DC"/>
-                      </a:solidFill>
-                      <a:prstDash val="solid"/>
-                      <a:round/>
-                      <a:headEnd type="none" w="med" len="med"/>
-                      <a:tailEnd type="none" w="med" len="med"/>
-                    </a:lnL>
-                    <a:lnR w="9525" cap="flat" cmpd="sng" algn="ctr">
-                      <a:solidFill>
-                        <a:srgbClr val="F4D9DC"/>
-                      </a:solidFill>
-                      <a:prstDash val="solid"/>
-                      <a:round/>
-                      <a:headEnd type="none" w="med" len="med"/>
-                      <a:tailEnd type="none" w="med" len="med"/>
-                    </a:lnR>
-                    <a:lnT w="9525" cap="flat" cmpd="sng" algn="ctr">
-                      <a:solidFill>
-                        <a:srgbClr val="F4D9DC"/>
-                      </a:solidFill>
-                      <a:prstDash val="solid"/>
-                      <a:round/>
-                      <a:headEnd type="none" w="med" len="med"/>
-                      <a:tailEnd type="none" w="med" len="med"/>
-                    </a:lnT>
-                    <a:lnB w="9525" cap="flat" cmpd="sng" algn="ctr">
-                      <a:solidFill>
-                        <a:srgbClr val="F4D9DC"/>
-                      </a:solidFill>
-                      <a:prstDash val="solid"/>
-                      <a:round/>
-                      <a:headEnd type="none" w="med" len="med"/>
-                      <a:tailEnd type="none" w="med" len="med"/>
-                    </a:lnB>
-                    <a:solidFill>
-                      <a:srgbClr val="3D68EC"/>
-                    </a:solidFill>
-                  </a:tcPr>
-                </a:tc>
-                <a:tc>
-                  <a:txBody>
-                    <a:bodyPr/>
-                    <a:lstStyle/>
-                    <a:p>
-                      <a:pPr indent="0" marL="0">
-                        <a:buNone/>
-                      </a:pPr>
-                      <a:r>
-                        <a:rPr lang="en-US" sz="1400" dirty="0">
-                          <a:solidFill>
-                            <a:srgbClr val="F4D9DC"/>
-                          </a:solidFill>
-                          <a:latin typeface="General Sans Semibold" pitchFamily="34" charset="0"/>
-                          <a:ea typeface="General Sans Semibold" pitchFamily="34" charset="-122"/>
-                          <a:cs typeface="General Sans Semibold" pitchFamily="34" charset="-120"/>
-                        </a:rPr>
-                        <a:t>Blok</a:t>
-                      </a:r>
-                      <a:endParaRPr lang="en-US" sz="1400" dirty="0">
-                        <a:latin typeface="General Sans Semibold" charset="0"/>
-                        <a:ea typeface="General Sans Semibold" charset="0"/>
-                        <a:cs typeface="General Sans Semibold" charset="0"/>
-                      </a:endParaRPr>
-                    </a:p>
-                  </a:txBody>
-                  <a:tcPr marL="101600" marR="101600" marT="63500" marB="63500" anchor="ctr">
-                    <a:lnL w="9525" cap="flat" cmpd="sng" algn="ctr">
-                      <a:solidFill>
-                        <a:srgbClr val="F4D9DC"/>
-                      </a:solidFill>
-                      <a:prstDash val="solid"/>
-                      <a:round/>
-                      <a:headEnd type="none" w="med" len="med"/>
-                      <a:tailEnd type="none" w="med" len="med"/>
-                    </a:lnL>
-                    <a:lnR w="9525" cap="flat" cmpd="sng" algn="ctr">
-                      <a:solidFill>
-                        <a:srgbClr val="F4D9DC"/>
-                      </a:solidFill>
-                      <a:prstDash val="solid"/>
-                      <a:round/>
-                      <a:headEnd type="none" w="med" len="med"/>
-                      <a:tailEnd type="none" w="med" len="med"/>
-                    </a:lnR>
-                    <a:lnT w="9525" cap="flat" cmpd="sng" algn="ctr">
-                      <a:solidFill>
-                        <a:srgbClr val="F4D9DC"/>
-                      </a:solidFill>
-                      <a:prstDash val="solid"/>
-                      <a:round/>
-                      <a:headEnd type="none" w="med" len="med"/>
-                      <a:tailEnd type="none" w="med" len="med"/>
-                    </a:lnT>
-                    <a:lnB w="9525" cap="flat" cmpd="sng" algn="ctr">
-                      <a:solidFill>
-                        <a:srgbClr val="F4D9DC"/>
-                      </a:solidFill>
-                      <a:prstDash val="solid"/>
-                      <a:round/>
-                      <a:headEnd type="none" w="med" len="med"/>
-                      <a:tailEnd type="none" w="med" len="med"/>
-                    </a:lnB>
-                    <a:solidFill>
-                      <a:srgbClr val="3D68EC"/>
-                    </a:solidFill>
-                  </a:tcPr>
-                </a:tc>
-                <a:tc>
-                  <a:txBody>
-                    <a:bodyPr/>
-                    <a:lstStyle/>
-                    <a:p>
-                      <a:pPr indent="0" marL="0">
-                        <a:buNone/>
-                      </a:pPr>
-                      <a:r>
-                        <a:rPr lang="en-US" sz="1400" dirty="0">
-                          <a:solidFill>
-                            <a:srgbClr val="F4D9DC"/>
-                          </a:solidFill>
-                          <a:latin typeface="General Sans Semibold" pitchFamily="34" charset="0"/>
-                          <a:ea typeface="General Sans Semibold" pitchFamily="34" charset="-122"/>
-                          <a:cs typeface="General Sans Semibold" pitchFamily="34" charset="-120"/>
-                        </a:rPr>
-                        <a:t>Duur</a:t>
-                      </a:r>
-                      <a:endParaRPr lang="en-US" sz="1400" dirty="0">
-                        <a:latin typeface="General Sans Semibold" charset="0"/>
-                        <a:ea typeface="General Sans Semibold" charset="0"/>
-                        <a:cs typeface="General Sans Semibold" charset="0"/>
-                      </a:endParaRPr>
-                    </a:p>
-                  </a:txBody>
-                  <a:tcPr marL="101600" marR="101600" marT="63500" marB="63500" anchor="ctr">
-                    <a:lnL w="9525" cap="flat" cmpd="sng" algn="ctr">
-                      <a:solidFill>
-                        <a:srgbClr val="F4D9DC"/>
-                      </a:solidFill>
-                      <a:prstDash val="solid"/>
-                      <a:round/>
-                      <a:headEnd type="none" w="med" len="med"/>
-                      <a:tailEnd type="none" w="med" len="med"/>
-                    </a:lnL>
-                    <a:lnR w="9525" cap="flat" cmpd="sng" algn="ctr">
-                      <a:solidFill>
-                        <a:srgbClr val="F4D9DC"/>
-                      </a:solidFill>
-                      <a:prstDash val="solid"/>
-                      <a:round/>
-                      <a:headEnd type="none" w="med" len="med"/>
-                      <a:tailEnd type="none" w="med" len="med"/>
-                    </a:lnR>
-                    <a:lnT w="9525" cap="flat" cmpd="sng" algn="ctr">
-                      <a:solidFill>
-                        <a:srgbClr val="F4D9DC"/>
-                      </a:solidFill>
-                      <a:prstDash val="solid"/>
-                      <a:round/>
-                      <a:headEnd type="none" w="med" len="med"/>
-                      <a:tailEnd type="none" w="med" len="med"/>
-                    </a:lnT>
-                    <a:lnB w="9525" cap="flat" cmpd="sng" algn="ctr">
-                      <a:solidFill>
-                        <a:srgbClr val="F4D9DC"/>
-                      </a:solidFill>
-                      <a:prstDash val="solid"/>
-                      <a:round/>
-                      <a:headEnd type="none" w="med" len="med"/>
-                      <a:tailEnd type="none" w="med" len="med"/>
-                    </a:lnB>
-                    <a:solidFill>
-                      <a:srgbClr val="3D68EC"/>
-                    </a:solidFill>
-                  </a:tcPr>
-                </a:tc>
-              </a:tr>
-              <a:tr h="0">
-                <a:tc>
-                  <a:txBody>
-                    <a:bodyPr/>
-                    <a:lstStyle/>
-                    <a:p>
-                      <a:pPr indent="0" marL="0">
-                        <a:buNone/>
-                      </a:pPr>
-                      <a:r>
-                        <a:rPr lang="en-US" sz="1400" dirty="0">
-                          <a:solidFill>
-                            <a:srgbClr val="000000"/>
-                          </a:solidFill>
-                          <a:latin typeface="General Sans" pitchFamily="34" charset="0"/>
-                          <a:ea typeface="General Sans" pitchFamily="34" charset="-122"/>
-                          <a:cs typeface="General Sans" pitchFamily="34" charset="-120"/>
-                        </a:rPr>
-                        <a:t>0:00</a:t>
-                      </a:r>
-                      <a:endParaRPr lang="en-US" sz="1400" dirty="0">
-                        <a:latin typeface="General Sans" charset="0"/>
-                        <a:ea typeface="General Sans" charset="0"/>
-                        <a:cs typeface="General Sans" charset="0"/>
-                      </a:endParaRPr>
-                    </a:p>
-                  </a:txBody>
-                  <a:tcPr marL="101600" marR="101600" marT="63500" marB="63500" anchor="ctr">
-                    <a:lnL w="9525" cap="flat" cmpd="sng" algn="ctr">
-                      <a:solidFill>
-                        <a:srgbClr val="F4D9DC"/>
-                      </a:solidFill>
-                      <a:prstDash val="solid"/>
-                      <a:round/>
-                      <a:headEnd type="none" w="med" len="med"/>
-                      <a:tailEnd type="none" w="med" len="med"/>
-                    </a:lnL>
-                    <a:lnR w="9525" cap="flat" cmpd="sng" algn="ctr">
-                      <a:solidFill>
-                        <a:srgbClr val="F4D9DC"/>
-                      </a:solidFill>
-                      <a:prstDash val="solid"/>
-                      <a:round/>
-                      <a:headEnd type="none" w="med" len="med"/>
-                      <a:tailEnd type="none" w="med" len="med"/>
-                    </a:lnR>
-                    <a:lnT w="9525" cap="flat" cmpd="sng" algn="ctr">
-                      <a:solidFill>
-                        <a:srgbClr val="F4D9DC"/>
-                      </a:solidFill>
-                      <a:prstDash val="solid"/>
-                      <a:round/>
-                      <a:headEnd type="none" w="med" len="med"/>
-                      <a:tailEnd type="none" w="med" len="med"/>
-                    </a:lnT>
-                    <a:lnB w="9525" cap="flat" cmpd="sng" algn="ctr">
-                      <a:solidFill>
-                        <a:srgbClr val="F4D9DC"/>
-                      </a:solidFill>
-                      <a:prstDash val="solid"/>
-                      <a:round/>
-                      <a:headEnd type="none" w="med" len="med"/>
-                      <a:tailEnd type="none" w="med" len="med"/>
-                    </a:lnB>
-                    <a:solidFill>
-                      <a:srgbClr val="FAEAEA"/>
-                    </a:solidFill>
-                  </a:tcPr>
-                </a:tc>
-                <a:tc>
-                  <a:txBody>
-                    <a:bodyPr/>
-                    <a:lstStyle/>
-                    <a:p>
-                      <a:pPr indent="0" marL="0">
-                        <a:buNone/>
-                      </a:pPr>
-                      <a:r>
-                        <a:rPr lang="en-US" sz="1400" dirty="0">
-                          <a:solidFill>
-                            <a:srgbClr val="000000"/>
-                          </a:solidFill>
-                          <a:latin typeface="General Sans" pitchFamily="34" charset="0"/>
-                          <a:ea typeface="General Sans" pitchFamily="34" charset="-122"/>
-                          <a:cs typeface="General Sans" pitchFamily="34" charset="-120"/>
-                        </a:rPr>
-                        <a:t>Intro, synthetische data, casus</a:t>
-                      </a:r>
-                      <a:endParaRPr lang="en-US" sz="1400" dirty="0">
-                        <a:latin typeface="General Sans" charset="0"/>
-                        <a:ea typeface="General Sans" charset="0"/>
-                        <a:cs typeface="General Sans" charset="0"/>
-                      </a:endParaRPr>
-                    </a:p>
-                  </a:txBody>
-                  <a:tcPr marL="101600" marR="101600" marT="63500" marB="63500" anchor="ctr">
-                    <a:lnL w="9525" cap="flat" cmpd="sng" algn="ctr">
-                      <a:solidFill>
-                        <a:srgbClr val="F4D9DC"/>
-                      </a:solidFill>
-                      <a:prstDash val="solid"/>
-                      <a:round/>
-                      <a:headEnd type="none" w="med" len="med"/>
-                      <a:tailEnd type="none" w="med" len="med"/>
-                    </a:lnL>
-                    <a:lnR w="9525" cap="flat" cmpd="sng" algn="ctr">
-                      <a:solidFill>
-                        <a:srgbClr val="F4D9DC"/>
-                      </a:solidFill>
-                      <a:prstDash val="solid"/>
-                      <a:round/>
-                      <a:headEnd type="none" w="med" len="med"/>
-                      <a:tailEnd type="none" w="med" len="med"/>
-                    </a:lnR>
-                    <a:lnT w="9525" cap="flat" cmpd="sng" algn="ctr">
-                      <a:solidFill>
-                        <a:srgbClr val="F4D9DC"/>
-                      </a:solidFill>
-                      <a:prstDash val="solid"/>
-                      <a:round/>
-                      <a:headEnd type="none" w="med" len="med"/>
-                      <a:tailEnd type="none" w="med" len="med"/>
-                    </a:lnT>
-                    <a:lnB w="9525" cap="flat" cmpd="sng" algn="ctr">
-                      <a:solidFill>
-                        <a:srgbClr val="F4D9DC"/>
-                      </a:solidFill>
-                      <a:prstDash val="solid"/>
-                      <a:round/>
-                      <a:headEnd type="none" w="med" len="med"/>
-                      <a:tailEnd type="none" w="med" len="med"/>
-                    </a:lnB>
-                    <a:solidFill>
-                      <a:srgbClr val="FAEAEA"/>
-                    </a:solidFill>
-                  </a:tcPr>
-                </a:tc>
-                <a:tc>
-                  <a:txBody>
-                    <a:bodyPr/>
-                    <a:lstStyle/>
-                    <a:p>
-                      <a:pPr indent="0" marL="0">
-                        <a:buNone/>
-                      </a:pPr>
-                      <a:r>
-                        <a:rPr lang="en-US" sz="1400" dirty="0">
-                          <a:solidFill>
-                            <a:srgbClr val="000000"/>
-                          </a:solidFill>
-                          <a:latin typeface="General Sans" pitchFamily="34" charset="0"/>
-                          <a:ea typeface="General Sans" pitchFamily="34" charset="-122"/>
-                          <a:cs typeface="General Sans" pitchFamily="34" charset="-120"/>
-                        </a:rPr>
-                        <a:t>17 min</a:t>
-                      </a:r>
-                      <a:endParaRPr lang="en-US" sz="1400" dirty="0">
-                        <a:latin typeface="General Sans" charset="0"/>
-                        <a:ea typeface="General Sans" charset="0"/>
-                        <a:cs typeface="General Sans" charset="0"/>
-                      </a:endParaRPr>
-                    </a:p>
-                  </a:txBody>
-                  <a:tcPr marL="101600" marR="101600" marT="63500" marB="63500" anchor="ctr">
-                    <a:lnL w="9525" cap="flat" cmpd="sng" algn="ctr">
-                      <a:solidFill>
-                        <a:srgbClr val="F4D9DC"/>
-                      </a:solidFill>
-                      <a:prstDash val="solid"/>
-                      <a:round/>
-                      <a:headEnd type="none" w="med" len="med"/>
-                      <a:tailEnd type="none" w="med" len="med"/>
-                    </a:lnL>
-                    <a:lnR w="9525" cap="flat" cmpd="sng" algn="ctr">
-                      <a:solidFill>
-                        <a:srgbClr val="F4D9DC"/>
-                      </a:solidFill>
-                      <a:prstDash val="solid"/>
-                      <a:round/>
-                      <a:headEnd type="none" w="med" len="med"/>
-                      <a:tailEnd type="none" w="med" len="med"/>
-                    </a:lnR>
-                    <a:lnT w="9525" cap="flat" cmpd="sng" algn="ctr">
-                      <a:solidFill>
-                        <a:srgbClr val="F4D9DC"/>
-                      </a:solidFill>
-                      <a:prstDash val="solid"/>
-                      <a:round/>
-                      <a:headEnd type="none" w="med" len="med"/>
-                      <a:tailEnd type="none" w="med" len="med"/>
-                    </a:lnT>
-                    <a:lnB w="9525" cap="flat" cmpd="sng" algn="ctr">
-                      <a:solidFill>
-                        <a:srgbClr val="F4D9DC"/>
-                      </a:solidFill>
-                      <a:prstDash val="solid"/>
-                      <a:round/>
-                      <a:headEnd type="none" w="med" len="med"/>
-                      <a:tailEnd type="none" w="med" len="med"/>
-                    </a:lnB>
-                    <a:solidFill>
-                      <a:srgbClr val="FAEAEA"/>
-                    </a:solidFill>
-                  </a:tcPr>
-                </a:tc>
-              </a:tr>
-              <a:tr h="0">
-                <a:tc>
-                  <a:txBody>
-                    <a:bodyPr/>
-                    <a:lstStyle/>
-                    <a:p>
-                      <a:pPr indent="0" marL="0">
-                        <a:buNone/>
-                      </a:pPr>
-                      <a:r>
-                        <a:rPr lang="en-US" sz="1400" dirty="0">
-                          <a:solidFill>
-                            <a:srgbClr val="000000"/>
-                          </a:solidFill>
-                          <a:latin typeface="General Sans" pitchFamily="34" charset="0"/>
-                          <a:ea typeface="General Sans" pitchFamily="34" charset="-122"/>
-                          <a:cs typeface="General Sans" pitchFamily="34" charset="-120"/>
-                        </a:rPr>
-                        <a:t>0:17</a:t>
-                      </a:r>
-                      <a:endParaRPr lang="en-US" sz="1400" dirty="0">
-                        <a:latin typeface="General Sans" charset="0"/>
-                        <a:ea typeface="General Sans" charset="0"/>
-                        <a:cs typeface="General Sans" charset="0"/>
-                      </a:endParaRPr>
-                    </a:p>
-                  </a:txBody>
-                  <a:tcPr marL="101600" marR="101600" marT="63500" marB="63500" anchor="ctr">
-                    <a:lnL w="9525" cap="flat" cmpd="sng" algn="ctr">
-                      <a:solidFill>
-                        <a:srgbClr val="F4D9DC"/>
-                      </a:solidFill>
-                      <a:prstDash val="solid"/>
-                      <a:round/>
-                      <a:headEnd type="none" w="med" len="med"/>
-                      <a:tailEnd type="none" w="med" len="med"/>
-                    </a:lnL>
-                    <a:lnR w="9525" cap="flat" cmpd="sng" algn="ctr">
-                      <a:solidFill>
-                        <a:srgbClr val="F4D9DC"/>
-                      </a:solidFill>
-                      <a:prstDash val="solid"/>
-                      <a:round/>
-                      <a:headEnd type="none" w="med" len="med"/>
-                      <a:tailEnd type="none" w="med" len="med"/>
-                    </a:lnR>
-                    <a:lnT w="9525" cap="flat" cmpd="sng" algn="ctr">
-                      <a:solidFill>
-                        <a:srgbClr val="F4D9DC"/>
-                      </a:solidFill>
-                      <a:prstDash val="solid"/>
-                      <a:round/>
-                      <a:headEnd type="none" w="med" len="med"/>
-                      <a:tailEnd type="none" w="med" len="med"/>
-                    </a:lnT>
-                    <a:lnB w="9525" cap="flat" cmpd="sng" algn="ctr">
-                      <a:solidFill>
-                        <a:srgbClr val="F4D9DC"/>
-                      </a:solidFill>
-                      <a:prstDash val="solid"/>
-                      <a:round/>
-                      <a:headEnd type="none" w="med" len="med"/>
-                      <a:tailEnd type="none" w="med" len="med"/>
-                    </a:lnB>
-                    <a:solidFill>
-                      <a:srgbClr val="FFFFFF"/>
-                    </a:solidFill>
-                  </a:tcPr>
-                </a:tc>
-                <a:tc>
-                  <a:txBody>
-                    <a:bodyPr/>
-                    <a:lstStyle/>
-                    <a:p>
-                      <a:pPr indent="0" marL="0">
-                        <a:buNone/>
-                      </a:pPr>
-                      <a:r>
-                        <a:rPr lang="en-US" sz="1400" dirty="0">
-                          <a:solidFill>
-                            <a:srgbClr val="000000"/>
-                          </a:solidFill>
-                          <a:latin typeface="General Sans" pitchFamily="34" charset="0"/>
-                          <a:ea typeface="General Sans" pitchFamily="34" charset="-122"/>
-                          <a:cs typeface="General Sans" pitchFamily="34" charset="-120"/>
-                        </a:rPr>
-                        <a:t>Skills, prompts en de devcontainer</a:t>
-                      </a:r>
-                      <a:endParaRPr lang="en-US" sz="1400" dirty="0">
-                        <a:latin typeface="General Sans" charset="0"/>
-                        <a:ea typeface="General Sans" charset="0"/>
-                        <a:cs typeface="General Sans" charset="0"/>
-                      </a:endParaRPr>
-                    </a:p>
-                  </a:txBody>
-                  <a:tcPr marL="101600" marR="101600" marT="63500" marB="63500" anchor="ctr">
-                    <a:lnL w="9525" cap="flat" cmpd="sng" algn="ctr">
-                      <a:solidFill>
-                        <a:srgbClr val="F4D9DC"/>
-                      </a:solidFill>
-                      <a:prstDash val="solid"/>
-                      <a:round/>
-                      <a:headEnd type="none" w="med" len="med"/>
-                      <a:tailEnd type="none" w="med" len="med"/>
-                    </a:lnL>
-                    <a:lnR w="9525" cap="flat" cmpd="sng" algn="ctr">
-                      <a:solidFill>
-                        <a:srgbClr val="F4D9DC"/>
-                      </a:solidFill>
-                      <a:prstDash val="solid"/>
-                      <a:round/>
-                      <a:headEnd type="none" w="med" len="med"/>
-                      <a:tailEnd type="none" w="med" len="med"/>
-                    </a:lnR>
-                    <a:lnT w="9525" cap="flat" cmpd="sng" algn="ctr">
-                      <a:solidFill>
-                        <a:srgbClr val="F4D9DC"/>
-                      </a:solidFill>
-                      <a:prstDash val="solid"/>
-                      <a:round/>
-                      <a:headEnd type="none" w="med" len="med"/>
-                      <a:tailEnd type="none" w="med" len="med"/>
-                    </a:lnT>
-                    <a:lnB w="9525" cap="flat" cmpd="sng" algn="ctr">
-                      <a:solidFill>
-                        <a:srgbClr val="F4D9DC"/>
-                      </a:solidFill>
-                      <a:prstDash val="solid"/>
-                      <a:round/>
-                      <a:headEnd type="none" w="med" len="med"/>
-                      <a:tailEnd type="none" w="med" len="med"/>
-                    </a:lnB>
-                    <a:solidFill>
-                      <a:srgbClr val="FFFFFF"/>
-                    </a:solidFill>
-                  </a:tcPr>
-                </a:tc>
-                <a:tc>
-                  <a:txBody>
-                    <a:bodyPr/>
-                    <a:lstStyle/>
-                    <a:p>
-                      <a:pPr indent="0" marL="0">
-                        <a:buNone/>
-                      </a:pPr>
-                      <a:r>
-                        <a:rPr lang="en-US" sz="1400" dirty="0">
-                          <a:solidFill>
-                            <a:srgbClr val="000000"/>
-                          </a:solidFill>
-                          <a:latin typeface="General Sans" pitchFamily="34" charset="0"/>
-                          <a:ea typeface="General Sans" pitchFamily="34" charset="-122"/>
-                          <a:cs typeface="General Sans" pitchFamily="34" charset="-120"/>
-                        </a:rPr>
-                        <a:t>13 min</a:t>
-                      </a:r>
-                      <a:endParaRPr lang="en-US" sz="1400" dirty="0">
-                        <a:latin typeface="General Sans" charset="0"/>
-                        <a:ea typeface="General Sans" charset="0"/>
-                        <a:cs typeface="General Sans" charset="0"/>
-                      </a:endParaRPr>
-                    </a:p>
-                  </a:txBody>
-                  <a:tcPr marL="101600" marR="101600" marT="63500" marB="63500" anchor="ctr">
-                    <a:lnL w="9525" cap="flat" cmpd="sng" algn="ctr">
-                      <a:solidFill>
-                        <a:srgbClr val="F4D9DC"/>
-                      </a:solidFill>
-                      <a:prstDash val="solid"/>
-                      <a:round/>
-                      <a:headEnd type="none" w="med" len="med"/>
-                      <a:tailEnd type="none" w="med" len="med"/>
-                    </a:lnL>
-                    <a:lnR w="9525" cap="flat" cmpd="sng" algn="ctr">
-                      <a:solidFill>
-                        <a:srgbClr val="F4D9DC"/>
-                      </a:solidFill>
-                      <a:prstDash val="solid"/>
-                      <a:round/>
-                      <a:headEnd type="none" w="med" len="med"/>
-                      <a:tailEnd type="none" w="med" len="med"/>
-                    </a:lnR>
-                    <a:lnT w="9525" cap="flat" cmpd="sng" algn="ctr">
-                      <a:solidFill>
-                        <a:srgbClr val="F4D9DC"/>
-                      </a:solidFill>
-                      <a:prstDash val="solid"/>
-                      <a:round/>
-                      <a:headEnd type="none" w="med" len="med"/>
-                      <a:tailEnd type="none" w="med" len="med"/>
-                    </a:lnT>
-                    <a:lnB w="9525" cap="flat" cmpd="sng" algn="ctr">
-                      <a:solidFill>
-                        <a:srgbClr val="F4D9DC"/>
-                      </a:solidFill>
-                      <a:prstDash val="solid"/>
-                      <a:round/>
-                      <a:headEnd type="none" w="med" len="med"/>
-                      <a:tailEnd type="none" w="med" len="med"/>
-                    </a:lnB>
-                    <a:solidFill>
-                      <a:srgbClr val="FFFFFF"/>
-                    </a:solidFill>
-                  </a:tcPr>
-                </a:tc>
-              </a:tr>
-              <a:tr h="0">
-                <a:tc>
-                  <a:txBody>
-                    <a:bodyPr/>
-                    <a:lstStyle/>
-                    <a:p>
-                      <a:pPr indent="0" marL="0">
-                        <a:buNone/>
-                      </a:pPr>
-                      <a:r>
-                        <a:rPr lang="en-US" sz="1400" dirty="0">
-                          <a:solidFill>
-                            <a:srgbClr val="000000"/>
-                          </a:solidFill>
-                          <a:latin typeface="General Sans" pitchFamily="34" charset="0"/>
-                          <a:ea typeface="General Sans" pitchFamily="34" charset="-122"/>
-                          <a:cs typeface="General Sans" pitchFamily="34" charset="-120"/>
-                        </a:rPr>
-                        <a:t>0:30</a:t>
-                      </a:r>
-                      <a:endParaRPr lang="en-US" sz="1400" dirty="0">
-                        <a:latin typeface="General Sans" charset="0"/>
-                        <a:ea typeface="General Sans" charset="0"/>
-                        <a:cs typeface="General Sans" charset="0"/>
-                      </a:endParaRPr>
-                    </a:p>
-                  </a:txBody>
-                  <a:tcPr marL="101600" marR="101600" marT="63500" marB="63500" anchor="ctr">
-                    <a:lnL w="9525" cap="flat" cmpd="sng" algn="ctr">
-                      <a:solidFill>
-                        <a:srgbClr val="F4D9DC"/>
-                      </a:solidFill>
-                      <a:prstDash val="solid"/>
-                      <a:round/>
-                      <a:headEnd type="none" w="med" len="med"/>
-                      <a:tailEnd type="none" w="med" len="med"/>
-                    </a:lnL>
-                    <a:lnR w="9525" cap="flat" cmpd="sng" algn="ctr">
-                      <a:solidFill>
-                        <a:srgbClr val="F4D9DC"/>
-                      </a:solidFill>
-                      <a:prstDash val="solid"/>
-                      <a:round/>
-                      <a:headEnd type="none" w="med" len="med"/>
-                      <a:tailEnd type="none" w="med" len="med"/>
-                    </a:lnR>
-                    <a:lnT w="9525" cap="flat" cmpd="sng" algn="ctr">
-                      <a:solidFill>
-                        <a:srgbClr val="F4D9DC"/>
-                      </a:solidFill>
-                      <a:prstDash val="solid"/>
-                      <a:round/>
-                      <a:headEnd type="none" w="med" len="med"/>
-                      <a:tailEnd type="none" w="med" len="med"/>
-                    </a:lnT>
-                    <a:lnB w="9525" cap="flat" cmpd="sng" algn="ctr">
-                      <a:solidFill>
-                        <a:srgbClr val="F4D9DC"/>
-                      </a:solidFill>
-                      <a:prstDash val="solid"/>
-                      <a:round/>
-                      <a:headEnd type="none" w="med" len="med"/>
-                      <a:tailEnd type="none" w="med" len="med"/>
-                    </a:lnB>
-                    <a:solidFill>
-                      <a:srgbClr val="FAEAEA"/>
-                    </a:solidFill>
-                  </a:tcPr>
-                </a:tc>
-                <a:tc>
-                  <a:txBody>
-                    <a:bodyPr/>
-                    <a:lstStyle/>
-                    <a:p>
-                      <a:pPr indent="0" marL="0">
-                        <a:buNone/>
-                      </a:pPr>
-                      <a:r>
-                        <a:rPr lang="en-US" sz="1400" dirty="0">
-                          <a:solidFill>
-                            <a:srgbClr val="000000"/>
-                          </a:solidFill>
-                          <a:latin typeface="General Sans" pitchFamily="34" charset="0"/>
-                          <a:ea typeface="General Sans" pitchFamily="34" charset="-122"/>
-                          <a:cs typeface="General Sans" pitchFamily="34" charset="-120"/>
-                        </a:rPr>
-                        <a:t>Ronde 1: data verkennen</a:t>
-                      </a:r>
-                      <a:endParaRPr lang="en-US" sz="1400" dirty="0">
-                        <a:latin typeface="General Sans" charset="0"/>
-                        <a:ea typeface="General Sans" charset="0"/>
-                        <a:cs typeface="General Sans" charset="0"/>
-                      </a:endParaRPr>
-                    </a:p>
-                  </a:txBody>
-                  <a:tcPr marL="101600" marR="101600" marT="63500" marB="63500" anchor="ctr">
-                    <a:lnL w="9525" cap="flat" cmpd="sng" algn="ctr">
-                      <a:solidFill>
-                        <a:srgbClr val="F4D9DC"/>
-                      </a:solidFill>
-                      <a:prstDash val="solid"/>
-                      <a:round/>
-                      <a:headEnd type="none" w="med" len="med"/>
-                      <a:tailEnd type="none" w="med" len="med"/>
-                    </a:lnL>
-                    <a:lnR w="9525" cap="flat" cmpd="sng" algn="ctr">
-                      <a:solidFill>
-                        <a:srgbClr val="F4D9DC"/>
-                      </a:solidFill>
-                      <a:prstDash val="solid"/>
-                      <a:round/>
-                      <a:headEnd type="none" w="med" len="med"/>
-                      <a:tailEnd type="none" w="med" len="med"/>
-                    </a:lnR>
-                    <a:lnT w="9525" cap="flat" cmpd="sng" algn="ctr">
-                      <a:solidFill>
-                        <a:srgbClr val="F4D9DC"/>
-                      </a:solidFill>
-                      <a:prstDash val="solid"/>
-                      <a:round/>
-                      <a:headEnd type="none" w="med" len="med"/>
-                      <a:tailEnd type="none" w="med" len="med"/>
-                    </a:lnT>
-                    <a:lnB w="9525" cap="flat" cmpd="sng" algn="ctr">
-                      <a:solidFill>
-                        <a:srgbClr val="F4D9DC"/>
-                      </a:solidFill>
-                      <a:prstDash val="solid"/>
-                      <a:round/>
-                      <a:headEnd type="none" w="med" len="med"/>
-                      <a:tailEnd type="none" w="med" len="med"/>
-                    </a:lnB>
-                    <a:solidFill>
-                      <a:srgbClr val="FAEAEA"/>
-                    </a:solidFill>
-                  </a:tcPr>
-                </a:tc>
-                <a:tc>
-                  <a:txBody>
-                    <a:bodyPr/>
-                    <a:lstStyle/>
-                    <a:p>
-                      <a:pPr indent="0" marL="0">
-                        <a:buNone/>
-                      </a:pPr>
-                      <a:r>
-                        <a:rPr lang="en-US" sz="1400" dirty="0">
-                          <a:solidFill>
-                            <a:srgbClr val="000000"/>
-                          </a:solidFill>
-                          <a:latin typeface="General Sans" pitchFamily="34" charset="0"/>
-                          <a:ea typeface="General Sans" pitchFamily="34" charset="-122"/>
-                          <a:cs typeface="General Sans" pitchFamily="34" charset="-120"/>
-                        </a:rPr>
-                        <a:t>22 min</a:t>
-                      </a:r>
-                      <a:endParaRPr lang="en-US" sz="1400" dirty="0">
-                        <a:latin typeface="General Sans" charset="0"/>
-                        <a:ea typeface="General Sans" charset="0"/>
-                        <a:cs typeface="General Sans" charset="0"/>
-                      </a:endParaRPr>
-                    </a:p>
-                  </a:txBody>
-                  <a:tcPr marL="101600" marR="101600" marT="63500" marB="63500" anchor="ctr">
-                    <a:lnL w="9525" cap="flat" cmpd="sng" algn="ctr">
-                      <a:solidFill>
-                        <a:srgbClr val="F4D9DC"/>
-                      </a:solidFill>
-                      <a:prstDash val="solid"/>
-                      <a:round/>
-                      <a:headEnd type="none" w="med" len="med"/>
-                      <a:tailEnd type="none" w="med" len="med"/>
-                    </a:lnL>
-                    <a:lnR w="9525" cap="flat" cmpd="sng" algn="ctr">
-                      <a:solidFill>
-                        <a:srgbClr val="F4D9DC"/>
-                      </a:solidFill>
-                      <a:prstDash val="solid"/>
-                      <a:round/>
-                      <a:headEnd type="none" w="med" len="med"/>
-                      <a:tailEnd type="none" w="med" len="med"/>
-                    </a:lnR>
-                    <a:lnT w="9525" cap="flat" cmpd="sng" algn="ctr">
-                      <a:solidFill>
-                        <a:srgbClr val="F4D9DC"/>
-                      </a:solidFill>
-                      <a:prstDash val="solid"/>
-                      <a:round/>
-                      <a:headEnd type="none" w="med" len="med"/>
-                      <a:tailEnd type="none" w="med" len="med"/>
-                    </a:lnT>
-                    <a:lnB w="9525" cap="flat" cmpd="sng" algn="ctr">
-                      <a:solidFill>
-                        <a:srgbClr val="F4D9DC"/>
-                      </a:solidFill>
-                      <a:prstDash val="solid"/>
-                      <a:round/>
-                      <a:headEnd type="none" w="med" len="med"/>
-                      <a:tailEnd type="none" w="med" len="med"/>
-                    </a:lnB>
-                    <a:solidFill>
-                      <a:srgbClr val="FAEAEA"/>
-                    </a:solidFill>
-                  </a:tcPr>
-                </a:tc>
-              </a:tr>
-              <a:tr h="0">
-                <a:tc>
-                  <a:txBody>
-                    <a:bodyPr/>
-                    <a:lstStyle/>
-                    <a:p>
-                      <a:pPr indent="0" marL="0">
-                        <a:buNone/>
-                      </a:pPr>
-                      <a:r>
-                        <a:rPr lang="en-US" sz="1400" dirty="0">
-                          <a:solidFill>
-                            <a:srgbClr val="000000"/>
-                          </a:solidFill>
-                          <a:latin typeface="General Sans" pitchFamily="34" charset="0"/>
-                          <a:ea typeface="General Sans" pitchFamily="34" charset="-122"/>
-                          <a:cs typeface="General Sans" pitchFamily="34" charset="-120"/>
-                        </a:rPr>
-                        <a:t>0:52</a:t>
-                      </a:r>
-                      <a:endParaRPr lang="en-US" sz="1400" dirty="0">
-                        <a:latin typeface="General Sans" charset="0"/>
-                        <a:ea typeface="General Sans" charset="0"/>
-                        <a:cs typeface="General Sans" charset="0"/>
-                      </a:endParaRPr>
-                    </a:p>
-                  </a:txBody>
-                  <a:tcPr marL="101600" marR="101600" marT="63500" marB="63500" anchor="ctr">
-                    <a:lnL w="9525" cap="flat" cmpd="sng" algn="ctr">
-                      <a:solidFill>
-                        <a:srgbClr val="F4D9DC"/>
-                      </a:solidFill>
-                      <a:prstDash val="solid"/>
-                      <a:round/>
-                      <a:headEnd type="none" w="med" len="med"/>
-                      <a:tailEnd type="none" w="med" len="med"/>
-                    </a:lnL>
-                    <a:lnR w="9525" cap="flat" cmpd="sng" algn="ctr">
-                      <a:solidFill>
-                        <a:srgbClr val="F4D9DC"/>
-                      </a:solidFill>
-                      <a:prstDash val="solid"/>
-                      <a:round/>
-                      <a:headEnd type="none" w="med" len="med"/>
-                      <a:tailEnd type="none" w="med" len="med"/>
-                    </a:lnR>
-                    <a:lnT w="9525" cap="flat" cmpd="sng" algn="ctr">
-                      <a:solidFill>
-                        <a:srgbClr val="F4D9DC"/>
-                      </a:solidFill>
-                      <a:prstDash val="solid"/>
-                      <a:round/>
-                      <a:headEnd type="none" w="med" len="med"/>
-                      <a:tailEnd type="none" w="med" len="med"/>
-                    </a:lnT>
-                    <a:lnB w="9525" cap="flat" cmpd="sng" algn="ctr">
-                      <a:solidFill>
-                        <a:srgbClr val="F4D9DC"/>
-                      </a:solidFill>
-                      <a:prstDash val="solid"/>
-                      <a:round/>
-                      <a:headEnd type="none" w="med" len="med"/>
-                      <a:tailEnd type="none" w="med" len="med"/>
-                    </a:lnB>
-                    <a:solidFill>
-                      <a:srgbClr val="FFFFFF"/>
-                    </a:solidFill>
-                  </a:tcPr>
-                </a:tc>
-                <a:tc>
-                  <a:txBody>
-                    <a:bodyPr/>
-                    <a:lstStyle/>
-                    <a:p>
-                      <a:pPr indent="0" marL="0">
-                        <a:buNone/>
-                      </a:pPr>
-                      <a:r>
-                        <a:rPr lang="en-US" sz="1400" dirty="0">
-                          <a:solidFill>
-                            <a:srgbClr val="000000"/>
-                          </a:solidFill>
-                          <a:latin typeface="General Sans" pitchFamily="34" charset="0"/>
-                          <a:ea typeface="General Sans" pitchFamily="34" charset="-122"/>
-                          <a:cs typeface="General Sans" pitchFamily="34" charset="-120"/>
-                        </a:rPr>
-                        <a:t>Spiegelmoment 1</a:t>
-                      </a:r>
-                      <a:endParaRPr lang="en-US" sz="1400" dirty="0">
-                        <a:latin typeface="General Sans" charset="0"/>
-                        <a:ea typeface="General Sans" charset="0"/>
-                        <a:cs typeface="General Sans" charset="0"/>
-                      </a:endParaRPr>
-                    </a:p>
-                  </a:txBody>
-                  <a:tcPr marL="101600" marR="101600" marT="63500" marB="63500" anchor="ctr">
-                    <a:lnL w="9525" cap="flat" cmpd="sng" algn="ctr">
-                      <a:solidFill>
-                        <a:srgbClr val="F4D9DC"/>
-                      </a:solidFill>
-                      <a:prstDash val="solid"/>
-                      <a:round/>
-                      <a:headEnd type="none" w="med" len="med"/>
-                      <a:tailEnd type="none" w="med" len="med"/>
-                    </a:lnL>
-                    <a:lnR w="9525" cap="flat" cmpd="sng" algn="ctr">
-                      <a:solidFill>
-                        <a:srgbClr val="F4D9DC"/>
-                      </a:solidFill>
-                      <a:prstDash val="solid"/>
-                      <a:round/>
-                      <a:headEnd type="none" w="med" len="med"/>
-                      <a:tailEnd type="none" w="med" len="med"/>
-                    </a:lnR>
-                    <a:lnT w="9525" cap="flat" cmpd="sng" algn="ctr">
-                      <a:solidFill>
-                        <a:srgbClr val="F4D9DC"/>
-                      </a:solidFill>
-                      <a:prstDash val="solid"/>
-                      <a:round/>
-                      <a:headEnd type="none" w="med" len="med"/>
-                      <a:tailEnd type="none" w="med" len="med"/>
-                    </a:lnT>
-                    <a:lnB w="9525" cap="flat" cmpd="sng" algn="ctr">
-                      <a:solidFill>
-                        <a:srgbClr val="F4D9DC"/>
-                      </a:solidFill>
-                      <a:prstDash val="solid"/>
-                      <a:round/>
-                      <a:headEnd type="none" w="med" len="med"/>
-                      <a:tailEnd type="none" w="med" len="med"/>
-                    </a:lnB>
-                    <a:solidFill>
-                      <a:srgbClr val="FFFFFF"/>
-                    </a:solidFill>
-                  </a:tcPr>
-                </a:tc>
-                <a:tc>
-                  <a:txBody>
-                    <a:bodyPr/>
-                    <a:lstStyle/>
-                    <a:p>
-                      <a:pPr indent="0" marL="0">
-                        <a:buNone/>
-                      </a:pPr>
-                      <a:r>
-                        <a:rPr lang="en-US" sz="1400" dirty="0">
-                          <a:solidFill>
-                            <a:srgbClr val="000000"/>
-                          </a:solidFill>
-                          <a:latin typeface="General Sans" pitchFamily="34" charset="0"/>
-                          <a:ea typeface="General Sans" pitchFamily="34" charset="-122"/>
-                          <a:cs typeface="General Sans" pitchFamily="34" charset="-120"/>
-                        </a:rPr>
-                        <a:t>15 min</a:t>
-                      </a:r>
-                      <a:endParaRPr lang="en-US" sz="1400" dirty="0">
-                        <a:latin typeface="General Sans" charset="0"/>
-                        <a:ea typeface="General Sans" charset="0"/>
-                        <a:cs typeface="General Sans" charset="0"/>
-                      </a:endParaRPr>
-                    </a:p>
-                  </a:txBody>
-                  <a:tcPr marL="101600" marR="101600" marT="63500" marB="63500" anchor="ctr">
-                    <a:lnL w="9525" cap="flat" cmpd="sng" algn="ctr">
-                      <a:solidFill>
-                        <a:srgbClr val="F4D9DC"/>
-                      </a:solidFill>
-                      <a:prstDash val="solid"/>
-                      <a:round/>
-                      <a:headEnd type="none" w="med" len="med"/>
-                      <a:tailEnd type="none" w="med" len="med"/>
-                    </a:lnL>
-                    <a:lnR w="9525" cap="flat" cmpd="sng" algn="ctr">
-                      <a:solidFill>
-                        <a:srgbClr val="F4D9DC"/>
-                      </a:solidFill>
-                      <a:prstDash val="solid"/>
-                      <a:round/>
-                      <a:headEnd type="none" w="med" len="med"/>
-                      <a:tailEnd type="none" w="med" len="med"/>
-                    </a:lnR>
-                    <a:lnT w="9525" cap="flat" cmpd="sng" algn="ctr">
-                      <a:solidFill>
-                        <a:srgbClr val="F4D9DC"/>
-                      </a:solidFill>
-                      <a:prstDash val="solid"/>
-                      <a:round/>
-                      <a:headEnd type="none" w="med" len="med"/>
-                      <a:tailEnd type="none" w="med" len="med"/>
-                    </a:lnT>
-                    <a:lnB w="9525" cap="flat" cmpd="sng" algn="ctr">
-                      <a:solidFill>
-                        <a:srgbClr val="F4D9DC"/>
-                      </a:solidFill>
-                      <a:prstDash val="solid"/>
-                      <a:round/>
-                      <a:headEnd type="none" w="med" len="med"/>
-                      <a:tailEnd type="none" w="med" len="med"/>
-                    </a:lnB>
-                    <a:solidFill>
-                      <a:srgbClr val="FFFFFF"/>
-                    </a:solidFill>
-                  </a:tcPr>
-                </a:tc>
-              </a:tr>
-              <a:tr h="0">
-                <a:tc>
-                  <a:txBody>
-                    <a:bodyPr/>
-                    <a:lstStyle/>
-                    <a:p>
-                      <a:pPr indent="0" marL="0">
-                        <a:buNone/>
-                      </a:pPr>
-                      <a:r>
-                        <a:rPr lang="en-US" sz="1400" dirty="0">
-                          <a:solidFill>
-                            <a:srgbClr val="000000"/>
-                          </a:solidFill>
-                          <a:latin typeface="General Sans" pitchFamily="34" charset="0"/>
-                          <a:ea typeface="General Sans" pitchFamily="34" charset="-122"/>
-                          <a:cs typeface="General Sans" pitchFamily="34" charset="-120"/>
-                        </a:rPr>
-                        <a:t>1:07</a:t>
-                      </a:r>
-                      <a:endParaRPr lang="en-US" sz="1400" dirty="0">
-                        <a:latin typeface="General Sans" charset="0"/>
-                        <a:ea typeface="General Sans" charset="0"/>
-                        <a:cs typeface="General Sans" charset="0"/>
-                      </a:endParaRPr>
-                    </a:p>
-                  </a:txBody>
-                  <a:tcPr marL="101600" marR="101600" marT="63500" marB="63500" anchor="ctr">
-                    <a:lnL w="9525" cap="flat" cmpd="sng" algn="ctr">
-                      <a:solidFill>
-                        <a:srgbClr val="F4D9DC"/>
-                      </a:solidFill>
-                      <a:prstDash val="solid"/>
-                      <a:round/>
-                      <a:headEnd type="none" w="med" len="med"/>
-                      <a:tailEnd type="none" w="med" len="med"/>
-                    </a:lnL>
-                    <a:lnR w="9525" cap="flat" cmpd="sng" algn="ctr">
-                      <a:solidFill>
-                        <a:srgbClr val="F4D9DC"/>
-                      </a:solidFill>
-                      <a:prstDash val="solid"/>
-                      <a:round/>
-                      <a:headEnd type="none" w="med" len="med"/>
-                      <a:tailEnd type="none" w="med" len="med"/>
-                    </a:lnR>
-                    <a:lnT w="9525" cap="flat" cmpd="sng" algn="ctr">
-                      <a:solidFill>
-                        <a:srgbClr val="F4D9DC"/>
-                      </a:solidFill>
-                      <a:prstDash val="solid"/>
-                      <a:round/>
-                      <a:headEnd type="none" w="med" len="med"/>
-                      <a:tailEnd type="none" w="med" len="med"/>
-                    </a:lnT>
-                    <a:lnB w="9525" cap="flat" cmpd="sng" algn="ctr">
-                      <a:solidFill>
-                        <a:srgbClr val="F4D9DC"/>
-                      </a:solidFill>
-                      <a:prstDash val="solid"/>
-                      <a:round/>
-                      <a:headEnd type="none" w="med" len="med"/>
-                      <a:tailEnd type="none" w="med" len="med"/>
-                    </a:lnB>
-                    <a:solidFill>
-                      <a:srgbClr val="FAEAEA"/>
-                    </a:solidFill>
-                  </a:tcPr>
-                </a:tc>
-                <a:tc>
-                  <a:txBody>
-                    <a:bodyPr/>
-                    <a:lstStyle/>
-                    <a:p>
-                      <a:pPr indent="0" marL="0">
-                        <a:buNone/>
-                      </a:pPr>
-                      <a:r>
-                        <a:rPr lang="en-US" sz="1400" dirty="0">
-                          <a:solidFill>
-                            <a:srgbClr val="000000"/>
-                          </a:solidFill>
-                          <a:latin typeface="General Sans" pitchFamily="34" charset="0"/>
-                          <a:ea typeface="General Sans" pitchFamily="34" charset="-122"/>
-                          <a:cs typeface="General Sans" pitchFamily="34" charset="-120"/>
-                        </a:rPr>
-                        <a:t>Ronde 2: dashboard bouwen</a:t>
-                      </a:r>
-                      <a:endParaRPr lang="en-US" sz="1400" dirty="0">
-                        <a:latin typeface="General Sans" charset="0"/>
-                        <a:ea typeface="General Sans" charset="0"/>
-                        <a:cs typeface="General Sans" charset="0"/>
-                      </a:endParaRPr>
-                    </a:p>
-                  </a:txBody>
-                  <a:tcPr marL="101600" marR="101600" marT="63500" marB="63500" anchor="ctr">
-                    <a:lnL w="9525" cap="flat" cmpd="sng" algn="ctr">
-                      <a:solidFill>
-                        <a:srgbClr val="F4D9DC"/>
-                      </a:solidFill>
-                      <a:prstDash val="solid"/>
-                      <a:round/>
-                      <a:headEnd type="none" w="med" len="med"/>
-                      <a:tailEnd type="none" w="med" len="med"/>
-                    </a:lnL>
-                    <a:lnR w="9525" cap="flat" cmpd="sng" algn="ctr">
-                      <a:solidFill>
-                        <a:srgbClr val="F4D9DC"/>
-                      </a:solidFill>
-                      <a:prstDash val="solid"/>
-                      <a:round/>
-                      <a:headEnd type="none" w="med" len="med"/>
-                      <a:tailEnd type="none" w="med" len="med"/>
-                    </a:lnR>
-                    <a:lnT w="9525" cap="flat" cmpd="sng" algn="ctr">
-                      <a:solidFill>
-                        <a:srgbClr val="F4D9DC"/>
-                      </a:solidFill>
-                      <a:prstDash val="solid"/>
-                      <a:round/>
-                      <a:headEnd type="none" w="med" len="med"/>
-                      <a:tailEnd type="none" w="med" len="med"/>
-                    </a:lnT>
-                    <a:lnB w="9525" cap="flat" cmpd="sng" algn="ctr">
-                      <a:solidFill>
-                        <a:srgbClr val="F4D9DC"/>
-                      </a:solidFill>
-                      <a:prstDash val="solid"/>
-                      <a:round/>
-                      <a:headEnd type="none" w="med" len="med"/>
-                      <a:tailEnd type="none" w="med" len="med"/>
-                    </a:lnB>
-                    <a:solidFill>
-                      <a:srgbClr val="FAEAEA"/>
-                    </a:solidFill>
-                  </a:tcPr>
-                </a:tc>
-                <a:tc>
-                  <a:txBody>
-                    <a:bodyPr/>
-                    <a:lstStyle/>
-                    <a:p>
-                      <a:pPr indent="0" marL="0">
-                        <a:buNone/>
-                      </a:pPr>
-                      <a:r>
-                        <a:rPr lang="en-US" sz="1400" dirty="0">
-                          <a:solidFill>
-                            <a:srgbClr val="000000"/>
-                          </a:solidFill>
-                          <a:latin typeface="General Sans" pitchFamily="34" charset="0"/>
-                          <a:ea typeface="General Sans" pitchFamily="34" charset="-122"/>
-                          <a:cs typeface="General Sans" pitchFamily="34" charset="-120"/>
-                        </a:rPr>
-                        <a:t>22 min</a:t>
-                      </a:r>
-                      <a:endParaRPr lang="en-US" sz="1400" dirty="0">
-                        <a:latin typeface="General Sans" charset="0"/>
-                        <a:ea typeface="General Sans" charset="0"/>
-                        <a:cs typeface="General Sans" charset="0"/>
-                      </a:endParaRPr>
-                    </a:p>
-                  </a:txBody>
-                  <a:tcPr marL="101600" marR="101600" marT="63500" marB="63500" anchor="ctr">
-                    <a:lnL w="9525" cap="flat" cmpd="sng" algn="ctr">
-                      <a:solidFill>
-                        <a:srgbClr val="F4D9DC"/>
-                      </a:solidFill>
-                      <a:prstDash val="solid"/>
-                      <a:round/>
-                      <a:headEnd type="none" w="med" len="med"/>
-                      <a:tailEnd type="none" w="med" len="med"/>
-                    </a:lnL>
-                    <a:lnR w="9525" cap="flat" cmpd="sng" algn="ctr">
-                      <a:solidFill>
-                        <a:srgbClr val="F4D9DC"/>
-                      </a:solidFill>
-                      <a:prstDash val="solid"/>
-                      <a:round/>
-                      <a:headEnd type="none" w="med" len="med"/>
-                      <a:tailEnd type="none" w="med" len="med"/>
-                    </a:lnR>
-                    <a:lnT w="9525" cap="flat" cmpd="sng" algn="ctr">
-                      <a:solidFill>
-                        <a:srgbClr val="F4D9DC"/>
-                      </a:solidFill>
-                      <a:prstDash val="solid"/>
-                      <a:round/>
-                      <a:headEnd type="none" w="med" len="med"/>
-                      <a:tailEnd type="none" w="med" len="med"/>
-                    </a:lnT>
-                    <a:lnB w="9525" cap="flat" cmpd="sng" algn="ctr">
-                      <a:solidFill>
-                        <a:srgbClr val="F4D9DC"/>
-                      </a:solidFill>
-                      <a:prstDash val="solid"/>
-                      <a:round/>
-                      <a:headEnd type="none" w="med" len="med"/>
-                      <a:tailEnd type="none" w="med" len="med"/>
-                    </a:lnB>
-                    <a:solidFill>
-                      <a:srgbClr val="FAEAEA"/>
-                    </a:solidFill>
-                  </a:tcPr>
-                </a:tc>
-              </a:tr>
-              <a:tr h="0">
-                <a:tc>
-                  <a:txBody>
-                    <a:bodyPr/>
-                    <a:lstStyle/>
-                    <a:p>
-                      <a:pPr indent="0" marL="0">
-                        <a:buNone/>
-                      </a:pPr>
-                      <a:r>
-                        <a:rPr lang="en-US" sz="1400" dirty="0">
-                          <a:solidFill>
-                            <a:srgbClr val="000000"/>
-                          </a:solidFill>
-                          <a:latin typeface="General Sans" pitchFamily="34" charset="0"/>
-                          <a:ea typeface="General Sans" pitchFamily="34" charset="-122"/>
-                          <a:cs typeface="General Sans" pitchFamily="34" charset="-120"/>
-                        </a:rPr>
-                        <a:t>1:29</a:t>
-                      </a:r>
-                      <a:endParaRPr lang="en-US" sz="1400" dirty="0">
-                        <a:latin typeface="General Sans" charset="0"/>
-                        <a:ea typeface="General Sans" charset="0"/>
-                        <a:cs typeface="General Sans" charset="0"/>
-                      </a:endParaRPr>
-                    </a:p>
-                  </a:txBody>
-                  <a:tcPr marL="101600" marR="101600" marT="63500" marB="63500" anchor="ctr">
-                    <a:lnL w="9525" cap="flat" cmpd="sng" algn="ctr">
-                      <a:solidFill>
-                        <a:srgbClr val="F4D9DC"/>
-                      </a:solidFill>
-                      <a:prstDash val="solid"/>
-                      <a:round/>
-                      <a:headEnd type="none" w="med" len="med"/>
-                      <a:tailEnd type="none" w="med" len="med"/>
-                    </a:lnL>
-                    <a:lnR w="9525" cap="flat" cmpd="sng" algn="ctr">
-                      <a:solidFill>
-                        <a:srgbClr val="F4D9DC"/>
-                      </a:solidFill>
-                      <a:prstDash val="solid"/>
-                      <a:round/>
-                      <a:headEnd type="none" w="med" len="med"/>
-                      <a:tailEnd type="none" w="med" len="med"/>
-                    </a:lnR>
-                    <a:lnT w="9525" cap="flat" cmpd="sng" algn="ctr">
-                      <a:solidFill>
-                        <a:srgbClr val="F4D9DC"/>
-                      </a:solidFill>
-                      <a:prstDash val="solid"/>
-                      <a:round/>
-                      <a:headEnd type="none" w="med" len="med"/>
-                      <a:tailEnd type="none" w="med" len="med"/>
-                    </a:lnT>
-                    <a:lnB w="9525" cap="flat" cmpd="sng" algn="ctr">
-                      <a:solidFill>
-                        <a:srgbClr val="F4D9DC"/>
-                      </a:solidFill>
-                      <a:prstDash val="solid"/>
-                      <a:round/>
-                      <a:headEnd type="none" w="med" len="med"/>
-                      <a:tailEnd type="none" w="med" len="med"/>
-                    </a:lnB>
-                    <a:solidFill>
-                      <a:srgbClr val="FFFFFF"/>
-                    </a:solidFill>
-                  </a:tcPr>
-                </a:tc>
-                <a:tc>
-                  <a:txBody>
-                    <a:bodyPr/>
-                    <a:lstStyle/>
-                    <a:p>
-                      <a:pPr indent="0" marL="0">
-                        <a:buNone/>
-                      </a:pPr>
-                      <a:r>
-                        <a:rPr lang="en-US" sz="1400" dirty="0">
-                          <a:solidFill>
-                            <a:srgbClr val="000000"/>
-                          </a:solidFill>
-                          <a:latin typeface="General Sans" pitchFamily="34" charset="0"/>
-                          <a:ea typeface="General Sans" pitchFamily="34" charset="-122"/>
-                          <a:cs typeface="General Sans" pitchFamily="34" charset="-120"/>
-                        </a:rPr>
-                        <a:t>Spiegelmoment 2</a:t>
-                      </a:r>
-                      <a:endParaRPr lang="en-US" sz="1400" dirty="0">
-                        <a:latin typeface="General Sans" charset="0"/>
-                        <a:ea typeface="General Sans" charset="0"/>
-                        <a:cs typeface="General Sans" charset="0"/>
-                      </a:endParaRPr>
-                    </a:p>
-                  </a:txBody>
-                  <a:tcPr marL="101600" marR="101600" marT="63500" marB="63500" anchor="ctr">
-                    <a:lnL w="9525" cap="flat" cmpd="sng" algn="ctr">
-                      <a:solidFill>
-                        <a:srgbClr val="F4D9DC"/>
-                      </a:solidFill>
-                      <a:prstDash val="solid"/>
-                      <a:round/>
-                      <a:headEnd type="none" w="med" len="med"/>
-                      <a:tailEnd type="none" w="med" len="med"/>
-                    </a:lnL>
-                    <a:lnR w="9525" cap="flat" cmpd="sng" algn="ctr">
-                      <a:solidFill>
-                        <a:srgbClr val="F4D9DC"/>
-                      </a:solidFill>
-                      <a:prstDash val="solid"/>
-                      <a:round/>
-                      <a:headEnd type="none" w="med" len="med"/>
-                      <a:tailEnd type="none" w="med" len="med"/>
-                    </a:lnR>
-                    <a:lnT w="9525" cap="flat" cmpd="sng" algn="ctr">
-                      <a:solidFill>
-                        <a:srgbClr val="F4D9DC"/>
-                      </a:solidFill>
-                      <a:prstDash val="solid"/>
-                      <a:round/>
-                      <a:headEnd type="none" w="med" len="med"/>
-                      <a:tailEnd type="none" w="med" len="med"/>
-                    </a:lnT>
-                    <a:lnB w="9525" cap="flat" cmpd="sng" algn="ctr">
-                      <a:solidFill>
-                        <a:srgbClr val="F4D9DC"/>
-                      </a:solidFill>
-                      <a:prstDash val="solid"/>
-                      <a:round/>
-                      <a:headEnd type="none" w="med" len="med"/>
-                      <a:tailEnd type="none" w="med" len="med"/>
-                    </a:lnB>
-                    <a:solidFill>
-                      <a:srgbClr val="FFFFFF"/>
-                    </a:solidFill>
-                  </a:tcPr>
-                </a:tc>
-                <a:tc>
-                  <a:txBody>
-                    <a:bodyPr/>
-                    <a:lstStyle/>
-                    <a:p>
-                      <a:pPr indent="0" marL="0">
-                        <a:buNone/>
-                      </a:pPr>
-                      <a:r>
-                        <a:rPr lang="en-US" sz="1400" dirty="0">
-                          <a:solidFill>
-                            <a:srgbClr val="000000"/>
-                          </a:solidFill>
-                          <a:latin typeface="General Sans" pitchFamily="34" charset="0"/>
-                          <a:ea typeface="General Sans" pitchFamily="34" charset="-122"/>
-                          <a:cs typeface="General Sans" pitchFamily="34" charset="-120"/>
-                        </a:rPr>
-                        <a:t>15 min</a:t>
-                      </a:r>
-                      <a:endParaRPr lang="en-US" sz="1400" dirty="0">
-                        <a:latin typeface="General Sans" charset="0"/>
-                        <a:ea typeface="General Sans" charset="0"/>
-                        <a:cs typeface="General Sans" charset="0"/>
-                      </a:endParaRPr>
-                    </a:p>
-                  </a:txBody>
-                  <a:tcPr marL="101600" marR="101600" marT="63500" marB="63500" anchor="ctr">
-                    <a:lnL w="9525" cap="flat" cmpd="sng" algn="ctr">
-                      <a:solidFill>
-                        <a:srgbClr val="F4D9DC"/>
-                      </a:solidFill>
-                      <a:prstDash val="solid"/>
-                      <a:round/>
-                      <a:headEnd type="none" w="med" len="med"/>
-                      <a:tailEnd type="none" w="med" len="med"/>
-                    </a:lnL>
-                    <a:lnR w="9525" cap="flat" cmpd="sng" algn="ctr">
-                      <a:solidFill>
-                        <a:srgbClr val="F4D9DC"/>
-                      </a:solidFill>
-                      <a:prstDash val="solid"/>
-                      <a:round/>
-                      <a:headEnd type="none" w="med" len="med"/>
-                      <a:tailEnd type="none" w="med" len="med"/>
-                    </a:lnR>
-                    <a:lnT w="9525" cap="flat" cmpd="sng" algn="ctr">
-                      <a:solidFill>
-                        <a:srgbClr val="F4D9DC"/>
-                      </a:solidFill>
-                      <a:prstDash val="solid"/>
-                      <a:round/>
-                      <a:headEnd type="none" w="med" len="med"/>
-                      <a:tailEnd type="none" w="med" len="med"/>
-                    </a:lnT>
-                    <a:lnB w="9525" cap="flat" cmpd="sng" algn="ctr">
-                      <a:solidFill>
-                        <a:srgbClr val="F4D9DC"/>
-                      </a:solidFill>
-                      <a:prstDash val="solid"/>
-                      <a:round/>
-                      <a:headEnd type="none" w="med" len="med"/>
-                      <a:tailEnd type="none" w="med" len="med"/>
-                    </a:lnB>
-                    <a:solidFill>
-                      <a:srgbClr val="FFFFFF"/>
-                    </a:solidFill>
-                  </a:tcPr>
-                </a:tc>
-              </a:tr>
-              <a:tr h="0">
-                <a:tc>
-                  <a:txBody>
-                    <a:bodyPr/>
-                    <a:lstStyle/>
-                    <a:p>
-                      <a:pPr indent="0" marL="0">
-                        <a:buNone/>
-                      </a:pPr>
-                      <a:r>
-                        <a:rPr lang="en-US" sz="1400" dirty="0">
-                          <a:solidFill>
-                            <a:srgbClr val="000000"/>
-                          </a:solidFill>
-                          <a:latin typeface="General Sans" pitchFamily="34" charset="0"/>
-                          <a:ea typeface="General Sans" pitchFamily="34" charset="-122"/>
-                          <a:cs typeface="General Sans" pitchFamily="34" charset="-120"/>
-                        </a:rPr>
-                        <a:t>1:44</a:t>
-                      </a:r>
-                      <a:endParaRPr lang="en-US" sz="1400" dirty="0">
-                        <a:latin typeface="General Sans" charset="0"/>
-                        <a:ea typeface="General Sans" charset="0"/>
-                        <a:cs typeface="General Sans" charset="0"/>
-                      </a:endParaRPr>
-                    </a:p>
-                  </a:txBody>
-                  <a:tcPr marL="101600" marR="101600" marT="63500" marB="63500" anchor="ctr">
-                    <a:lnL w="9525" cap="flat" cmpd="sng" algn="ctr">
-                      <a:solidFill>
-                        <a:srgbClr val="F4D9DC"/>
-                      </a:solidFill>
-                      <a:prstDash val="solid"/>
-                      <a:round/>
-                      <a:headEnd type="none" w="med" len="med"/>
-                      <a:tailEnd type="none" w="med" len="med"/>
-                    </a:lnL>
-                    <a:lnR w="9525" cap="flat" cmpd="sng" algn="ctr">
-                      <a:solidFill>
-                        <a:srgbClr val="F4D9DC"/>
-                      </a:solidFill>
-                      <a:prstDash val="solid"/>
-                      <a:round/>
-                      <a:headEnd type="none" w="med" len="med"/>
-                      <a:tailEnd type="none" w="med" len="med"/>
-                    </a:lnR>
-                    <a:lnT w="9525" cap="flat" cmpd="sng" algn="ctr">
-                      <a:solidFill>
-                        <a:srgbClr val="F4D9DC"/>
-                      </a:solidFill>
-                      <a:prstDash val="solid"/>
-                      <a:round/>
-                      <a:headEnd type="none" w="med" len="med"/>
-                      <a:tailEnd type="none" w="med" len="med"/>
-                    </a:lnT>
-                    <a:lnB w="9525" cap="flat" cmpd="sng" algn="ctr">
-                      <a:solidFill>
-                        <a:srgbClr val="F4D9DC"/>
-                      </a:solidFill>
-                      <a:prstDash val="solid"/>
-                      <a:round/>
-                      <a:headEnd type="none" w="med" len="med"/>
-                      <a:tailEnd type="none" w="med" len="med"/>
-                    </a:lnB>
-                    <a:solidFill>
-                      <a:srgbClr val="FAEAEA"/>
-                    </a:solidFill>
-                  </a:tcPr>
-                </a:tc>
-                <a:tc>
-                  <a:txBody>
-                    <a:bodyPr/>
-                    <a:lstStyle/>
-                    <a:p>
-                      <a:pPr indent="0" marL="0">
-                        <a:buNone/>
-                      </a:pPr>
-                      <a:r>
-                        <a:rPr lang="en-US" sz="1400" dirty="0">
-                          <a:solidFill>
-                            <a:srgbClr val="000000"/>
-                          </a:solidFill>
-                          <a:latin typeface="General Sans" pitchFamily="34" charset="0"/>
-                          <a:ea typeface="General Sans" pitchFamily="34" charset="-122"/>
-                          <a:cs typeface="General Sans" pitchFamily="34" charset="-120"/>
-                        </a:rPr>
-                        <a:t>Evaluatie en afsluiting</a:t>
-                      </a:r>
-                      <a:endParaRPr lang="en-US" sz="1400" dirty="0">
-                        <a:latin typeface="General Sans" charset="0"/>
-                        <a:ea typeface="General Sans" charset="0"/>
-                        <a:cs typeface="General Sans" charset="0"/>
-                      </a:endParaRPr>
-                    </a:p>
-                  </a:txBody>
-                  <a:tcPr marL="101600" marR="101600" marT="63500" marB="63500" anchor="ctr">
-                    <a:lnL w="9525" cap="flat" cmpd="sng" algn="ctr">
-                      <a:solidFill>
-                        <a:srgbClr val="F4D9DC"/>
-                      </a:solidFill>
-                      <a:prstDash val="solid"/>
-                      <a:round/>
-                      <a:headEnd type="none" w="med" len="med"/>
-                      <a:tailEnd type="none" w="med" len="med"/>
-                    </a:lnL>
-                    <a:lnR w="9525" cap="flat" cmpd="sng" algn="ctr">
-                      <a:solidFill>
-                        <a:srgbClr val="F4D9DC"/>
-                      </a:solidFill>
-                      <a:prstDash val="solid"/>
-                      <a:round/>
-                      <a:headEnd type="none" w="med" len="med"/>
-                      <a:tailEnd type="none" w="med" len="med"/>
-                    </a:lnR>
-                    <a:lnT w="9525" cap="flat" cmpd="sng" algn="ctr">
-                      <a:solidFill>
-                        <a:srgbClr val="F4D9DC"/>
-                      </a:solidFill>
-                      <a:prstDash val="solid"/>
-                      <a:round/>
-                      <a:headEnd type="none" w="med" len="med"/>
-                      <a:tailEnd type="none" w="med" len="med"/>
-                    </a:lnT>
-                    <a:lnB w="9525" cap="flat" cmpd="sng" algn="ctr">
-                      <a:solidFill>
-                        <a:srgbClr val="F4D9DC"/>
-                      </a:solidFill>
-                      <a:prstDash val="solid"/>
-                      <a:round/>
-                      <a:headEnd type="none" w="med" len="med"/>
-                      <a:tailEnd type="none" w="med" len="med"/>
-                    </a:lnB>
-                    <a:solidFill>
-                      <a:srgbClr val="FAEAEA"/>
-                    </a:solidFill>
-                  </a:tcPr>
-                </a:tc>
-                <a:tc>
-                  <a:txBody>
-                    <a:bodyPr/>
-                    <a:lstStyle/>
-                    <a:p>
-                      <a:pPr indent="0" marL="0">
-                        <a:buNone/>
-                      </a:pPr>
-                      <a:r>
-                        <a:rPr lang="en-US" sz="1400" dirty="0">
-                          <a:solidFill>
-                            <a:srgbClr val="000000"/>
-                          </a:solidFill>
-                          <a:latin typeface="General Sans" pitchFamily="34" charset="0"/>
-                          <a:ea typeface="General Sans" pitchFamily="34" charset="-122"/>
-                          <a:cs typeface="General Sans" pitchFamily="34" charset="-120"/>
-                        </a:rPr>
-                        <a:t>16 min</a:t>
-                      </a:r>
-                      <a:endParaRPr lang="en-US" sz="1400" dirty="0">
-                        <a:latin typeface="General Sans" charset="0"/>
-                        <a:ea typeface="General Sans" charset="0"/>
-                        <a:cs typeface="General Sans" charset="0"/>
-                      </a:endParaRPr>
-                    </a:p>
-                  </a:txBody>
-                  <a:tcPr marL="101600" marR="101600" marT="63500" marB="63500" anchor="ctr">
-                    <a:lnL w="9525" cap="flat" cmpd="sng" algn="ctr">
-                      <a:solidFill>
-                        <a:srgbClr val="F4D9DC"/>
-                      </a:solidFill>
-                      <a:prstDash val="solid"/>
-                      <a:round/>
-                      <a:headEnd type="none" w="med" len="med"/>
-                      <a:tailEnd type="none" w="med" len="med"/>
-                    </a:lnL>
-                    <a:lnR w="9525" cap="flat" cmpd="sng" algn="ctr">
-                      <a:solidFill>
-                        <a:srgbClr val="F4D9DC"/>
-                      </a:solidFill>
-                      <a:prstDash val="solid"/>
-                      <a:round/>
-                      <a:headEnd type="none" w="med" len="med"/>
-                      <a:tailEnd type="none" w="med" len="med"/>
-                    </a:lnR>
-                    <a:lnT w="9525" cap="flat" cmpd="sng" algn="ctr">
-                      <a:solidFill>
-                        <a:srgbClr val="F4D9DC"/>
-                      </a:solidFill>
-                      <a:prstDash val="solid"/>
-                      <a:round/>
-                      <a:headEnd type="none" w="med" len="med"/>
-                      <a:tailEnd type="none" w="med" len="med"/>
-                    </a:lnT>
-                    <a:lnB w="9525" cap="flat" cmpd="sng" algn="ctr">
-                      <a:solidFill>
-                        <a:srgbClr val="F4D9DC"/>
-                      </a:solidFill>
-                      <a:prstDash val="solid"/>
-                      <a:round/>
-                      <a:headEnd type="none" w="med" len="med"/>
-                      <a:tailEnd type="none" w="med" len="med"/>
-                    </a:lnB>
-                    <a:solidFill>
-                      <a:srgbClr val="FAEAEA"/>
-                    </a:solidFill>
-                  </a:tcPr>
-                </a:tc>
-              </a:tr>
-            </a:tbl>
-          </a:graphicData>
-        </a:graphic>
-      </p:graphicFrame>
+      <p:sp>
+        <p:nvSpPr>
+          <p:cNvPr id="73" name="TextBox 72"/>
+          <p:cNvSpPr txBox="1"/>
+          <p:nvPr/>
+        </p:nvSpPr>
+        <p:spPr>
+          <a:xfrm>
+            <a:off x="548640" y="1719072"/>
+            <a:ext cx="914400" cy="274320"/>
+          </a:xfrm>
+          <a:prstGeom prst="rect">
+            <a:avLst/>
+          </a:prstGeom>
+          <a:noFill/>
+        </p:spPr>
+        <p:txBody>
+          <a:bodyPr wrap="square" lIns="0" rIns="0" tIns="0" bIns="0" anchor="t">
+            <a:spAutoFit/>
+          </a:bodyPr>
+          <a:lstStyle/>
+          <a:p>
+            <a:pPr algn="l"/>
+            <a:r>
+              <a:rPr sz="1400">
+                <a:solidFill>
+                  <a:srgbClr val="3D68EC"/>
+                </a:solidFill>
+                <a:latin typeface="General Sans Semibold"/>
+              </a:rPr>
+              <a:t>0:00</a:t>
+            </a:r>
+          </a:p>
+        </p:txBody>
+      </p:sp>
+      <p:sp>
+        <p:nvSpPr>
+          <p:cNvPr id="74" name="Rectangle 73"/>
+          <p:cNvSpPr/>
+          <p:nvPr/>
+        </p:nvSpPr>
+        <p:spPr>
+          <a:xfrm>
+            <a:off x="548640" y="2103120"/>
+            <a:ext cx="1532458" cy="914400"/>
+          </a:xfrm>
+          <a:prstGeom prst="rect">
+            <a:avLst/>
+          </a:prstGeom>
+          <a:solidFill>
+            <a:srgbClr val="F4D74B"/>
+          </a:solidFill>
+          <a:ln>
+            <a:noFill/>
+          </a:ln>
+          <a:effectLst/>
+        </p:spPr>
+        <p:style>
+          <a:lnRef idx="1">
+            <a:schemeClr val="accent1"/>
+          </a:lnRef>
+          <a:fillRef idx="3">
+            <a:schemeClr val="accent1"/>
+          </a:fillRef>
+          <a:effectRef idx="2">
+            <a:schemeClr val="accent1"/>
+          </a:effectRef>
+          <a:fontRef idx="minor">
+            <a:schemeClr val="lt1"/>
+          </a:fontRef>
+        </p:style>
+        <p:txBody>
+          <a:bodyPr rtlCol="0" anchor="ctr" lIns="45720" rIns="45720" tIns="0" bIns="0" wrap="square"/>
+          <a:lstStyle/>
+          <a:p>
+            <a:pPr algn="ctr"/>
+            <a:r>
+              <a:rPr sz="1800">
+                <a:solidFill>
+                  <a:srgbClr val="000000"/>
+                </a:solidFill>
+                <a:latin typeface="General Sans Semibold"/>
+              </a:rPr>
+              <a:t>17 min</a:t>
+            </a:r>
+          </a:p>
+        </p:txBody>
+      </p:sp>
+      <p:sp>
+        <p:nvSpPr>
+          <p:cNvPr id="75" name="Rectangle 74"/>
+          <p:cNvSpPr/>
+          <p:nvPr/>
+        </p:nvSpPr>
+        <p:spPr>
+          <a:xfrm>
+            <a:off x="548640" y="3017520"/>
+            <a:ext cx="1532458" cy="45720"/>
+          </a:xfrm>
+          <a:prstGeom prst="rect">
+            <a:avLst/>
+          </a:prstGeom>
+          <a:solidFill>
+            <a:srgbClr val="F4D74B"/>
+          </a:solidFill>
+          <a:ln>
+            <a:noFill/>
+          </a:ln>
+          <a:effectLst/>
+        </p:spPr>
+        <p:style>
+          <a:lnRef idx="1">
+            <a:schemeClr val="accent1"/>
+          </a:lnRef>
+          <a:fillRef idx="3">
+            <a:schemeClr val="accent1"/>
+          </a:fillRef>
+          <a:effectRef idx="2">
+            <a:schemeClr val="accent1"/>
+          </a:effectRef>
+          <a:fontRef idx="minor">
+            <a:schemeClr val="lt1"/>
+          </a:fontRef>
+        </p:style>
+        <p:txBody>
+          <a:bodyPr rtlCol="0" anchor="ctr"/>
+          <a:lstStyle/>
+          <a:p>
+            <a:pPr algn="ctr"/>
+          </a:p>
+        </p:txBody>
+      </p:sp>
+      <p:sp>
+        <p:nvSpPr>
+          <p:cNvPr id="76" name="TextBox 75"/>
+          <p:cNvSpPr txBox="1"/>
+          <p:nvPr/>
+        </p:nvSpPr>
+        <p:spPr>
+          <a:xfrm>
+            <a:off x="566928" y="3291839"/>
+            <a:ext cx="1441018" cy="731520"/>
+          </a:xfrm>
+          <a:prstGeom prst="rect">
+            <a:avLst/>
+          </a:prstGeom>
+          <a:noFill/>
+        </p:spPr>
+        <p:txBody>
+          <a:bodyPr wrap="square" lIns="0" rIns="0" tIns="0" bIns="0" anchor="t">
+            <a:spAutoFit/>
+          </a:bodyPr>
+          <a:lstStyle/>
+          <a:p>
+            <a:pPr algn="l"/>
+            <a:r>
+              <a:rPr sz="1100">
+                <a:solidFill>
+                  <a:srgbClr val="000000"/>
+                </a:solidFill>
+                <a:latin typeface="General Sans Semibold"/>
+              </a:rPr>
+              <a:t>Intro, data en casus</a:t>
+            </a:r>
+          </a:p>
+        </p:txBody>
+      </p:sp>
+      <p:sp>
+        <p:nvSpPr>
+          <p:cNvPr id="77" name="TextBox 76"/>
+          <p:cNvSpPr txBox="1"/>
+          <p:nvPr/>
+        </p:nvSpPr>
+        <p:spPr>
+          <a:xfrm>
+            <a:off x="566928" y="4160520"/>
+            <a:ext cx="1441018" cy="822960"/>
+          </a:xfrm>
+          <a:prstGeom prst="rect">
+            <a:avLst/>
+          </a:prstGeom>
+          <a:noFill/>
+        </p:spPr>
+        <p:txBody>
+          <a:bodyPr wrap="square" lIns="0" rIns="0" tIns="0" bIns="0" anchor="t">
+            <a:spAutoFit/>
+          </a:bodyPr>
+          <a:lstStyle/>
+          <a:p>
+            <a:pPr algn="l"/>
+            <a:r>
+              <a:rPr sz="1200">
+                <a:solidFill>
+                  <a:srgbClr val="000000"/>
+                </a:solidFill>
+                <a:latin typeface="General Sans"/>
+              </a:rPr>
+              <a:t>CEDA, synthetische data en de opdracht</a:t>
+            </a:r>
+          </a:p>
+        </p:txBody>
+      </p:sp>
+      <p:sp>
+        <p:nvSpPr>
+          <p:cNvPr id="78" name="TextBox 77"/>
+          <p:cNvSpPr txBox="1"/>
+          <p:nvPr/>
+        </p:nvSpPr>
+        <p:spPr>
+          <a:xfrm>
+            <a:off x="2126818" y="1719072"/>
+            <a:ext cx="914400" cy="274320"/>
+          </a:xfrm>
+          <a:prstGeom prst="rect">
+            <a:avLst/>
+          </a:prstGeom>
+          <a:noFill/>
+        </p:spPr>
+        <p:txBody>
+          <a:bodyPr wrap="square" lIns="0" rIns="0" tIns="0" bIns="0" anchor="t">
+            <a:spAutoFit/>
+          </a:bodyPr>
+          <a:lstStyle/>
+          <a:p>
+            <a:pPr algn="l"/>
+            <a:r>
+              <a:rPr sz="1400">
+                <a:solidFill>
+                  <a:srgbClr val="3D68EC"/>
+                </a:solidFill>
+                <a:latin typeface="General Sans Semibold"/>
+              </a:rPr>
+              <a:t>0:17</a:t>
+            </a:r>
+          </a:p>
+        </p:txBody>
+      </p:sp>
+      <p:sp>
+        <p:nvSpPr>
+          <p:cNvPr id="79" name="Rectangle 78"/>
+          <p:cNvSpPr/>
+          <p:nvPr/>
+        </p:nvSpPr>
+        <p:spPr>
+          <a:xfrm>
+            <a:off x="2126818" y="2103120"/>
+            <a:ext cx="1171879" cy="914400"/>
+          </a:xfrm>
+          <a:prstGeom prst="rect">
+            <a:avLst/>
+          </a:prstGeom>
+          <a:solidFill>
+            <a:srgbClr val="F4D74B"/>
+          </a:solidFill>
+          <a:ln>
+            <a:noFill/>
+          </a:ln>
+          <a:effectLst/>
+        </p:spPr>
+        <p:style>
+          <a:lnRef idx="1">
+            <a:schemeClr val="accent1"/>
+          </a:lnRef>
+          <a:fillRef idx="3">
+            <a:schemeClr val="accent1"/>
+          </a:fillRef>
+          <a:effectRef idx="2">
+            <a:schemeClr val="accent1"/>
+          </a:effectRef>
+          <a:fontRef idx="minor">
+            <a:schemeClr val="lt1"/>
+          </a:fontRef>
+        </p:style>
+        <p:txBody>
+          <a:bodyPr rtlCol="0" anchor="ctr" lIns="45720" rIns="45720" tIns="0" bIns="0" wrap="square"/>
+          <a:lstStyle/>
+          <a:p>
+            <a:pPr algn="ctr"/>
+            <a:r>
+              <a:rPr sz="1800">
+                <a:solidFill>
+                  <a:srgbClr val="000000"/>
+                </a:solidFill>
+                <a:latin typeface="General Sans Semibold"/>
+              </a:rPr>
+              <a:t>13 min</a:t>
+            </a:r>
+          </a:p>
+        </p:txBody>
+      </p:sp>
+      <p:sp>
+        <p:nvSpPr>
+          <p:cNvPr id="80" name="Rectangle 79"/>
+          <p:cNvSpPr/>
+          <p:nvPr/>
+        </p:nvSpPr>
+        <p:spPr>
+          <a:xfrm>
+            <a:off x="2126818" y="3017520"/>
+            <a:ext cx="1171879" cy="45720"/>
+          </a:xfrm>
+          <a:prstGeom prst="rect">
+            <a:avLst/>
+          </a:prstGeom>
+          <a:solidFill>
+            <a:srgbClr val="F4D74B"/>
+          </a:solidFill>
+          <a:ln>
+            <a:noFill/>
+          </a:ln>
+          <a:effectLst/>
+        </p:spPr>
+        <p:style>
+          <a:lnRef idx="1">
+            <a:schemeClr val="accent1"/>
+          </a:lnRef>
+          <a:fillRef idx="3">
+            <a:schemeClr val="accent1"/>
+          </a:fillRef>
+          <a:effectRef idx="2">
+            <a:schemeClr val="accent1"/>
+          </a:effectRef>
+          <a:fontRef idx="minor">
+            <a:schemeClr val="lt1"/>
+          </a:fontRef>
+        </p:style>
+        <p:txBody>
+          <a:bodyPr rtlCol="0" anchor="ctr"/>
+          <a:lstStyle/>
+          <a:p>
+            <a:pPr algn="ctr"/>
+          </a:p>
+        </p:txBody>
+      </p:sp>
+      <p:sp>
+        <p:nvSpPr>
+          <p:cNvPr id="81" name="TextBox 80"/>
+          <p:cNvSpPr txBox="1"/>
+          <p:nvPr/>
+        </p:nvSpPr>
+        <p:spPr>
+          <a:xfrm>
+            <a:off x="2145106" y="3291839"/>
+            <a:ext cx="1080439" cy="731520"/>
+          </a:xfrm>
+          <a:prstGeom prst="rect">
+            <a:avLst/>
+          </a:prstGeom>
+          <a:noFill/>
+        </p:spPr>
+        <p:txBody>
+          <a:bodyPr wrap="square" lIns="0" rIns="0" tIns="0" bIns="0" anchor="t">
+            <a:spAutoFit/>
+          </a:bodyPr>
+          <a:lstStyle/>
+          <a:p>
+            <a:pPr algn="l"/>
+            <a:r>
+              <a:rPr sz="1100">
+                <a:solidFill>
+                  <a:srgbClr val="000000"/>
+                </a:solidFill>
+                <a:latin typeface="General Sans Semibold"/>
+              </a:rPr>
+              <a:t>Skills en devcontainer</a:t>
+            </a:r>
+          </a:p>
+        </p:txBody>
+      </p:sp>
+      <p:sp>
+        <p:nvSpPr>
+          <p:cNvPr id="82" name="TextBox 81"/>
+          <p:cNvSpPr txBox="1"/>
+          <p:nvPr/>
+        </p:nvSpPr>
+        <p:spPr>
+          <a:xfrm>
+            <a:off x="2145106" y="4160520"/>
+            <a:ext cx="1080439" cy="822960"/>
+          </a:xfrm>
+          <a:prstGeom prst="rect">
+            <a:avLst/>
+          </a:prstGeom>
+          <a:noFill/>
+        </p:spPr>
+        <p:txBody>
+          <a:bodyPr wrap="square" lIns="0" rIns="0" tIns="0" bIns="0" anchor="t">
+            <a:spAutoFit/>
+          </a:bodyPr>
+          <a:lstStyle/>
+          <a:p>
+            <a:pPr algn="l"/>
+            <a:r>
+              <a:rPr sz="1200">
+                <a:solidFill>
+                  <a:srgbClr val="000000"/>
+                </a:solidFill>
+                <a:latin typeface="General Sans"/>
+              </a:rPr>
+              <a:t>Wat is een skill, eerste prompt</a:t>
+            </a:r>
+          </a:p>
+        </p:txBody>
+      </p:sp>
+      <p:sp>
+        <p:nvSpPr>
+          <p:cNvPr id="83" name="TextBox 82"/>
+          <p:cNvSpPr txBox="1"/>
+          <p:nvPr/>
+        </p:nvSpPr>
+        <p:spPr>
+          <a:xfrm>
+            <a:off x="3344418" y="1719072"/>
+            <a:ext cx="914400" cy="274320"/>
+          </a:xfrm>
+          <a:prstGeom prst="rect">
+            <a:avLst/>
+          </a:prstGeom>
+          <a:noFill/>
+        </p:spPr>
+        <p:txBody>
+          <a:bodyPr wrap="square" lIns="0" rIns="0" tIns="0" bIns="0" anchor="t">
+            <a:spAutoFit/>
+          </a:bodyPr>
+          <a:lstStyle/>
+          <a:p>
+            <a:pPr algn="l"/>
+            <a:r>
+              <a:rPr sz="1400">
+                <a:solidFill>
+                  <a:srgbClr val="3D68EC"/>
+                </a:solidFill>
+                <a:latin typeface="General Sans Semibold"/>
+              </a:rPr>
+              <a:t>0:30</a:t>
+            </a:r>
+          </a:p>
+        </p:txBody>
+      </p:sp>
+      <p:sp>
+        <p:nvSpPr>
+          <p:cNvPr id="84" name="Rectangle 83"/>
+          <p:cNvSpPr/>
+          <p:nvPr/>
+        </p:nvSpPr>
+        <p:spPr>
+          <a:xfrm>
+            <a:off x="3344418" y="2103120"/>
+            <a:ext cx="1983181" cy="914400"/>
+          </a:xfrm>
+          <a:prstGeom prst="rect">
+            <a:avLst/>
+          </a:prstGeom>
+          <a:solidFill>
+            <a:srgbClr val="3D68EC"/>
+          </a:solidFill>
+          <a:ln>
+            <a:noFill/>
+          </a:ln>
+          <a:effectLst/>
+        </p:spPr>
+        <p:style>
+          <a:lnRef idx="1">
+            <a:schemeClr val="accent1"/>
+          </a:lnRef>
+          <a:fillRef idx="3">
+            <a:schemeClr val="accent1"/>
+          </a:fillRef>
+          <a:effectRef idx="2">
+            <a:schemeClr val="accent1"/>
+          </a:effectRef>
+          <a:fontRef idx="minor">
+            <a:schemeClr val="lt1"/>
+          </a:fontRef>
+        </p:style>
+        <p:txBody>
+          <a:bodyPr rtlCol="0" anchor="ctr" lIns="45720" rIns="45720" tIns="0" bIns="0" wrap="square"/>
+          <a:lstStyle/>
+          <a:p>
+            <a:pPr algn="ctr"/>
+            <a:r>
+              <a:rPr sz="1800">
+                <a:solidFill>
+                  <a:srgbClr val="FFFFFF"/>
+                </a:solidFill>
+                <a:latin typeface="General Sans Semibold"/>
+              </a:rPr>
+              <a:t>22 min</a:t>
+            </a:r>
+          </a:p>
+        </p:txBody>
+      </p:sp>
+      <p:sp>
+        <p:nvSpPr>
+          <p:cNvPr id="85" name="Rectangle 84"/>
+          <p:cNvSpPr/>
+          <p:nvPr/>
+        </p:nvSpPr>
+        <p:spPr>
+          <a:xfrm>
+            <a:off x="3344418" y="3017520"/>
+            <a:ext cx="1983181" cy="45720"/>
+          </a:xfrm>
+          <a:prstGeom prst="rect">
+            <a:avLst/>
+          </a:prstGeom>
+          <a:solidFill>
+            <a:srgbClr val="3D68EC"/>
+          </a:solidFill>
+          <a:ln>
+            <a:noFill/>
+          </a:ln>
+          <a:effectLst/>
+        </p:spPr>
+        <p:style>
+          <a:lnRef idx="1">
+            <a:schemeClr val="accent1"/>
+          </a:lnRef>
+          <a:fillRef idx="3">
+            <a:schemeClr val="accent1"/>
+          </a:fillRef>
+          <a:effectRef idx="2">
+            <a:schemeClr val="accent1"/>
+          </a:effectRef>
+          <a:fontRef idx="minor">
+            <a:schemeClr val="lt1"/>
+          </a:fontRef>
+        </p:style>
+        <p:txBody>
+          <a:bodyPr rtlCol="0" anchor="ctr"/>
+          <a:lstStyle/>
+          <a:p>
+            <a:pPr algn="ctr"/>
+          </a:p>
+        </p:txBody>
+      </p:sp>
+      <p:sp>
+        <p:nvSpPr>
+          <p:cNvPr id="86" name="TextBox 85"/>
+          <p:cNvSpPr txBox="1"/>
+          <p:nvPr/>
+        </p:nvSpPr>
+        <p:spPr>
+          <a:xfrm>
+            <a:off x="3362706" y="3291839"/>
+            <a:ext cx="1891741" cy="731520"/>
+          </a:xfrm>
+          <a:prstGeom prst="rect">
+            <a:avLst/>
+          </a:prstGeom>
+          <a:noFill/>
+        </p:spPr>
+        <p:txBody>
+          <a:bodyPr wrap="square" lIns="0" rIns="0" tIns="0" bIns="0" anchor="t">
+            <a:spAutoFit/>
+          </a:bodyPr>
+          <a:lstStyle/>
+          <a:p>
+            <a:pPr algn="l"/>
+            <a:r>
+              <a:rPr sz="1100">
+                <a:solidFill>
+                  <a:srgbClr val="000000"/>
+                </a:solidFill>
+                <a:latin typeface="General Sans Semibold"/>
+              </a:rPr>
+              <a:t>Ronde 1: data verkennen</a:t>
+            </a:r>
+          </a:p>
+        </p:txBody>
+      </p:sp>
+      <p:sp>
+        <p:nvSpPr>
+          <p:cNvPr id="87" name="TextBox 86"/>
+          <p:cNvSpPr txBox="1"/>
+          <p:nvPr/>
+        </p:nvSpPr>
+        <p:spPr>
+          <a:xfrm>
+            <a:off x="3362706" y="4160520"/>
+            <a:ext cx="1891741" cy="822960"/>
+          </a:xfrm>
+          <a:prstGeom prst="rect">
+            <a:avLst/>
+          </a:prstGeom>
+          <a:noFill/>
+        </p:spPr>
+        <p:txBody>
+          <a:bodyPr wrap="square" lIns="0" rIns="0" tIns="0" bIns="0" anchor="t">
+            <a:spAutoFit/>
+          </a:bodyPr>
+          <a:lstStyle/>
+          <a:p>
+            <a:pPr algn="l"/>
+            <a:r>
+              <a:rPr sz="1200">
+                <a:solidFill>
+                  <a:srgbClr val="000000"/>
+                </a:solidFill>
+                <a:latin typeface="General Sans"/>
+              </a:rPr>
+              <a:t>In tweetallen met de agent</a:t>
+            </a:r>
+          </a:p>
+        </p:txBody>
+      </p:sp>
+      <p:sp>
+        <p:nvSpPr>
+          <p:cNvPr id="88" name="Rounded Rectangle 87"/>
+          <p:cNvSpPr/>
+          <p:nvPr/>
+        </p:nvSpPr>
+        <p:spPr>
+          <a:xfrm>
+            <a:off x="3362706" y="5029200"/>
+            <a:ext cx="1946605" cy="310896"/>
+          </a:xfrm>
+          <a:prstGeom prst="roundRect">
+            <a:avLst/>
+          </a:prstGeom>
+          <a:solidFill>
+            <a:srgbClr val="FFFFFF"/>
+          </a:solidFill>
+          <a:ln>
+            <a:noFill/>
+          </a:ln>
+          <a:effectLst/>
+        </p:spPr>
+        <p:style>
+          <a:lnRef idx="1">
+            <a:schemeClr val="accent1"/>
+          </a:lnRef>
+          <a:fillRef idx="3">
+            <a:schemeClr val="accent1"/>
+          </a:fillRef>
+          <a:effectRef idx="2">
+            <a:schemeClr val="accent1"/>
+          </a:effectRef>
+          <a:fontRef idx="minor">
+            <a:schemeClr val="lt1"/>
+          </a:fontRef>
+        </p:style>
+        <p:txBody>
+          <a:bodyPr rtlCol="0" anchor="ctr" lIns="0" rIns="0" tIns="0" bIns="0" wrap="none"/>
+          <a:lstStyle/>
+          <a:p>
+            <a:pPr algn="ctr"/>
+            <a:r>
+              <a:rPr sz="900">
+                <a:solidFill>
+                  <a:srgbClr val="3D68EC"/>
+                </a:solidFill>
+                <a:latin typeface="General Sans Semibold"/>
+              </a:rPr>
+              <a:t>/workshop-verkennen</a:t>
+            </a:r>
+          </a:p>
+        </p:txBody>
+      </p:sp>
+      <p:sp>
+        <p:nvSpPr>
+          <p:cNvPr id="89" name="TextBox 88"/>
+          <p:cNvSpPr txBox="1"/>
+          <p:nvPr/>
+        </p:nvSpPr>
+        <p:spPr>
+          <a:xfrm>
+            <a:off x="5373319" y="1719072"/>
+            <a:ext cx="914400" cy="274320"/>
+          </a:xfrm>
+          <a:prstGeom prst="rect">
+            <a:avLst/>
+          </a:prstGeom>
+          <a:noFill/>
+        </p:spPr>
+        <p:txBody>
+          <a:bodyPr wrap="square" lIns="0" rIns="0" tIns="0" bIns="0" anchor="t">
+            <a:spAutoFit/>
+          </a:bodyPr>
+          <a:lstStyle/>
+          <a:p>
+            <a:pPr algn="l"/>
+            <a:r>
+              <a:rPr sz="1400">
+                <a:solidFill>
+                  <a:srgbClr val="3D68EC"/>
+                </a:solidFill>
+                <a:latin typeface="General Sans Semibold"/>
+              </a:rPr>
+              <a:t>0:52</a:t>
+            </a:r>
+          </a:p>
+        </p:txBody>
+      </p:sp>
+      <p:sp>
+        <p:nvSpPr>
+          <p:cNvPr id="90" name="Rectangle 89"/>
+          <p:cNvSpPr/>
+          <p:nvPr/>
+        </p:nvSpPr>
+        <p:spPr>
+          <a:xfrm>
+            <a:off x="5373319" y="2103120"/>
+            <a:ext cx="1352169" cy="914400"/>
+          </a:xfrm>
+          <a:prstGeom prst="rect">
+            <a:avLst/>
+          </a:prstGeom>
+          <a:solidFill>
+            <a:srgbClr val="DD784B"/>
+          </a:solidFill>
+          <a:ln>
+            <a:noFill/>
+          </a:ln>
+          <a:effectLst/>
+        </p:spPr>
+        <p:style>
+          <a:lnRef idx="1">
+            <a:schemeClr val="accent1"/>
+          </a:lnRef>
+          <a:fillRef idx="3">
+            <a:schemeClr val="accent1"/>
+          </a:fillRef>
+          <a:effectRef idx="2">
+            <a:schemeClr val="accent1"/>
+          </a:effectRef>
+          <a:fontRef idx="minor">
+            <a:schemeClr val="lt1"/>
+          </a:fontRef>
+        </p:style>
+        <p:txBody>
+          <a:bodyPr rtlCol="0" anchor="ctr" lIns="45720" rIns="45720" tIns="0" bIns="0" wrap="square"/>
+          <a:lstStyle/>
+          <a:p>
+            <a:pPr algn="ctr"/>
+            <a:r>
+              <a:rPr sz="1800">
+                <a:solidFill>
+                  <a:srgbClr val="000000"/>
+                </a:solidFill>
+                <a:latin typeface="General Sans Semibold"/>
+              </a:rPr>
+              <a:t>15 min</a:t>
+            </a:r>
+          </a:p>
+        </p:txBody>
+      </p:sp>
+      <p:sp>
+        <p:nvSpPr>
+          <p:cNvPr id="91" name="Rectangle 90"/>
+          <p:cNvSpPr/>
+          <p:nvPr/>
+        </p:nvSpPr>
+        <p:spPr>
+          <a:xfrm>
+            <a:off x="5373319" y="3017520"/>
+            <a:ext cx="1352169" cy="45720"/>
+          </a:xfrm>
+          <a:prstGeom prst="rect">
+            <a:avLst/>
+          </a:prstGeom>
+          <a:solidFill>
+            <a:srgbClr val="DD784B"/>
+          </a:solidFill>
+          <a:ln>
+            <a:noFill/>
+          </a:ln>
+          <a:effectLst/>
+        </p:spPr>
+        <p:style>
+          <a:lnRef idx="1">
+            <a:schemeClr val="accent1"/>
+          </a:lnRef>
+          <a:fillRef idx="3">
+            <a:schemeClr val="accent1"/>
+          </a:fillRef>
+          <a:effectRef idx="2">
+            <a:schemeClr val="accent1"/>
+          </a:effectRef>
+          <a:fontRef idx="minor">
+            <a:schemeClr val="lt1"/>
+          </a:fontRef>
+        </p:style>
+        <p:txBody>
+          <a:bodyPr rtlCol="0" anchor="ctr"/>
+          <a:lstStyle/>
+          <a:p>
+            <a:pPr algn="ctr"/>
+          </a:p>
+        </p:txBody>
+      </p:sp>
+      <p:sp>
+        <p:nvSpPr>
+          <p:cNvPr id="92" name="TextBox 91"/>
+          <p:cNvSpPr txBox="1"/>
+          <p:nvPr/>
+        </p:nvSpPr>
+        <p:spPr>
+          <a:xfrm>
+            <a:off x="5391607" y="3291839"/>
+            <a:ext cx="1260729" cy="731520"/>
+          </a:xfrm>
+          <a:prstGeom prst="rect">
+            <a:avLst/>
+          </a:prstGeom>
+          <a:noFill/>
+        </p:spPr>
+        <p:txBody>
+          <a:bodyPr wrap="square" lIns="0" rIns="0" tIns="0" bIns="0" anchor="t">
+            <a:spAutoFit/>
+          </a:bodyPr>
+          <a:lstStyle/>
+          <a:p>
+            <a:pPr algn="l"/>
+            <a:r>
+              <a:rPr sz="1100">
+                <a:solidFill>
+                  <a:srgbClr val="000000"/>
+                </a:solidFill>
+                <a:latin typeface="General Sans Semibold"/>
+              </a:rPr>
+              <a:t>Spiegelmoment 1</a:t>
+            </a:r>
+          </a:p>
+        </p:txBody>
+      </p:sp>
+      <p:sp>
+        <p:nvSpPr>
+          <p:cNvPr id="93" name="TextBox 92"/>
+          <p:cNvSpPr txBox="1"/>
+          <p:nvPr/>
+        </p:nvSpPr>
+        <p:spPr>
+          <a:xfrm>
+            <a:off x="5391607" y="4160520"/>
+            <a:ext cx="1260729" cy="822960"/>
+          </a:xfrm>
+          <a:prstGeom prst="rect">
+            <a:avLst/>
+          </a:prstGeom>
+          <a:noFill/>
+        </p:spPr>
+        <p:txBody>
+          <a:bodyPr wrap="square" lIns="0" rIns="0" tIns="0" bIns="0" anchor="t">
+            <a:spAutoFit/>
+          </a:bodyPr>
+          <a:lstStyle/>
+          <a:p>
+            <a:pPr algn="l"/>
+            <a:r>
+              <a:rPr sz="1200">
+                <a:solidFill>
+                  <a:srgbClr val="000000"/>
+                </a:solidFill>
+                <a:latin typeface="General Sans"/>
+              </a:rPr>
+              <a:t>Kijk in de skill</a:t>
+            </a:r>
+          </a:p>
+        </p:txBody>
+      </p:sp>
+      <p:sp>
+        <p:nvSpPr>
+          <p:cNvPr id="94" name="Rounded Rectangle 93"/>
+          <p:cNvSpPr/>
+          <p:nvPr/>
+        </p:nvSpPr>
+        <p:spPr>
+          <a:xfrm>
+            <a:off x="5391607" y="5029200"/>
+            <a:ext cx="1315593" cy="310896"/>
+          </a:xfrm>
+          <a:prstGeom prst="roundRect">
+            <a:avLst/>
+          </a:prstGeom>
+          <a:solidFill>
+            <a:srgbClr val="FFFFFF"/>
+          </a:solidFill>
+          <a:ln>
+            <a:noFill/>
+          </a:ln>
+          <a:effectLst/>
+        </p:spPr>
+        <p:style>
+          <a:lnRef idx="1">
+            <a:schemeClr val="accent1"/>
+          </a:lnRef>
+          <a:fillRef idx="3">
+            <a:schemeClr val="accent1"/>
+          </a:fillRef>
+          <a:effectRef idx="2">
+            <a:schemeClr val="accent1"/>
+          </a:effectRef>
+          <a:fontRef idx="minor">
+            <a:schemeClr val="lt1"/>
+          </a:fontRef>
+        </p:style>
+        <p:txBody>
+          <a:bodyPr rtlCol="0" anchor="ctr" lIns="0" rIns="0" tIns="0" bIns="0" wrap="none"/>
+          <a:lstStyle/>
+          <a:p>
+            <a:pPr algn="ctr"/>
+            <a:r>
+              <a:rPr sz="900">
+                <a:solidFill>
+                  <a:srgbClr val="3D68EC"/>
+                </a:solidFill>
+                <a:latin typeface="General Sans Semibold"/>
+              </a:rPr>
+              <a:t>/workshop-verkennen</a:t>
+            </a:r>
+          </a:p>
+        </p:txBody>
+      </p:sp>
+      <p:sp>
+        <p:nvSpPr>
+          <p:cNvPr id="95" name="TextBox 94"/>
+          <p:cNvSpPr txBox="1"/>
+          <p:nvPr/>
+        </p:nvSpPr>
+        <p:spPr>
+          <a:xfrm>
+            <a:off x="6771208" y="1719072"/>
+            <a:ext cx="914400" cy="274320"/>
+          </a:xfrm>
+          <a:prstGeom prst="rect">
+            <a:avLst/>
+          </a:prstGeom>
+          <a:noFill/>
+        </p:spPr>
+        <p:txBody>
+          <a:bodyPr wrap="square" lIns="0" rIns="0" tIns="0" bIns="0" anchor="t">
+            <a:spAutoFit/>
+          </a:bodyPr>
+          <a:lstStyle/>
+          <a:p>
+            <a:pPr algn="l"/>
+            <a:r>
+              <a:rPr sz="1400">
+                <a:solidFill>
+                  <a:srgbClr val="3D68EC"/>
+                </a:solidFill>
+                <a:latin typeface="General Sans Semibold"/>
+              </a:rPr>
+              <a:t>1:07</a:t>
+            </a:r>
+          </a:p>
+        </p:txBody>
+      </p:sp>
+      <p:sp>
+        <p:nvSpPr>
+          <p:cNvPr id="96" name="Rectangle 95"/>
+          <p:cNvSpPr/>
+          <p:nvPr/>
+        </p:nvSpPr>
+        <p:spPr>
+          <a:xfrm>
+            <a:off x="6771208" y="2103120"/>
+            <a:ext cx="1983181" cy="914400"/>
+          </a:xfrm>
+          <a:prstGeom prst="rect">
+            <a:avLst/>
+          </a:prstGeom>
+          <a:solidFill>
+            <a:srgbClr val="3D68EC"/>
+          </a:solidFill>
+          <a:ln>
+            <a:noFill/>
+          </a:ln>
+          <a:effectLst/>
+        </p:spPr>
+        <p:style>
+          <a:lnRef idx="1">
+            <a:schemeClr val="accent1"/>
+          </a:lnRef>
+          <a:fillRef idx="3">
+            <a:schemeClr val="accent1"/>
+          </a:fillRef>
+          <a:effectRef idx="2">
+            <a:schemeClr val="accent1"/>
+          </a:effectRef>
+          <a:fontRef idx="minor">
+            <a:schemeClr val="lt1"/>
+          </a:fontRef>
+        </p:style>
+        <p:txBody>
+          <a:bodyPr rtlCol="0" anchor="ctr" lIns="45720" rIns="45720" tIns="0" bIns="0" wrap="square"/>
+          <a:lstStyle/>
+          <a:p>
+            <a:pPr algn="ctr"/>
+            <a:r>
+              <a:rPr sz="1800">
+                <a:solidFill>
+                  <a:srgbClr val="FFFFFF"/>
+                </a:solidFill>
+                <a:latin typeface="General Sans Semibold"/>
+              </a:rPr>
+              <a:t>22 min</a:t>
+            </a:r>
+          </a:p>
+        </p:txBody>
+      </p:sp>
+      <p:sp>
+        <p:nvSpPr>
+          <p:cNvPr id="97" name="Rectangle 96"/>
+          <p:cNvSpPr/>
+          <p:nvPr/>
+        </p:nvSpPr>
+        <p:spPr>
+          <a:xfrm>
+            <a:off x="6771208" y="3017520"/>
+            <a:ext cx="1983181" cy="45720"/>
+          </a:xfrm>
+          <a:prstGeom prst="rect">
+            <a:avLst/>
+          </a:prstGeom>
+          <a:solidFill>
+            <a:srgbClr val="3D68EC"/>
+          </a:solidFill>
+          <a:ln>
+            <a:noFill/>
+          </a:ln>
+          <a:effectLst/>
+        </p:spPr>
+        <p:style>
+          <a:lnRef idx="1">
+            <a:schemeClr val="accent1"/>
+          </a:lnRef>
+          <a:fillRef idx="3">
+            <a:schemeClr val="accent1"/>
+          </a:fillRef>
+          <a:effectRef idx="2">
+            <a:schemeClr val="accent1"/>
+          </a:effectRef>
+          <a:fontRef idx="minor">
+            <a:schemeClr val="lt1"/>
+          </a:fontRef>
+        </p:style>
+        <p:txBody>
+          <a:bodyPr rtlCol="0" anchor="ctr"/>
+          <a:lstStyle/>
+          <a:p>
+            <a:pPr algn="ctr"/>
+          </a:p>
+        </p:txBody>
+      </p:sp>
+      <p:sp>
+        <p:nvSpPr>
+          <p:cNvPr id="98" name="TextBox 97"/>
+          <p:cNvSpPr txBox="1"/>
+          <p:nvPr/>
+        </p:nvSpPr>
+        <p:spPr>
+          <a:xfrm>
+            <a:off x="6789496" y="3291839"/>
+            <a:ext cx="1891741" cy="731520"/>
+          </a:xfrm>
+          <a:prstGeom prst="rect">
+            <a:avLst/>
+          </a:prstGeom>
+          <a:noFill/>
+        </p:spPr>
+        <p:txBody>
+          <a:bodyPr wrap="square" lIns="0" rIns="0" tIns="0" bIns="0" anchor="t">
+            <a:spAutoFit/>
+          </a:bodyPr>
+          <a:lstStyle/>
+          <a:p>
+            <a:pPr algn="l"/>
+            <a:r>
+              <a:rPr sz="1100">
+                <a:solidFill>
+                  <a:srgbClr val="000000"/>
+                </a:solidFill>
+                <a:latin typeface="General Sans Semibold"/>
+              </a:rPr>
+              <a:t>Ronde 2: dashboard bouwen</a:t>
+            </a:r>
+          </a:p>
+        </p:txBody>
+      </p:sp>
+      <p:sp>
+        <p:nvSpPr>
+          <p:cNvPr id="99" name="TextBox 98"/>
+          <p:cNvSpPr txBox="1"/>
+          <p:nvPr/>
+        </p:nvSpPr>
+        <p:spPr>
+          <a:xfrm>
+            <a:off x="6789496" y="4160520"/>
+            <a:ext cx="1891741" cy="822960"/>
+          </a:xfrm>
+          <a:prstGeom prst="rect">
+            <a:avLst/>
+          </a:prstGeom>
+          <a:noFill/>
+        </p:spPr>
+        <p:txBody>
+          <a:bodyPr wrap="square" lIns="0" rIns="0" tIns="0" bIns="0" anchor="t">
+            <a:spAutoFit/>
+          </a:bodyPr>
+          <a:lstStyle/>
+          <a:p>
+            <a:pPr algn="l"/>
+            <a:r>
+              <a:rPr sz="1200">
+                <a:solidFill>
+                  <a:srgbClr val="000000"/>
+                </a:solidFill>
+                <a:latin typeface="General Sans"/>
+              </a:rPr>
+              <a:t>Wissel van rol</a:t>
+            </a:r>
+          </a:p>
+        </p:txBody>
+      </p:sp>
+      <p:sp>
+        <p:nvSpPr>
+          <p:cNvPr id="100" name="Rounded Rectangle 99"/>
+          <p:cNvSpPr/>
+          <p:nvPr/>
+        </p:nvSpPr>
+        <p:spPr>
+          <a:xfrm>
+            <a:off x="6789496" y="5029200"/>
+            <a:ext cx="1946605" cy="310896"/>
+          </a:xfrm>
+          <a:prstGeom prst="roundRect">
+            <a:avLst/>
+          </a:prstGeom>
+          <a:solidFill>
+            <a:srgbClr val="FFFFFF"/>
+          </a:solidFill>
+          <a:ln>
+            <a:noFill/>
+          </a:ln>
+          <a:effectLst/>
+        </p:spPr>
+        <p:style>
+          <a:lnRef idx="1">
+            <a:schemeClr val="accent1"/>
+          </a:lnRef>
+          <a:fillRef idx="3">
+            <a:schemeClr val="accent1"/>
+          </a:fillRef>
+          <a:effectRef idx="2">
+            <a:schemeClr val="accent1"/>
+          </a:effectRef>
+          <a:fontRef idx="minor">
+            <a:schemeClr val="lt1"/>
+          </a:fontRef>
+        </p:style>
+        <p:txBody>
+          <a:bodyPr rtlCol="0" anchor="ctr" lIns="0" rIns="0" tIns="0" bIns="0" wrap="none"/>
+          <a:lstStyle/>
+          <a:p>
+            <a:pPr algn="ctr"/>
+            <a:r>
+              <a:rPr sz="900">
+                <a:solidFill>
+                  <a:srgbClr val="3D68EC"/>
+                </a:solidFill>
+                <a:latin typeface="General Sans Semibold"/>
+              </a:rPr>
+              <a:t>/workshop-dashboard</a:t>
+            </a:r>
+          </a:p>
+        </p:txBody>
+      </p:sp>
+      <p:sp>
+        <p:nvSpPr>
+          <p:cNvPr id="101" name="TextBox 100"/>
+          <p:cNvSpPr txBox="1"/>
+          <p:nvPr/>
+        </p:nvSpPr>
+        <p:spPr>
+          <a:xfrm>
+            <a:off x="8800109" y="1719072"/>
+            <a:ext cx="914400" cy="274320"/>
+          </a:xfrm>
+          <a:prstGeom prst="rect">
+            <a:avLst/>
+          </a:prstGeom>
+          <a:noFill/>
+        </p:spPr>
+        <p:txBody>
+          <a:bodyPr wrap="square" lIns="0" rIns="0" tIns="0" bIns="0" anchor="t">
+            <a:spAutoFit/>
+          </a:bodyPr>
+          <a:lstStyle/>
+          <a:p>
+            <a:pPr algn="l"/>
+            <a:r>
+              <a:rPr sz="1400">
+                <a:solidFill>
+                  <a:srgbClr val="3D68EC"/>
+                </a:solidFill>
+                <a:latin typeface="General Sans Semibold"/>
+              </a:rPr>
+              <a:t>1:29</a:t>
+            </a:r>
+          </a:p>
+        </p:txBody>
+      </p:sp>
+      <p:sp>
+        <p:nvSpPr>
+          <p:cNvPr id="102" name="Rectangle 101"/>
+          <p:cNvSpPr/>
+          <p:nvPr/>
+        </p:nvSpPr>
+        <p:spPr>
+          <a:xfrm>
+            <a:off x="8800109" y="2103120"/>
+            <a:ext cx="1352169" cy="914400"/>
+          </a:xfrm>
+          <a:prstGeom prst="rect">
+            <a:avLst/>
+          </a:prstGeom>
+          <a:solidFill>
+            <a:srgbClr val="DD784B"/>
+          </a:solidFill>
+          <a:ln>
+            <a:noFill/>
+          </a:ln>
+          <a:effectLst/>
+        </p:spPr>
+        <p:style>
+          <a:lnRef idx="1">
+            <a:schemeClr val="accent1"/>
+          </a:lnRef>
+          <a:fillRef idx="3">
+            <a:schemeClr val="accent1"/>
+          </a:fillRef>
+          <a:effectRef idx="2">
+            <a:schemeClr val="accent1"/>
+          </a:effectRef>
+          <a:fontRef idx="minor">
+            <a:schemeClr val="lt1"/>
+          </a:fontRef>
+        </p:style>
+        <p:txBody>
+          <a:bodyPr rtlCol="0" anchor="ctr" lIns="45720" rIns="45720" tIns="0" bIns="0" wrap="square"/>
+          <a:lstStyle/>
+          <a:p>
+            <a:pPr algn="ctr"/>
+            <a:r>
+              <a:rPr sz="1800">
+                <a:solidFill>
+                  <a:srgbClr val="000000"/>
+                </a:solidFill>
+                <a:latin typeface="General Sans Semibold"/>
+              </a:rPr>
+              <a:t>15 min</a:t>
+            </a:r>
+          </a:p>
+        </p:txBody>
+      </p:sp>
+      <p:sp>
+        <p:nvSpPr>
+          <p:cNvPr id="103" name="Rectangle 102"/>
+          <p:cNvSpPr/>
+          <p:nvPr/>
+        </p:nvSpPr>
+        <p:spPr>
+          <a:xfrm>
+            <a:off x="8800109" y="3017520"/>
+            <a:ext cx="1352169" cy="45720"/>
+          </a:xfrm>
+          <a:prstGeom prst="rect">
+            <a:avLst/>
+          </a:prstGeom>
+          <a:solidFill>
+            <a:srgbClr val="DD784B"/>
+          </a:solidFill>
+          <a:ln>
+            <a:noFill/>
+          </a:ln>
+          <a:effectLst/>
+        </p:spPr>
+        <p:style>
+          <a:lnRef idx="1">
+            <a:schemeClr val="accent1"/>
+          </a:lnRef>
+          <a:fillRef idx="3">
+            <a:schemeClr val="accent1"/>
+          </a:fillRef>
+          <a:effectRef idx="2">
+            <a:schemeClr val="accent1"/>
+          </a:effectRef>
+          <a:fontRef idx="minor">
+            <a:schemeClr val="lt1"/>
+          </a:fontRef>
+        </p:style>
+        <p:txBody>
+          <a:bodyPr rtlCol="0" anchor="ctr"/>
+          <a:lstStyle/>
+          <a:p>
+            <a:pPr algn="ctr"/>
+          </a:p>
+        </p:txBody>
+      </p:sp>
+      <p:sp>
+        <p:nvSpPr>
+          <p:cNvPr id="104" name="TextBox 103"/>
+          <p:cNvSpPr txBox="1"/>
+          <p:nvPr/>
+        </p:nvSpPr>
+        <p:spPr>
+          <a:xfrm>
+            <a:off x="8818397" y="3291839"/>
+            <a:ext cx="1260729" cy="731520"/>
+          </a:xfrm>
+          <a:prstGeom prst="rect">
+            <a:avLst/>
+          </a:prstGeom>
+          <a:noFill/>
+        </p:spPr>
+        <p:txBody>
+          <a:bodyPr wrap="square" lIns="0" rIns="0" tIns="0" bIns="0" anchor="t">
+            <a:spAutoFit/>
+          </a:bodyPr>
+          <a:lstStyle/>
+          <a:p>
+            <a:pPr algn="l"/>
+            <a:r>
+              <a:rPr sz="1100">
+                <a:solidFill>
+                  <a:srgbClr val="000000"/>
+                </a:solidFill>
+                <a:latin typeface="General Sans Semibold"/>
+              </a:rPr>
+              <a:t>Spiegelmoment 2</a:t>
+            </a:r>
+          </a:p>
+        </p:txBody>
+      </p:sp>
+      <p:sp>
+        <p:nvSpPr>
+          <p:cNvPr id="105" name="TextBox 104"/>
+          <p:cNvSpPr txBox="1"/>
+          <p:nvPr/>
+        </p:nvSpPr>
+        <p:spPr>
+          <a:xfrm>
+            <a:off x="8818397" y="4160520"/>
+            <a:ext cx="1260729" cy="822960"/>
+          </a:xfrm>
+          <a:prstGeom prst="rect">
+            <a:avLst/>
+          </a:prstGeom>
+          <a:noFill/>
+        </p:spPr>
+        <p:txBody>
+          <a:bodyPr wrap="square" lIns="0" rIns="0" tIns="0" bIns="0" anchor="t">
+            <a:spAutoFit/>
+          </a:bodyPr>
+          <a:lstStyle/>
+          <a:p>
+            <a:pPr algn="l"/>
+            <a:r>
+              <a:rPr sz="1200">
+                <a:solidFill>
+                  <a:srgbClr val="000000"/>
+                </a:solidFill>
+                <a:latin typeface="General Sans"/>
+              </a:rPr>
+              <a:t>Kijk in de skill, onthulling</a:t>
+            </a:r>
+          </a:p>
+        </p:txBody>
+      </p:sp>
+      <p:sp>
+        <p:nvSpPr>
+          <p:cNvPr id="106" name="Rounded Rectangle 105"/>
+          <p:cNvSpPr/>
+          <p:nvPr/>
+        </p:nvSpPr>
+        <p:spPr>
+          <a:xfrm>
+            <a:off x="8818397" y="5029200"/>
+            <a:ext cx="1315593" cy="310896"/>
+          </a:xfrm>
+          <a:prstGeom prst="roundRect">
+            <a:avLst/>
+          </a:prstGeom>
+          <a:solidFill>
+            <a:srgbClr val="FFFFFF"/>
+          </a:solidFill>
+          <a:ln>
+            <a:noFill/>
+          </a:ln>
+          <a:effectLst/>
+        </p:spPr>
+        <p:style>
+          <a:lnRef idx="1">
+            <a:schemeClr val="accent1"/>
+          </a:lnRef>
+          <a:fillRef idx="3">
+            <a:schemeClr val="accent1"/>
+          </a:fillRef>
+          <a:effectRef idx="2">
+            <a:schemeClr val="accent1"/>
+          </a:effectRef>
+          <a:fontRef idx="minor">
+            <a:schemeClr val="lt1"/>
+          </a:fontRef>
+        </p:style>
+        <p:txBody>
+          <a:bodyPr rtlCol="0" anchor="ctr" lIns="0" rIns="0" tIns="0" bIns="0" wrap="none"/>
+          <a:lstStyle/>
+          <a:p>
+            <a:pPr algn="ctr"/>
+            <a:r>
+              <a:rPr sz="900">
+                <a:solidFill>
+                  <a:srgbClr val="3D68EC"/>
+                </a:solidFill>
+                <a:latin typeface="General Sans Semibold"/>
+              </a:rPr>
+              <a:t>/workshop-dashboard</a:t>
+            </a:r>
+          </a:p>
+        </p:txBody>
+      </p:sp>
+      <p:sp>
+        <p:nvSpPr>
+          <p:cNvPr id="107" name="TextBox 106"/>
+          <p:cNvSpPr txBox="1"/>
+          <p:nvPr/>
+        </p:nvSpPr>
+        <p:spPr>
+          <a:xfrm>
+            <a:off x="10197998" y="1719072"/>
+            <a:ext cx="914400" cy="274320"/>
+          </a:xfrm>
+          <a:prstGeom prst="rect">
+            <a:avLst/>
+          </a:prstGeom>
+          <a:noFill/>
+        </p:spPr>
+        <p:txBody>
+          <a:bodyPr wrap="square" lIns="0" rIns="0" tIns="0" bIns="0" anchor="t">
+            <a:spAutoFit/>
+          </a:bodyPr>
+          <a:lstStyle/>
+          <a:p>
+            <a:pPr algn="l"/>
+            <a:r>
+              <a:rPr sz="1400">
+                <a:solidFill>
+                  <a:srgbClr val="3D68EC"/>
+                </a:solidFill>
+                <a:latin typeface="General Sans Semibold"/>
+              </a:rPr>
+              <a:t>1:44</a:t>
+            </a:r>
+          </a:p>
+        </p:txBody>
+      </p:sp>
+      <p:sp>
+        <p:nvSpPr>
+          <p:cNvPr id="108" name="Rectangle 107"/>
+          <p:cNvSpPr/>
+          <p:nvPr/>
+        </p:nvSpPr>
+        <p:spPr>
+          <a:xfrm>
+            <a:off x="10197998" y="2103120"/>
+            <a:ext cx="1442313" cy="914400"/>
+          </a:xfrm>
+          <a:prstGeom prst="rect">
+            <a:avLst/>
+          </a:prstGeom>
+          <a:solidFill>
+            <a:srgbClr val="00AF81"/>
+          </a:solidFill>
+          <a:ln>
+            <a:noFill/>
+          </a:ln>
+          <a:effectLst/>
+        </p:spPr>
+        <p:style>
+          <a:lnRef idx="1">
+            <a:schemeClr val="accent1"/>
+          </a:lnRef>
+          <a:fillRef idx="3">
+            <a:schemeClr val="accent1"/>
+          </a:fillRef>
+          <a:effectRef idx="2">
+            <a:schemeClr val="accent1"/>
+          </a:effectRef>
+          <a:fontRef idx="minor">
+            <a:schemeClr val="lt1"/>
+          </a:fontRef>
+        </p:style>
+        <p:txBody>
+          <a:bodyPr rtlCol="0" anchor="ctr" lIns="45720" rIns="45720" tIns="0" bIns="0" wrap="square"/>
+          <a:lstStyle/>
+          <a:p>
+            <a:pPr algn="ctr"/>
+            <a:r>
+              <a:rPr sz="1800">
+                <a:solidFill>
+                  <a:srgbClr val="FFFFFF"/>
+                </a:solidFill>
+                <a:latin typeface="General Sans Semibold"/>
+              </a:rPr>
+              <a:t>16 min</a:t>
+            </a:r>
+          </a:p>
+        </p:txBody>
+      </p:sp>
+      <p:sp>
+        <p:nvSpPr>
+          <p:cNvPr id="109" name="Rectangle 108"/>
+          <p:cNvSpPr/>
+          <p:nvPr/>
+        </p:nvSpPr>
+        <p:spPr>
+          <a:xfrm>
+            <a:off x="10197998" y="3017520"/>
+            <a:ext cx="1442313" cy="45720"/>
+          </a:xfrm>
+          <a:prstGeom prst="rect">
+            <a:avLst/>
+          </a:prstGeom>
+          <a:solidFill>
+            <a:srgbClr val="00AF81"/>
+          </a:solidFill>
+          <a:ln>
+            <a:noFill/>
+          </a:ln>
+          <a:effectLst/>
+        </p:spPr>
+        <p:style>
+          <a:lnRef idx="1">
+            <a:schemeClr val="accent1"/>
+          </a:lnRef>
+          <a:fillRef idx="3">
+            <a:schemeClr val="accent1"/>
+          </a:fillRef>
+          <a:effectRef idx="2">
+            <a:schemeClr val="accent1"/>
+          </a:effectRef>
+          <a:fontRef idx="minor">
+            <a:schemeClr val="lt1"/>
+          </a:fontRef>
+        </p:style>
+        <p:txBody>
+          <a:bodyPr rtlCol="0" anchor="ctr"/>
+          <a:lstStyle/>
+          <a:p>
+            <a:pPr algn="ctr"/>
+          </a:p>
+        </p:txBody>
+      </p:sp>
+      <p:sp>
+        <p:nvSpPr>
+          <p:cNvPr id="110" name="TextBox 109"/>
+          <p:cNvSpPr txBox="1"/>
+          <p:nvPr/>
+        </p:nvSpPr>
+        <p:spPr>
+          <a:xfrm>
+            <a:off x="10216286" y="3291839"/>
+            <a:ext cx="1350873" cy="731520"/>
+          </a:xfrm>
+          <a:prstGeom prst="rect">
+            <a:avLst/>
+          </a:prstGeom>
+          <a:noFill/>
+        </p:spPr>
+        <p:txBody>
+          <a:bodyPr wrap="square" lIns="0" rIns="0" tIns="0" bIns="0" anchor="t">
+            <a:spAutoFit/>
+          </a:bodyPr>
+          <a:lstStyle/>
+          <a:p>
+            <a:pPr algn="l"/>
+            <a:r>
+              <a:rPr sz="1100">
+                <a:solidFill>
+                  <a:srgbClr val="000000"/>
+                </a:solidFill>
+                <a:latin typeface="General Sans Semibold"/>
+              </a:rPr>
+              <a:t>Evaluatie en afsluiting</a:t>
+            </a:r>
+          </a:p>
+        </p:txBody>
+      </p:sp>
+      <p:sp>
+        <p:nvSpPr>
+          <p:cNvPr id="111" name="TextBox 110"/>
+          <p:cNvSpPr txBox="1"/>
+          <p:nvPr/>
+        </p:nvSpPr>
+        <p:spPr>
+          <a:xfrm>
+            <a:off x="10216286" y="4160520"/>
+            <a:ext cx="1350873" cy="822960"/>
+          </a:xfrm>
+          <a:prstGeom prst="rect">
+            <a:avLst/>
+          </a:prstGeom>
+          <a:noFill/>
+        </p:spPr>
+        <p:txBody>
+          <a:bodyPr wrap="square" lIns="0" rIns="0" tIns="0" bIns="0" anchor="t">
+            <a:spAutoFit/>
+          </a:bodyPr>
+          <a:lstStyle/>
+          <a:p>
+            <a:pPr algn="l"/>
+            <a:r>
+              <a:rPr sz="1200">
+                <a:solidFill>
+                  <a:srgbClr val="000000"/>
+                </a:solidFill>
+                <a:latin typeface="General Sans"/>
+              </a:rPr>
+              <a:t>Terugblik, peiling, rondje</a:t>
+            </a:r>
+          </a:p>
+        </p:txBody>
+      </p:sp>
+      <p:sp>
+        <p:nvSpPr>
+          <p:cNvPr id="112" name="Rounded Rectangle 111"/>
+          <p:cNvSpPr/>
+          <p:nvPr/>
+        </p:nvSpPr>
+        <p:spPr>
+          <a:xfrm>
+            <a:off x="10216286" y="5029200"/>
+            <a:ext cx="1405737" cy="310896"/>
+          </a:xfrm>
+          <a:prstGeom prst="roundRect">
+            <a:avLst/>
+          </a:prstGeom>
+          <a:solidFill>
+            <a:srgbClr val="FFFFFF"/>
+          </a:solidFill>
+          <a:ln>
+            <a:noFill/>
+          </a:ln>
+          <a:effectLst/>
+        </p:spPr>
+        <p:style>
+          <a:lnRef idx="1">
+            <a:schemeClr val="accent1"/>
+          </a:lnRef>
+          <a:fillRef idx="3">
+            <a:schemeClr val="accent1"/>
+          </a:fillRef>
+          <a:effectRef idx="2">
+            <a:schemeClr val="accent1"/>
+          </a:effectRef>
+          <a:fontRef idx="minor">
+            <a:schemeClr val="lt1"/>
+          </a:fontRef>
+        </p:style>
+        <p:txBody>
+          <a:bodyPr rtlCol="0" anchor="ctr" lIns="0" rIns="0" tIns="0" bIns="0" wrap="none"/>
+          <a:lstStyle/>
+          <a:p>
+            <a:pPr algn="ctr"/>
+            <a:r>
+              <a:rPr sz="900">
+                <a:solidFill>
+                  <a:srgbClr val="3D68EC"/>
+                </a:solidFill>
+                <a:latin typeface="General Sans Semibold"/>
+              </a:rPr>
+              <a:t>/workshop-reflectie</a:t>
+            </a:r>
+          </a:p>
+        </p:txBody>
+      </p:sp>
+      <p:sp>
+        <p:nvSpPr>
+          <p:cNvPr id="113" name="TextBox 112"/>
+          <p:cNvSpPr txBox="1"/>
+          <p:nvPr/>
+        </p:nvSpPr>
+        <p:spPr>
+          <a:xfrm>
+            <a:off x="10725912" y="1719072"/>
+            <a:ext cx="914400" cy="274320"/>
+          </a:xfrm>
+          <a:prstGeom prst="rect">
+            <a:avLst/>
+          </a:prstGeom>
+          <a:noFill/>
+        </p:spPr>
+        <p:txBody>
+          <a:bodyPr wrap="square" lIns="0" rIns="0" tIns="0" bIns="0" anchor="t">
+            <a:spAutoFit/>
+          </a:bodyPr>
+          <a:lstStyle/>
+          <a:p>
+            <a:pPr algn="r"/>
+            <a:r>
+              <a:rPr sz="1400">
+                <a:solidFill>
+                  <a:srgbClr val="3D68EC"/>
+                </a:solidFill>
+                <a:latin typeface="General Sans Semibold"/>
+              </a:rPr>
+              <a:t>2:00</a:t>
+            </a:r>
+          </a:p>
+        </p:txBody>
+      </p:sp>
+      <p:sp>
+        <p:nvSpPr>
+          <p:cNvPr id="114" name="Rectangle 113"/>
+          <p:cNvSpPr/>
+          <p:nvPr/>
+        </p:nvSpPr>
+        <p:spPr>
+          <a:xfrm>
+            <a:off x="548640" y="6025896"/>
+            <a:ext cx="201168" cy="201168"/>
+          </a:xfrm>
+          <a:prstGeom prst="rect">
+            <a:avLst/>
+          </a:prstGeom>
+          <a:solidFill>
+            <a:srgbClr val="F4D74B"/>
+          </a:solidFill>
+          <a:ln>
+            <a:noFill/>
+          </a:ln>
+          <a:effectLst/>
+        </p:spPr>
+        <p:style>
+          <a:lnRef idx="1">
+            <a:schemeClr val="accent1"/>
+          </a:lnRef>
+          <a:fillRef idx="3">
+            <a:schemeClr val="accent1"/>
+          </a:fillRef>
+          <a:effectRef idx="2">
+            <a:schemeClr val="accent1"/>
+          </a:effectRef>
+          <a:fontRef idx="minor">
+            <a:schemeClr val="lt1"/>
+          </a:fontRef>
+        </p:style>
+        <p:txBody>
+          <a:bodyPr rtlCol="0" anchor="ctr"/>
+          <a:lstStyle/>
+          <a:p>
+            <a:pPr algn="ctr"/>
+          </a:p>
+        </p:txBody>
+      </p:sp>
+      <p:sp>
+        <p:nvSpPr>
+          <p:cNvPr id="115" name="TextBox 114"/>
+          <p:cNvSpPr txBox="1"/>
+          <p:nvPr/>
+        </p:nvSpPr>
+        <p:spPr>
+          <a:xfrm>
+            <a:off x="841247" y="5989320"/>
+            <a:ext cx="2194560" cy="274320"/>
+          </a:xfrm>
+          <a:prstGeom prst="rect">
+            <a:avLst/>
+          </a:prstGeom>
+          <a:noFill/>
+        </p:spPr>
+        <p:txBody>
+          <a:bodyPr wrap="square" lIns="0" rIns="0" tIns="0" bIns="0" anchor="ctr">
+            <a:spAutoFit/>
+          </a:bodyPr>
+          <a:lstStyle/>
+          <a:p>
+            <a:pPr algn="l"/>
+            <a:r>
+              <a:rPr sz="1200">
+                <a:solidFill>
+                  <a:srgbClr val="000000"/>
+                </a:solidFill>
+                <a:latin typeface="General Sans"/>
+              </a:rPr>
+              <a:t>Uitleg</a:t>
+            </a:r>
+          </a:p>
+        </p:txBody>
+      </p:sp>
+      <p:sp>
+        <p:nvSpPr>
+          <p:cNvPr id="116" name="Rectangle 115"/>
+          <p:cNvSpPr/>
+          <p:nvPr/>
+        </p:nvSpPr>
+        <p:spPr>
+          <a:xfrm>
+            <a:off x="1901952" y="6025896"/>
+            <a:ext cx="201168" cy="201168"/>
+          </a:xfrm>
+          <a:prstGeom prst="rect">
+            <a:avLst/>
+          </a:prstGeom>
+          <a:solidFill>
+            <a:srgbClr val="3D68EC"/>
+          </a:solidFill>
+          <a:ln>
+            <a:noFill/>
+          </a:ln>
+          <a:effectLst/>
+        </p:spPr>
+        <p:style>
+          <a:lnRef idx="1">
+            <a:schemeClr val="accent1"/>
+          </a:lnRef>
+          <a:fillRef idx="3">
+            <a:schemeClr val="accent1"/>
+          </a:fillRef>
+          <a:effectRef idx="2">
+            <a:schemeClr val="accent1"/>
+          </a:effectRef>
+          <a:fontRef idx="minor">
+            <a:schemeClr val="lt1"/>
+          </a:fontRef>
+        </p:style>
+        <p:txBody>
+          <a:bodyPr rtlCol="0" anchor="ctr"/>
+          <a:lstStyle/>
+          <a:p>
+            <a:pPr algn="ctr"/>
+          </a:p>
+        </p:txBody>
+      </p:sp>
+      <p:sp>
+        <p:nvSpPr>
+          <p:cNvPr id="117" name="TextBox 116"/>
+          <p:cNvSpPr txBox="1"/>
+          <p:nvPr/>
+        </p:nvSpPr>
+        <p:spPr>
+          <a:xfrm>
+            <a:off x="2194560" y="5989320"/>
+            <a:ext cx="2194560" cy="274320"/>
+          </a:xfrm>
+          <a:prstGeom prst="rect">
+            <a:avLst/>
+          </a:prstGeom>
+          <a:noFill/>
+        </p:spPr>
+        <p:txBody>
+          <a:bodyPr wrap="square" lIns="0" rIns="0" tIns="0" bIns="0" anchor="ctr">
+            <a:spAutoFit/>
+          </a:bodyPr>
+          <a:lstStyle/>
+          <a:p>
+            <a:pPr algn="l"/>
+            <a:r>
+              <a:rPr sz="1200">
+                <a:solidFill>
+                  <a:srgbClr val="000000"/>
+                </a:solidFill>
+                <a:latin typeface="General Sans"/>
+              </a:rPr>
+              <a:t>Werken in tweetallen</a:t>
+            </a:r>
+          </a:p>
+        </p:txBody>
+      </p:sp>
+      <p:sp>
+        <p:nvSpPr>
+          <p:cNvPr id="118" name="Rectangle 117"/>
+          <p:cNvSpPr/>
+          <p:nvPr/>
+        </p:nvSpPr>
+        <p:spPr>
+          <a:xfrm>
+            <a:off x="4663440" y="6025896"/>
+            <a:ext cx="201168" cy="201168"/>
+          </a:xfrm>
+          <a:prstGeom prst="rect">
+            <a:avLst/>
+          </a:prstGeom>
+          <a:solidFill>
+            <a:srgbClr val="DD784B"/>
+          </a:solidFill>
+          <a:ln>
+            <a:noFill/>
+          </a:ln>
+          <a:effectLst/>
+        </p:spPr>
+        <p:style>
+          <a:lnRef idx="1">
+            <a:schemeClr val="accent1"/>
+          </a:lnRef>
+          <a:fillRef idx="3">
+            <a:schemeClr val="accent1"/>
+          </a:fillRef>
+          <a:effectRef idx="2">
+            <a:schemeClr val="accent1"/>
+          </a:effectRef>
+          <a:fontRef idx="minor">
+            <a:schemeClr val="lt1"/>
+          </a:fontRef>
+        </p:style>
+        <p:txBody>
+          <a:bodyPr rtlCol="0" anchor="ctr"/>
+          <a:lstStyle/>
+          <a:p>
+            <a:pPr algn="ctr"/>
+          </a:p>
+        </p:txBody>
+      </p:sp>
+      <p:sp>
+        <p:nvSpPr>
+          <p:cNvPr id="119" name="TextBox 118"/>
+          <p:cNvSpPr txBox="1"/>
+          <p:nvPr/>
+        </p:nvSpPr>
+        <p:spPr>
+          <a:xfrm>
+            <a:off x="4956048" y="5989320"/>
+            <a:ext cx="2194560" cy="274320"/>
+          </a:xfrm>
+          <a:prstGeom prst="rect">
+            <a:avLst/>
+          </a:prstGeom>
+          <a:noFill/>
+        </p:spPr>
+        <p:txBody>
+          <a:bodyPr wrap="square" lIns="0" rIns="0" tIns="0" bIns="0" anchor="ctr">
+            <a:spAutoFit/>
+          </a:bodyPr>
+          <a:lstStyle/>
+          <a:p>
+            <a:pPr algn="l"/>
+            <a:r>
+              <a:rPr sz="1200">
+                <a:solidFill>
+                  <a:srgbClr val="000000"/>
+                </a:solidFill>
+                <a:latin typeface="General Sans"/>
+              </a:rPr>
+              <a:t>Spiegelmoment</a:t>
+            </a:r>
+          </a:p>
+        </p:txBody>
+      </p:sp>
+      <p:sp>
+        <p:nvSpPr>
+          <p:cNvPr id="120" name="Rectangle 119"/>
+          <p:cNvSpPr/>
+          <p:nvPr/>
+        </p:nvSpPr>
+        <p:spPr>
+          <a:xfrm>
+            <a:off x="6720840" y="6025896"/>
+            <a:ext cx="201168" cy="201168"/>
+          </a:xfrm>
+          <a:prstGeom prst="rect">
+            <a:avLst/>
+          </a:prstGeom>
+          <a:solidFill>
+            <a:srgbClr val="00AF81"/>
+          </a:solidFill>
+          <a:ln>
+            <a:noFill/>
+          </a:ln>
+          <a:effectLst/>
+        </p:spPr>
+        <p:style>
+          <a:lnRef idx="1">
+            <a:schemeClr val="accent1"/>
+          </a:lnRef>
+          <a:fillRef idx="3">
+            <a:schemeClr val="accent1"/>
+          </a:fillRef>
+          <a:effectRef idx="2">
+            <a:schemeClr val="accent1"/>
+          </a:effectRef>
+          <a:fontRef idx="minor">
+            <a:schemeClr val="lt1"/>
+          </a:fontRef>
+        </p:style>
+        <p:txBody>
+          <a:bodyPr rtlCol="0" anchor="ctr"/>
+          <a:lstStyle/>
+          <a:p>
+            <a:pPr algn="ctr"/>
+          </a:p>
+        </p:txBody>
+      </p:sp>
+      <p:sp>
+        <p:nvSpPr>
+          <p:cNvPr id="121" name="TextBox 120"/>
+          <p:cNvSpPr txBox="1"/>
+          <p:nvPr/>
+        </p:nvSpPr>
+        <p:spPr>
+          <a:xfrm>
+            <a:off x="7013448" y="5989320"/>
+            <a:ext cx="2194560" cy="274320"/>
+          </a:xfrm>
+          <a:prstGeom prst="rect">
+            <a:avLst/>
+          </a:prstGeom>
+          <a:noFill/>
+        </p:spPr>
+        <p:txBody>
+          <a:bodyPr wrap="square" lIns="0" rIns="0" tIns="0" bIns="0" anchor="ctr">
+            <a:spAutoFit/>
+          </a:bodyPr>
+          <a:lstStyle/>
+          <a:p>
+            <a:pPr algn="l"/>
+            <a:r>
+              <a:rPr sz="1200">
+                <a:solidFill>
+                  <a:srgbClr val="000000"/>
+                </a:solidFill>
+                <a:latin typeface="General Sans"/>
+              </a:rPr>
+              <a:t>Evaluatie en afsluiting</a:t>
+            </a:r>
+          </a:p>
+        </p:txBody>
+      </p:sp>
       <p:pic>
         <p:nvPicPr>
-          <p:cNvPr id="73" name="Npuls beeldmerk" descr="npuls-beeldmerk-zwart.png"/>
+          <p:cNvPr id="122" name="Npuls beeldmerk" descr="npuls-beeldmerk-zwart.png"/>
           <p:cNvPicPr>
             <a:picLocks noChangeAspect="1"/>
           </p:cNvPicPr>

</xml_diff>

<commit_message>
fix(workshop): begrijpelijkere slides over casus, rollen en prompt/skill/agent; skills alleen bij spiegelmomenten
- 'AI-taak' wordt 'Met de agent'; bestuurder/navigator wordt prompter/checker; 'Vraag je iets?' vervangen
- Agent, prompt en skill uitgelegd met de agent als uitvoerder, de prompt als losse opdracht en de skill als vast stappenplan
- Deelnemers gebruiken de skills niet zelf; de leider laat ze zien bij de spiegelmomenten (ook in de tijdlijn)

Co-Authored-By: Claude Sonnet 5.5 <noreply@anthropic.com>
</commit_message>
<xml_diff>
--- a/workshop-rad/exports/261005_workshop_rad_uitvoering.pptx
+++ b/workshop-rad/exports/261005_workshop_rad_uitvoering.pptx
@@ -863,7 +863,7 @@
           <a:p>
             <a:r>
               <a:rPr lang="en-US" dirty="0"/>
-              <a:t>Doe de eerste instructie live voor, op het scherm. Laat zien dat de agent de code zichtbaar maakt. Activeren van de skills duurt maximaal een minuut; lukt dat niet, dan is dat een signaal over de devcontainer en niet over de deelnemer.</a:t>
+              <a:t>Doe de eerste instructie live voor, op het scherm. Laat zien dat de agent de code zichtbaar maakt. Lukt het starten van Claude Code niet binnen een paar minuten, dan is dat een signaal over de devcontainer en niet over de deelnemer. Houd hier genoeg tijd voor.</a:t>
             </a:r>
             <a:endParaRPr lang="en-US" dirty="0"/>
           </a:p>
@@ -1127,7 +1127,7 @@
           <a:p>
             <a:r>
               <a:rPr lang="en-US" dirty="0"/>
-              <a:t>We kijken niet naar individuele schetsen, maar naar de skill. Vraag eerst twee tweetallen om één ding te noemen dat ze in ronde 1 tegenkwamen (één zin per tweetal). Loop daarna met de volgende twee dia's door de skill. Draai desgewenst /workshop-verkennen live om het verschil te laten zien.</a:t>
+              <a:t>We kijken niet naar individuele schetsen, maar naar de skill. Vraag eerst twee tweetallen om één ding te noemen dat ze in ronde 1 tegenkwamen (één zin per tweetal). Loop daarna met de volgende twee dia's door de skill. Draai /workshop-verkennen live (zie docs/tijdmeting.md voor hoe lang dat duurt) en leg uit terwijl hij loopt. Zet daarnaast desgewenst één gewone prompt op hetzelfde scherm.</a:t>
             </a:r>
             <a:endParaRPr lang="en-US" dirty="0"/>
           </a:p>
@@ -2887,7 +2887,7 @@
           <a:p>
             <a:r>
               <a:rPr lang="en-US" dirty="0"/>
-              <a:t>Casus A gekozen omdat de data daar het sterkst op aansluit. Let op: opleidingsvorm heeft maar één waarde (voltijd). Wie dat zelf ontdekt, ziet waarom verkennen loont. Noem het niet vooraf.</a:t>
+              <a:t>Uitleg voor jezelf: een casus is het probleem waar alle tweetallen aan werken. Eerstejaarsuitval = eerstejaars die binnen een jaar stoppen. De vraag is wie dat zijn en of het per sector verschilt. De deelnemers laten de agent de cijfers uitrekenen; zij bepalen wat ze ermee doen. Casus A gekozen omdat de data daar het sterkst op aansluit. Let op: opleidingsvorm heeft maar één waarde (voltijd). Wie dat zelf ontdekt, ziet waarom verkennen loont. Noem het niet vooraf.</a:t>
             </a:r>
             <a:endParaRPr lang="en-US" dirty="0"/>
           </a:p>
@@ -2975,7 +2975,7 @@
           <a:p>
             <a:r>
               <a:rPr lang="en-US" dirty="0"/>
-              <a:t>Verdeel de tweetallen nu. Iedereen heeft een laptop met de devcontainer; check dat per tweetal één laptop werkt. Wat ze aan het eind in handen hebben: een eigen aanpak, gespiegeld aan de tweetallen om hen heen.</a:t>
+              <a:t>Verdeel de tweetallen nu. Niemand hoeft code te lezen: de prompter typt, de checker beoordeelt of het antwoord van de agent logisch is. Bij vragen van deelnemers: stel zelf een wedervraag (wat zou je de agent kunnen vragen?). Check dat per tweetal één laptop met de devcontainer werkt. Wat ze aan het eind in handen hebben: een eigen aanpak, gespiegeld aan de tweetallen om hen heen.</a:t>
             </a:r>
             <a:endParaRPr lang="en-US" dirty="0"/>
           </a:p>
@@ -3063,7 +3063,7 @@
           <a:p>
             <a:r>
               <a:rPr lang="en-US" dirty="0"/>
-              <a:t>Laat een echte SKILL.md zien, maximaal een minuut. Een goede prompt helpt jou vandaag, een goede skill helpt je hele team elke keer weer. Na elk spiegelmoment doet een skill in één instructie wat jullie net met de hand deden. Geen black box: je kunt lezen wat de agent gaat doen.</a:t>
+              <a:t>Vergelijk met een collega. De agent is de collega die het werk doet. Een prompt is een mondelinge opdracht aan die collega: snel, maar elke keer anders. Een skill is een werkinstructie die je die collega geeft: dezelfde stappen en dezelfde controles, elke keer. Laat een echte SKILL.md zien, maximaal een minuut. Vuistregel: elke prompt die je drie keer typt, is een skill in wording. Zelf doen jullie de rondes met prompts; de skills laten wij zien bij de spiegelmomenten.</a:t>
             </a:r>
             <a:endParaRPr lang="en-US" dirty="0"/>
           </a:p>
@@ -3151,7 +3151,7 @@
           <a:p>
             <a:r>
               <a:rPr lang="en-US" dirty="0"/>
-              <a:t>Noem de drie skills bij naam: /workshop-verkennen, /workshop-dashboard en /workshop-reflectie. Ze staan klaar in .claude/skills/ in de devcontainer. Bij elk spiegelmoment kijken we straks in de skill zelf: wat staat erin en wat dwingt hij af.</a:t>
+              <a:t>Noem de drie skills bij naam: /workshop-verkennen, /workshop-dashboard en /workshop-reflectie. De deelnemers gebruiken ze niet zelf in de rondes: de leider laat ze draaien bij de spiegelmomenten en legt dan uit wat erin staat en wat de skill afdwingt.</a:t>
             </a:r>
             <a:endParaRPr lang="en-US" dirty="0"/>
           </a:p>
@@ -4922,7 +4922,7 @@
                 <a:ea typeface="General Sans Semibold" pitchFamily="34" charset="-122"/>
                 <a:cs typeface="General Sans Semibold" pitchFamily="34" charset="-120"/>
               </a:rPr>
-              <a:t>Activeer skill 1</a:t>
+              <a:t>Stuur de agent aan</a:t>
             </a:r>
             <a:endParaRPr lang="en-US" sz="1600" dirty="0"/>
           </a:p>
@@ -4964,7 +4964,7 @@
                 <a:ea typeface="General Sans" pitchFamily="34" charset="-122"/>
                 <a:cs typeface="General Sans" pitchFamily="34" charset="-120"/>
               </a:rPr>
-              <a:t>/workshop-verkennen: dat doen we straks bij het spiegelmoment</a:t>
+              <a:t>Jij prompt, de agent rekent en bouwt. De skills laten wij straks zien</a:t>
             </a:r>
             <a:endParaRPr lang="en-US" sz="1400" dirty="0"/>
           </a:p>
@@ -5028,7 +5028,7 @@
                 <a:ea typeface="General Sans Semibold" pitchFamily="34" charset="-122"/>
                 <a:cs typeface="General Sans Semibold" pitchFamily="34" charset="-120"/>
               </a:rPr>
-              <a:t>Later</a:t>
+              <a:t>Straks</a:t>
             </a:r>
             <a:endParaRPr lang="en-US" sz="1100" dirty="0"/>
           </a:p>
@@ -19095,27 +19095,62 @@
                 </a:solidFill>
                 <a:latin typeface="General Sans"/>
               </a:rPr>
-              <a:t>In tweetallen met de agent</a:t>
-            </a:r>
-          </a:p>
-        </p:txBody>
-      </p:sp>
-      <p:sp>
-        <p:nvSpPr>
-          <p:cNvPr id="88" name="Rounded Rectangle 87"/>
-          <p:cNvSpPr/>
-          <p:nvPr/>
-        </p:nvSpPr>
-        <p:spPr>
-          <a:xfrm>
-            <a:off x="3362706" y="5029200"/>
-            <a:ext cx="1946605" cy="310896"/>
-          </a:xfrm>
-          <a:prstGeom prst="roundRect">
+              <a:t>Jullie prompten zelf</a:t>
+            </a:r>
+          </a:p>
+        </p:txBody>
+      </p:sp>
+      <p:sp>
+        <p:nvSpPr>
+          <p:cNvPr id="88" name="TextBox 87"/>
+          <p:cNvSpPr txBox="1"/>
+          <p:nvPr/>
+        </p:nvSpPr>
+        <p:spPr>
+          <a:xfrm>
+            <a:off x="5373319" y="1719072"/>
+            <a:ext cx="914400" cy="274320"/>
+          </a:xfrm>
+          <a:prstGeom prst="rect">
+            <a:avLst/>
+          </a:prstGeom>
+          <a:noFill/>
+        </p:spPr>
+        <p:txBody>
+          <a:bodyPr wrap="square" lIns="0" rIns="0" tIns="0" bIns="0" anchor="t">
+            <a:spAutoFit/>
+          </a:bodyPr>
+          <a:lstStyle/>
+          <a:p>
+            <a:pPr algn="l"/>
+            <a:r>
+              <a:rPr sz="1400">
+                <a:solidFill>
+                  <a:srgbClr val="3D68EC"/>
+                </a:solidFill>
+                <a:latin typeface="General Sans Semibold"/>
+              </a:rPr>
+              <a:t>0:52</a:t>
+            </a:r>
+          </a:p>
+        </p:txBody>
+      </p:sp>
+      <p:sp>
+        <p:nvSpPr>
+          <p:cNvPr id="89" name="Rectangle 88"/>
+          <p:cNvSpPr/>
+          <p:nvPr/>
+        </p:nvSpPr>
+        <p:spPr>
+          <a:xfrm>
+            <a:off x="5373319" y="2103120"/>
+            <a:ext cx="1352169" cy="914400"/>
+          </a:xfrm>
+          <a:prstGeom prst="rect">
             <a:avLst/>
           </a:prstGeom>
           <a:solidFill>
-            <a:srgbClr val="FFFFFF"/>
+            <a:srgbClr val="DD784B"/>
           </a:solidFill>
           <a:ln>
             <a:noFill/>
@@ -19137,53 +19172,18 @@
           </a:fontRef>
         </p:style>
         <p:txBody>
-          <a:bodyPr rtlCol="0" anchor="ctr" lIns="0" rIns="0" tIns="0" bIns="0" wrap="none"/>
+          <a:bodyPr rtlCol="0" anchor="ctr" lIns="45720" rIns="45720" tIns="0" bIns="0" wrap="square"/>
           <a:lstStyle/>
           <a:p>
             <a:pPr algn="ctr"/>
             <a:r>
-              <a:rPr sz="900">
-                <a:solidFill>
-                  <a:srgbClr val="3D68EC"/>
+              <a:rPr sz="1800">
+                <a:solidFill>
+                  <a:srgbClr val="000000"/>
                 </a:solidFill>
                 <a:latin typeface="General Sans Semibold"/>
               </a:rPr>
-              <a:t>/workshop-verkennen</a:t>
-            </a:r>
-          </a:p>
-        </p:txBody>
-      </p:sp>
-      <p:sp>
-        <p:nvSpPr>
-          <p:cNvPr id="89" name="TextBox 88"/>
-          <p:cNvSpPr txBox="1"/>
-          <p:nvPr/>
-        </p:nvSpPr>
-        <p:spPr>
-          <a:xfrm>
-            <a:off x="5373319" y="1719072"/>
-            <a:ext cx="914400" cy="274320"/>
-          </a:xfrm>
-          <a:prstGeom prst="rect">
-            <a:avLst/>
-          </a:prstGeom>
-          <a:noFill/>
-        </p:spPr>
-        <p:txBody>
-          <a:bodyPr wrap="square" lIns="0" rIns="0" tIns="0" bIns="0" anchor="t">
-            <a:spAutoFit/>
-          </a:bodyPr>
-          <a:lstStyle/>
-          <a:p>
-            <a:pPr algn="l"/>
-            <a:r>
-              <a:rPr sz="1400">
-                <a:solidFill>
-                  <a:srgbClr val="3D68EC"/>
-                </a:solidFill>
-                <a:latin typeface="General Sans Semibold"/>
-              </a:rPr>
-              <a:t>0:52</a:t>
+              <a:t>15 min</a:t>
             </a:r>
           </a:p>
         </p:txBody>
@@ -19196,8 +19196,8 @@
         </p:nvSpPr>
         <p:spPr>
           <a:xfrm>
-            <a:off x="5373319" y="2103120"/>
-            <a:ext cx="1352169" cy="914400"/>
+            <a:off x="5373319" y="3017520"/>
+            <a:ext cx="1352169" cy="45720"/>
           </a:xfrm>
           <a:prstGeom prst="rect">
             <a:avLst/>
@@ -19225,38 +19225,99 @@
           </a:fontRef>
         </p:style>
         <p:txBody>
-          <a:bodyPr rtlCol="0" anchor="ctr" lIns="45720" rIns="45720" tIns="0" bIns="0" wrap="square"/>
+          <a:bodyPr rtlCol="0" anchor="ctr"/>
           <a:lstStyle/>
           <a:p>
             <a:pPr algn="ctr"/>
-            <a:r>
-              <a:rPr sz="1800">
+          </a:p>
+        </p:txBody>
+      </p:sp>
+      <p:sp>
+        <p:nvSpPr>
+          <p:cNvPr id="91" name="TextBox 90"/>
+          <p:cNvSpPr txBox="1"/>
+          <p:nvPr/>
+        </p:nvSpPr>
+        <p:spPr>
+          <a:xfrm>
+            <a:off x="5391607" y="3291839"/>
+            <a:ext cx="1260729" cy="731520"/>
+          </a:xfrm>
+          <a:prstGeom prst="rect">
+            <a:avLst/>
+          </a:prstGeom>
+          <a:noFill/>
+        </p:spPr>
+        <p:txBody>
+          <a:bodyPr wrap="square" lIns="0" rIns="0" tIns="0" bIns="0" anchor="t">
+            <a:spAutoFit/>
+          </a:bodyPr>
+          <a:lstStyle/>
+          <a:p>
+            <a:pPr algn="l"/>
+            <a:r>
+              <a:rPr sz="1100">
                 <a:solidFill>
                   <a:srgbClr val="000000"/>
                 </a:solidFill>
                 <a:latin typeface="General Sans Semibold"/>
               </a:rPr>
-              <a:t>15 min</a:t>
-            </a:r>
-          </a:p>
-        </p:txBody>
-      </p:sp>
-      <p:sp>
-        <p:nvSpPr>
-          <p:cNvPr id="91" name="Rectangle 90"/>
-          <p:cNvSpPr/>
-          <p:nvPr/>
-        </p:nvSpPr>
-        <p:spPr>
-          <a:xfrm>
-            <a:off x="5373319" y="3017520"/>
-            <a:ext cx="1352169" cy="45720"/>
-          </a:xfrm>
-          <a:prstGeom prst="rect">
+              <a:t>Spiegelmoment 1</a:t>
+            </a:r>
+          </a:p>
+        </p:txBody>
+      </p:sp>
+      <p:sp>
+        <p:nvSpPr>
+          <p:cNvPr id="92" name="TextBox 91"/>
+          <p:cNvSpPr txBox="1"/>
+          <p:nvPr/>
+        </p:nvSpPr>
+        <p:spPr>
+          <a:xfrm>
+            <a:off x="5391607" y="4160520"/>
+            <a:ext cx="1260729" cy="822960"/>
+          </a:xfrm>
+          <a:prstGeom prst="rect">
+            <a:avLst/>
+          </a:prstGeom>
+          <a:noFill/>
+        </p:spPr>
+        <p:txBody>
+          <a:bodyPr wrap="square" lIns="0" rIns="0" tIns="0" bIns="0" anchor="t">
+            <a:spAutoFit/>
+          </a:bodyPr>
+          <a:lstStyle/>
+          <a:p>
+            <a:pPr algn="l"/>
+            <a:r>
+              <a:rPr sz="1200">
+                <a:solidFill>
+                  <a:srgbClr val="000000"/>
+                </a:solidFill>
+                <a:latin typeface="General Sans"/>
+              </a:rPr>
+              <a:t>Skill live: kijk wat erin zit</a:t>
+            </a:r>
+          </a:p>
+        </p:txBody>
+      </p:sp>
+      <p:sp>
+        <p:nvSpPr>
+          <p:cNvPr id="93" name="Rounded Rectangle 92"/>
+          <p:cNvSpPr/>
+          <p:nvPr/>
+        </p:nvSpPr>
+        <p:spPr>
+          <a:xfrm>
+            <a:off x="5391607" y="5029200"/>
+            <a:ext cx="1315593" cy="310896"/>
+          </a:xfrm>
+          <a:prstGeom prst="roundRect">
             <a:avLst/>
           </a:prstGeom>
           <a:solidFill>
-            <a:srgbClr val="DD784B"/>
+            <a:srgbClr val="FFFFFF"/>
           </a:solidFill>
           <a:ln>
             <a:noFill/>
@@ -19278,23 +19339,32 @@
           </a:fontRef>
         </p:style>
         <p:txBody>
-          <a:bodyPr rtlCol="0" anchor="ctr"/>
+          <a:bodyPr rtlCol="0" anchor="ctr" lIns="0" rIns="0" tIns="0" bIns="0" wrap="none"/>
           <a:lstStyle/>
           <a:p>
             <a:pPr algn="ctr"/>
-          </a:p>
-        </p:txBody>
-      </p:sp>
-      <p:sp>
-        <p:nvSpPr>
-          <p:cNvPr id="92" name="TextBox 91"/>
+            <a:r>
+              <a:rPr sz="900">
+                <a:solidFill>
+                  <a:srgbClr val="3D68EC"/>
+                </a:solidFill>
+                <a:latin typeface="General Sans Semibold"/>
+              </a:rPr>
+              <a:t>/workshop-verkennen</a:t>
+            </a:r>
+          </a:p>
+        </p:txBody>
+      </p:sp>
+      <p:sp>
+        <p:nvSpPr>
+          <p:cNvPr id="94" name="TextBox 93"/>
           <p:cNvSpPr txBox="1"/>
           <p:nvPr/>
         </p:nvSpPr>
         <p:spPr>
           <a:xfrm>
-            <a:off x="5391607" y="3291839"/>
-            <a:ext cx="1260729" cy="731520"/>
+            <a:off x="6771208" y="1719072"/>
+            <a:ext cx="914400" cy="274320"/>
           </a:xfrm>
           <a:prstGeom prst="rect">
             <a:avLst/>
@@ -19309,68 +19379,33 @@
           <a:p>
             <a:pPr algn="l"/>
             <a:r>
-              <a:rPr sz="1100">
-                <a:solidFill>
-                  <a:srgbClr val="000000"/>
+              <a:rPr sz="1400">
+                <a:solidFill>
+                  <a:srgbClr val="3D68EC"/>
                 </a:solidFill>
                 <a:latin typeface="General Sans Semibold"/>
               </a:rPr>
-              <a:t>Spiegelmoment 1</a:t>
-            </a:r>
-          </a:p>
-        </p:txBody>
-      </p:sp>
-      <p:sp>
-        <p:nvSpPr>
-          <p:cNvPr id="93" name="TextBox 92"/>
-          <p:cNvSpPr txBox="1"/>
-          <p:nvPr/>
-        </p:nvSpPr>
-        <p:spPr>
-          <a:xfrm>
-            <a:off x="5391607" y="4160520"/>
-            <a:ext cx="1260729" cy="822960"/>
-          </a:xfrm>
-          <a:prstGeom prst="rect">
-            <a:avLst/>
-          </a:prstGeom>
-          <a:noFill/>
-        </p:spPr>
-        <p:txBody>
-          <a:bodyPr wrap="square" lIns="0" rIns="0" tIns="0" bIns="0" anchor="t">
-            <a:spAutoFit/>
-          </a:bodyPr>
-          <a:lstStyle/>
-          <a:p>
-            <a:pPr algn="l"/>
-            <a:r>
-              <a:rPr sz="1200">
-                <a:solidFill>
-                  <a:srgbClr val="000000"/>
-                </a:solidFill>
-                <a:latin typeface="General Sans"/>
-              </a:rPr>
-              <a:t>Kijk in de skill</a:t>
-            </a:r>
-          </a:p>
-        </p:txBody>
-      </p:sp>
-      <p:sp>
-        <p:nvSpPr>
-          <p:cNvPr id="94" name="Rounded Rectangle 93"/>
-          <p:cNvSpPr/>
-          <p:nvPr/>
-        </p:nvSpPr>
-        <p:spPr>
-          <a:xfrm>
-            <a:off x="5391607" y="5029200"/>
-            <a:ext cx="1315593" cy="310896"/>
-          </a:xfrm>
-          <a:prstGeom prst="roundRect">
+              <a:t>1:07</a:t>
+            </a:r>
+          </a:p>
+        </p:txBody>
+      </p:sp>
+      <p:sp>
+        <p:nvSpPr>
+          <p:cNvPr id="95" name="Rectangle 94"/>
+          <p:cNvSpPr/>
+          <p:nvPr/>
+        </p:nvSpPr>
+        <p:spPr>
+          <a:xfrm>
+            <a:off x="6771208" y="2103120"/>
+            <a:ext cx="1983181" cy="914400"/>
+          </a:xfrm>
+          <a:prstGeom prst="rect">
             <a:avLst/>
           </a:prstGeom>
           <a:solidFill>
-            <a:srgbClr val="FFFFFF"/>
+            <a:srgbClr val="3D68EC"/>
           </a:solidFill>
           <a:ln>
             <a:noFill/>
@@ -19392,53 +19427,18 @@
           </a:fontRef>
         </p:style>
         <p:txBody>
-          <a:bodyPr rtlCol="0" anchor="ctr" lIns="0" rIns="0" tIns="0" bIns="0" wrap="none"/>
+          <a:bodyPr rtlCol="0" anchor="ctr" lIns="45720" rIns="45720" tIns="0" bIns="0" wrap="square"/>
           <a:lstStyle/>
           <a:p>
             <a:pPr algn="ctr"/>
             <a:r>
-              <a:rPr sz="900">
-                <a:solidFill>
-                  <a:srgbClr val="3D68EC"/>
+              <a:rPr sz="1800">
+                <a:solidFill>
+                  <a:srgbClr val="FFFFFF"/>
                 </a:solidFill>
                 <a:latin typeface="General Sans Semibold"/>
               </a:rPr>
-              <a:t>/workshop-verkennen</a:t>
-            </a:r>
-          </a:p>
-        </p:txBody>
-      </p:sp>
-      <p:sp>
-        <p:nvSpPr>
-          <p:cNvPr id="95" name="TextBox 94"/>
-          <p:cNvSpPr txBox="1"/>
-          <p:nvPr/>
-        </p:nvSpPr>
-        <p:spPr>
-          <a:xfrm>
-            <a:off x="6771208" y="1719072"/>
-            <a:ext cx="914400" cy="274320"/>
-          </a:xfrm>
-          <a:prstGeom prst="rect">
-            <a:avLst/>
-          </a:prstGeom>
-          <a:noFill/>
-        </p:spPr>
-        <p:txBody>
-          <a:bodyPr wrap="square" lIns="0" rIns="0" tIns="0" bIns="0" anchor="t">
-            <a:spAutoFit/>
-          </a:bodyPr>
-          <a:lstStyle/>
-          <a:p>
-            <a:pPr algn="l"/>
-            <a:r>
-              <a:rPr sz="1400">
-                <a:solidFill>
-                  <a:srgbClr val="3D68EC"/>
-                </a:solidFill>
-                <a:latin typeface="General Sans Semibold"/>
-              </a:rPr>
-              <a:t>1:07</a:t>
+              <a:t>22 min</a:t>
             </a:r>
           </a:p>
         </p:txBody>
@@ -19451,8 +19451,8 @@
         </p:nvSpPr>
         <p:spPr>
           <a:xfrm>
-            <a:off x="6771208" y="2103120"/>
-            <a:ext cx="1983181" cy="914400"/>
+            <a:off x="6771208" y="3017520"/>
+            <a:ext cx="1983181" cy="45720"/>
           </a:xfrm>
           <a:prstGeom prst="rect">
             <a:avLst/>
@@ -19480,38 +19480,134 @@
           </a:fontRef>
         </p:style>
         <p:txBody>
-          <a:bodyPr rtlCol="0" anchor="ctr" lIns="45720" rIns="45720" tIns="0" bIns="0" wrap="square"/>
+          <a:bodyPr rtlCol="0" anchor="ctr"/>
           <a:lstStyle/>
           <a:p>
             <a:pPr algn="ctr"/>
-            <a:r>
-              <a:rPr sz="1800">
-                <a:solidFill>
-                  <a:srgbClr val="FFFFFF"/>
+          </a:p>
+        </p:txBody>
+      </p:sp>
+      <p:sp>
+        <p:nvSpPr>
+          <p:cNvPr id="97" name="TextBox 96"/>
+          <p:cNvSpPr txBox="1"/>
+          <p:nvPr/>
+        </p:nvSpPr>
+        <p:spPr>
+          <a:xfrm>
+            <a:off x="6789496" y="3291839"/>
+            <a:ext cx="1891741" cy="731520"/>
+          </a:xfrm>
+          <a:prstGeom prst="rect">
+            <a:avLst/>
+          </a:prstGeom>
+          <a:noFill/>
+        </p:spPr>
+        <p:txBody>
+          <a:bodyPr wrap="square" lIns="0" rIns="0" tIns="0" bIns="0" anchor="t">
+            <a:spAutoFit/>
+          </a:bodyPr>
+          <a:lstStyle/>
+          <a:p>
+            <a:pPr algn="l"/>
+            <a:r>
+              <a:rPr sz="1100">
+                <a:solidFill>
+                  <a:srgbClr val="000000"/>
                 </a:solidFill>
                 <a:latin typeface="General Sans Semibold"/>
               </a:rPr>
-              <a:t>22 min</a:t>
-            </a:r>
-          </a:p>
-        </p:txBody>
-      </p:sp>
-      <p:sp>
-        <p:nvSpPr>
-          <p:cNvPr id="97" name="Rectangle 96"/>
-          <p:cNvSpPr/>
-          <p:nvPr/>
-        </p:nvSpPr>
-        <p:spPr>
-          <a:xfrm>
-            <a:off x="6771208" y="3017520"/>
-            <a:ext cx="1983181" cy="45720"/>
+              <a:t>Ronde 2: dashboard bouwen</a:t>
+            </a:r>
+          </a:p>
+        </p:txBody>
+      </p:sp>
+      <p:sp>
+        <p:nvSpPr>
+          <p:cNvPr id="98" name="TextBox 97"/>
+          <p:cNvSpPr txBox="1"/>
+          <p:nvPr/>
+        </p:nvSpPr>
+        <p:spPr>
+          <a:xfrm>
+            <a:off x="6789496" y="4160520"/>
+            <a:ext cx="1891741" cy="822960"/>
+          </a:xfrm>
+          <a:prstGeom prst="rect">
+            <a:avLst/>
+          </a:prstGeom>
+          <a:noFill/>
+        </p:spPr>
+        <p:txBody>
+          <a:bodyPr wrap="square" lIns="0" rIns="0" tIns="0" bIns="0" anchor="t">
+            <a:spAutoFit/>
+          </a:bodyPr>
+          <a:lstStyle/>
+          <a:p>
+            <a:pPr algn="l"/>
+            <a:r>
+              <a:rPr sz="1200">
+                <a:solidFill>
+                  <a:srgbClr val="000000"/>
+                </a:solidFill>
+                <a:latin typeface="General Sans"/>
+              </a:rPr>
+              <a:t>Jullie prompten zelf, andere rol</a:t>
+            </a:r>
+          </a:p>
+        </p:txBody>
+      </p:sp>
+      <p:sp>
+        <p:nvSpPr>
+          <p:cNvPr id="99" name="TextBox 98"/>
+          <p:cNvSpPr txBox="1"/>
+          <p:nvPr/>
+        </p:nvSpPr>
+        <p:spPr>
+          <a:xfrm>
+            <a:off x="8800109" y="1719072"/>
+            <a:ext cx="914400" cy="274320"/>
+          </a:xfrm>
+          <a:prstGeom prst="rect">
+            <a:avLst/>
+          </a:prstGeom>
+          <a:noFill/>
+        </p:spPr>
+        <p:txBody>
+          <a:bodyPr wrap="square" lIns="0" rIns="0" tIns="0" bIns="0" anchor="t">
+            <a:spAutoFit/>
+          </a:bodyPr>
+          <a:lstStyle/>
+          <a:p>
+            <a:pPr algn="l"/>
+            <a:r>
+              <a:rPr sz="1400">
+                <a:solidFill>
+                  <a:srgbClr val="3D68EC"/>
+                </a:solidFill>
+                <a:latin typeface="General Sans Semibold"/>
+              </a:rPr>
+              <a:t>1:29</a:t>
+            </a:r>
+          </a:p>
+        </p:txBody>
+      </p:sp>
+      <p:sp>
+        <p:nvSpPr>
+          <p:cNvPr id="100" name="Rectangle 99"/>
+          <p:cNvSpPr/>
+          <p:nvPr/>
+        </p:nvSpPr>
+        <p:spPr>
+          <a:xfrm>
+            <a:off x="8800109" y="2103120"/>
+            <a:ext cx="1352169" cy="914400"/>
           </a:xfrm>
           <a:prstGeom prst="rect">
             <a:avLst/>
           </a:prstGeom>
           <a:solidFill>
-            <a:srgbClr val="3D68EC"/>
+            <a:srgbClr val="DD784B"/>
           </a:solidFill>
           <a:ln>
             <a:noFill/>
@@ -19533,99 +19629,38 @@
           </a:fontRef>
         </p:style>
         <p:txBody>
-          <a:bodyPr rtlCol="0" anchor="ctr"/>
+          <a:bodyPr rtlCol="0" anchor="ctr" lIns="45720" rIns="45720" tIns="0" bIns="0" wrap="square"/>
           <a:lstStyle/>
           <a:p>
             <a:pPr algn="ctr"/>
-          </a:p>
-        </p:txBody>
-      </p:sp>
-      <p:sp>
-        <p:nvSpPr>
-          <p:cNvPr id="98" name="TextBox 97"/>
-          <p:cNvSpPr txBox="1"/>
-          <p:nvPr/>
-        </p:nvSpPr>
-        <p:spPr>
-          <a:xfrm>
-            <a:off x="6789496" y="3291839"/>
-            <a:ext cx="1891741" cy="731520"/>
-          </a:xfrm>
-          <a:prstGeom prst="rect">
-            <a:avLst/>
-          </a:prstGeom>
-          <a:noFill/>
-        </p:spPr>
-        <p:txBody>
-          <a:bodyPr wrap="square" lIns="0" rIns="0" tIns="0" bIns="0" anchor="t">
-            <a:spAutoFit/>
-          </a:bodyPr>
-          <a:lstStyle/>
-          <a:p>
-            <a:pPr algn="l"/>
-            <a:r>
-              <a:rPr sz="1100">
+            <a:r>
+              <a:rPr sz="1800">
                 <a:solidFill>
                   <a:srgbClr val="000000"/>
                 </a:solidFill>
                 <a:latin typeface="General Sans Semibold"/>
               </a:rPr>
-              <a:t>Ronde 2: dashboard bouwen</a:t>
-            </a:r>
-          </a:p>
-        </p:txBody>
-      </p:sp>
-      <p:sp>
-        <p:nvSpPr>
-          <p:cNvPr id="99" name="TextBox 98"/>
-          <p:cNvSpPr txBox="1"/>
-          <p:nvPr/>
-        </p:nvSpPr>
-        <p:spPr>
-          <a:xfrm>
-            <a:off x="6789496" y="4160520"/>
-            <a:ext cx="1891741" cy="822960"/>
-          </a:xfrm>
-          <a:prstGeom prst="rect">
-            <a:avLst/>
-          </a:prstGeom>
-          <a:noFill/>
-        </p:spPr>
-        <p:txBody>
-          <a:bodyPr wrap="square" lIns="0" rIns="0" tIns="0" bIns="0" anchor="t">
-            <a:spAutoFit/>
-          </a:bodyPr>
-          <a:lstStyle/>
-          <a:p>
-            <a:pPr algn="l"/>
-            <a:r>
-              <a:rPr sz="1200">
-                <a:solidFill>
-                  <a:srgbClr val="000000"/>
-                </a:solidFill>
-                <a:latin typeface="General Sans"/>
-              </a:rPr>
-              <a:t>Wissel van rol</a:t>
-            </a:r>
-          </a:p>
-        </p:txBody>
-      </p:sp>
-      <p:sp>
-        <p:nvSpPr>
-          <p:cNvPr id="100" name="Rounded Rectangle 99"/>
-          <p:cNvSpPr/>
-          <p:nvPr/>
-        </p:nvSpPr>
-        <p:spPr>
-          <a:xfrm>
-            <a:off x="6789496" y="5029200"/>
-            <a:ext cx="1946605" cy="310896"/>
-          </a:xfrm>
-          <a:prstGeom prst="roundRect">
+              <a:t>15 min</a:t>
+            </a:r>
+          </a:p>
+        </p:txBody>
+      </p:sp>
+      <p:sp>
+        <p:nvSpPr>
+          <p:cNvPr id="101" name="Rectangle 100"/>
+          <p:cNvSpPr/>
+          <p:nvPr/>
+        </p:nvSpPr>
+        <p:spPr>
+          <a:xfrm>
+            <a:off x="8800109" y="3017520"/>
+            <a:ext cx="1352169" cy="45720"/>
+          </a:xfrm>
+          <a:prstGeom prst="rect">
             <a:avLst/>
           </a:prstGeom>
           <a:solidFill>
-            <a:srgbClr val="FFFFFF"/>
+            <a:srgbClr val="DD784B"/>
           </a:solidFill>
           <a:ln>
             <a:noFill/>
@@ -19647,32 +19682,23 @@
           </a:fontRef>
         </p:style>
         <p:txBody>
-          <a:bodyPr rtlCol="0" anchor="ctr" lIns="0" rIns="0" tIns="0" bIns="0" wrap="none"/>
+          <a:bodyPr rtlCol="0" anchor="ctr"/>
           <a:lstStyle/>
           <a:p>
             <a:pPr algn="ctr"/>
-            <a:r>
-              <a:rPr sz="900">
-                <a:solidFill>
-                  <a:srgbClr val="3D68EC"/>
-                </a:solidFill>
-                <a:latin typeface="General Sans Semibold"/>
-              </a:rPr>
-              <a:t>/workshop-dashboard</a:t>
-            </a:r>
-          </a:p>
-        </p:txBody>
-      </p:sp>
-      <p:sp>
-        <p:nvSpPr>
-          <p:cNvPr id="101" name="TextBox 100"/>
+          </a:p>
+        </p:txBody>
+      </p:sp>
+      <p:sp>
+        <p:nvSpPr>
+          <p:cNvPr id="102" name="TextBox 101"/>
           <p:cNvSpPr txBox="1"/>
           <p:nvPr/>
         </p:nvSpPr>
         <p:spPr>
           <a:xfrm>
-            <a:off x="8800109" y="1719072"/>
-            <a:ext cx="914400" cy="274320"/>
+            <a:off x="8818397" y="3291839"/>
+            <a:ext cx="1260729" cy="731520"/>
           </a:xfrm>
           <a:prstGeom prst="rect">
             <a:avLst/>
@@ -19687,33 +19713,68 @@
           <a:p>
             <a:pPr algn="l"/>
             <a:r>
-              <a:rPr sz="1400">
-                <a:solidFill>
-                  <a:srgbClr val="3D68EC"/>
+              <a:rPr sz="1100">
+                <a:solidFill>
+                  <a:srgbClr val="000000"/>
                 </a:solidFill>
                 <a:latin typeface="General Sans Semibold"/>
               </a:rPr>
-              <a:t>1:29</a:t>
-            </a:r>
-          </a:p>
-        </p:txBody>
-      </p:sp>
-      <p:sp>
-        <p:nvSpPr>
-          <p:cNvPr id="102" name="Rectangle 101"/>
-          <p:cNvSpPr/>
-          <p:nvPr/>
-        </p:nvSpPr>
-        <p:spPr>
-          <a:xfrm>
-            <a:off x="8800109" y="2103120"/>
-            <a:ext cx="1352169" cy="914400"/>
-          </a:xfrm>
-          <a:prstGeom prst="rect">
+              <a:t>Spiegelmoment 2</a:t>
+            </a:r>
+          </a:p>
+        </p:txBody>
+      </p:sp>
+      <p:sp>
+        <p:nvSpPr>
+          <p:cNvPr id="103" name="TextBox 102"/>
+          <p:cNvSpPr txBox="1"/>
+          <p:nvPr/>
+        </p:nvSpPr>
+        <p:spPr>
+          <a:xfrm>
+            <a:off x="8818397" y="4160520"/>
+            <a:ext cx="1260729" cy="822960"/>
+          </a:xfrm>
+          <a:prstGeom prst="rect">
+            <a:avLst/>
+          </a:prstGeom>
+          <a:noFill/>
+        </p:spPr>
+        <p:txBody>
+          <a:bodyPr wrap="square" lIns="0" rIns="0" tIns="0" bIns="0" anchor="t">
+            <a:spAutoFit/>
+          </a:bodyPr>
+          <a:lstStyle/>
+          <a:p>
+            <a:pPr algn="l"/>
+            <a:r>
+              <a:rPr sz="1200">
+                <a:solidFill>
+                  <a:srgbClr val="000000"/>
+                </a:solidFill>
+                <a:latin typeface="General Sans"/>
+              </a:rPr>
+              <a:t>Skill live, daarna de onthulling</a:t>
+            </a:r>
+          </a:p>
+        </p:txBody>
+      </p:sp>
+      <p:sp>
+        <p:nvSpPr>
+          <p:cNvPr id="104" name="Rounded Rectangle 103"/>
+          <p:cNvSpPr/>
+          <p:nvPr/>
+        </p:nvSpPr>
+        <p:spPr>
+          <a:xfrm>
+            <a:off x="8818397" y="5029200"/>
+            <a:ext cx="1315593" cy="310896"/>
+          </a:xfrm>
+          <a:prstGeom prst="roundRect">
             <a:avLst/>
           </a:prstGeom>
           <a:solidFill>
-            <a:srgbClr val="DD784B"/>
+            <a:srgbClr val="FFFFFF"/>
           </a:solidFill>
           <a:ln>
             <a:noFill/>
@@ -19735,38 +19796,73 @@
           </a:fontRef>
         </p:style>
         <p:txBody>
-          <a:bodyPr rtlCol="0" anchor="ctr" lIns="45720" rIns="45720" tIns="0" bIns="0" wrap="square"/>
+          <a:bodyPr rtlCol="0" anchor="ctr" lIns="0" rIns="0" tIns="0" bIns="0" wrap="none"/>
           <a:lstStyle/>
           <a:p>
             <a:pPr algn="ctr"/>
             <a:r>
-              <a:rPr sz="1800">
-                <a:solidFill>
-                  <a:srgbClr val="000000"/>
+              <a:rPr sz="900">
+                <a:solidFill>
+                  <a:srgbClr val="3D68EC"/>
                 </a:solidFill>
                 <a:latin typeface="General Sans Semibold"/>
               </a:rPr>
-              <a:t>15 min</a:t>
-            </a:r>
-          </a:p>
-        </p:txBody>
-      </p:sp>
-      <p:sp>
-        <p:nvSpPr>
-          <p:cNvPr id="103" name="Rectangle 102"/>
-          <p:cNvSpPr/>
-          <p:nvPr/>
-        </p:nvSpPr>
-        <p:spPr>
-          <a:xfrm>
-            <a:off x="8800109" y="3017520"/>
-            <a:ext cx="1352169" cy="45720"/>
+              <a:t>/workshop-dashboard</a:t>
+            </a:r>
+          </a:p>
+        </p:txBody>
+      </p:sp>
+      <p:sp>
+        <p:nvSpPr>
+          <p:cNvPr id="105" name="TextBox 104"/>
+          <p:cNvSpPr txBox="1"/>
+          <p:nvPr/>
+        </p:nvSpPr>
+        <p:spPr>
+          <a:xfrm>
+            <a:off x="10197998" y="1719072"/>
+            <a:ext cx="914400" cy="274320"/>
+          </a:xfrm>
+          <a:prstGeom prst="rect">
+            <a:avLst/>
+          </a:prstGeom>
+          <a:noFill/>
+        </p:spPr>
+        <p:txBody>
+          <a:bodyPr wrap="square" lIns="0" rIns="0" tIns="0" bIns="0" anchor="t">
+            <a:spAutoFit/>
+          </a:bodyPr>
+          <a:lstStyle/>
+          <a:p>
+            <a:pPr algn="l"/>
+            <a:r>
+              <a:rPr sz="1400">
+                <a:solidFill>
+                  <a:srgbClr val="3D68EC"/>
+                </a:solidFill>
+                <a:latin typeface="General Sans Semibold"/>
+              </a:rPr>
+              <a:t>1:44</a:t>
+            </a:r>
+          </a:p>
+        </p:txBody>
+      </p:sp>
+      <p:sp>
+        <p:nvSpPr>
+          <p:cNvPr id="106" name="Rectangle 105"/>
+          <p:cNvSpPr/>
+          <p:nvPr/>
+        </p:nvSpPr>
+        <p:spPr>
+          <a:xfrm>
+            <a:off x="10197998" y="2103120"/>
+            <a:ext cx="1442313" cy="914400"/>
           </a:xfrm>
           <a:prstGeom prst="rect">
             <a:avLst/>
           </a:prstGeom>
           <a:solidFill>
-            <a:srgbClr val="DD784B"/>
+            <a:srgbClr val="00AF81"/>
           </a:solidFill>
           <a:ln>
             <a:noFill/>
@@ -19788,99 +19884,38 @@
           </a:fontRef>
         </p:style>
         <p:txBody>
-          <a:bodyPr rtlCol="0" anchor="ctr"/>
+          <a:bodyPr rtlCol="0" anchor="ctr" lIns="45720" rIns="45720" tIns="0" bIns="0" wrap="square"/>
           <a:lstStyle/>
           <a:p>
             <a:pPr algn="ctr"/>
-          </a:p>
-        </p:txBody>
-      </p:sp>
-      <p:sp>
-        <p:nvSpPr>
-          <p:cNvPr id="104" name="TextBox 103"/>
-          <p:cNvSpPr txBox="1"/>
-          <p:nvPr/>
-        </p:nvSpPr>
-        <p:spPr>
-          <a:xfrm>
-            <a:off x="8818397" y="3291839"/>
-            <a:ext cx="1260729" cy="731520"/>
-          </a:xfrm>
-          <a:prstGeom prst="rect">
-            <a:avLst/>
-          </a:prstGeom>
-          <a:noFill/>
-        </p:spPr>
-        <p:txBody>
-          <a:bodyPr wrap="square" lIns="0" rIns="0" tIns="0" bIns="0" anchor="t">
-            <a:spAutoFit/>
-          </a:bodyPr>
-          <a:lstStyle/>
-          <a:p>
-            <a:pPr algn="l"/>
-            <a:r>
-              <a:rPr sz="1100">
-                <a:solidFill>
-                  <a:srgbClr val="000000"/>
+            <a:r>
+              <a:rPr sz="1800">
+                <a:solidFill>
+                  <a:srgbClr val="FFFFFF"/>
                 </a:solidFill>
                 <a:latin typeface="General Sans Semibold"/>
               </a:rPr>
-              <a:t>Spiegelmoment 2</a:t>
-            </a:r>
-          </a:p>
-        </p:txBody>
-      </p:sp>
-      <p:sp>
-        <p:nvSpPr>
-          <p:cNvPr id="105" name="TextBox 104"/>
-          <p:cNvSpPr txBox="1"/>
-          <p:nvPr/>
-        </p:nvSpPr>
-        <p:spPr>
-          <a:xfrm>
-            <a:off x="8818397" y="4160520"/>
-            <a:ext cx="1260729" cy="822960"/>
-          </a:xfrm>
-          <a:prstGeom prst="rect">
-            <a:avLst/>
-          </a:prstGeom>
-          <a:noFill/>
-        </p:spPr>
-        <p:txBody>
-          <a:bodyPr wrap="square" lIns="0" rIns="0" tIns="0" bIns="0" anchor="t">
-            <a:spAutoFit/>
-          </a:bodyPr>
-          <a:lstStyle/>
-          <a:p>
-            <a:pPr algn="l"/>
-            <a:r>
-              <a:rPr sz="1200">
-                <a:solidFill>
-                  <a:srgbClr val="000000"/>
-                </a:solidFill>
-                <a:latin typeface="General Sans"/>
-              </a:rPr>
-              <a:t>Kijk in de skill, onthulling</a:t>
-            </a:r>
-          </a:p>
-        </p:txBody>
-      </p:sp>
-      <p:sp>
-        <p:nvSpPr>
-          <p:cNvPr id="106" name="Rounded Rectangle 105"/>
-          <p:cNvSpPr/>
-          <p:nvPr/>
-        </p:nvSpPr>
-        <p:spPr>
-          <a:xfrm>
-            <a:off x="8818397" y="5029200"/>
-            <a:ext cx="1315593" cy="310896"/>
-          </a:xfrm>
-          <a:prstGeom prst="roundRect">
+              <a:t>16 min</a:t>
+            </a:r>
+          </a:p>
+        </p:txBody>
+      </p:sp>
+      <p:sp>
+        <p:nvSpPr>
+          <p:cNvPr id="107" name="Rectangle 106"/>
+          <p:cNvSpPr/>
+          <p:nvPr/>
+        </p:nvSpPr>
+        <p:spPr>
+          <a:xfrm>
+            <a:off x="10197998" y="3017520"/>
+            <a:ext cx="1442313" cy="45720"/>
+          </a:xfrm>
+          <a:prstGeom prst="rect">
             <a:avLst/>
           </a:prstGeom>
           <a:solidFill>
-            <a:srgbClr val="FFFFFF"/>
+            <a:srgbClr val="00AF81"/>
           </a:solidFill>
           <a:ln>
             <a:noFill/>
@@ -19902,32 +19937,23 @@
           </a:fontRef>
         </p:style>
         <p:txBody>
-          <a:bodyPr rtlCol="0" anchor="ctr" lIns="0" rIns="0" tIns="0" bIns="0" wrap="none"/>
+          <a:bodyPr rtlCol="0" anchor="ctr"/>
           <a:lstStyle/>
           <a:p>
             <a:pPr algn="ctr"/>
-            <a:r>
-              <a:rPr sz="900">
-                <a:solidFill>
-                  <a:srgbClr val="3D68EC"/>
-                </a:solidFill>
-                <a:latin typeface="General Sans Semibold"/>
-              </a:rPr>
-              <a:t>/workshop-dashboard</a:t>
-            </a:r>
-          </a:p>
-        </p:txBody>
-      </p:sp>
-      <p:sp>
-        <p:nvSpPr>
-          <p:cNvPr id="107" name="TextBox 106"/>
+          </a:p>
+        </p:txBody>
+      </p:sp>
+      <p:sp>
+        <p:nvSpPr>
+          <p:cNvPr id="108" name="TextBox 107"/>
           <p:cNvSpPr txBox="1"/>
           <p:nvPr/>
         </p:nvSpPr>
         <p:spPr>
           <a:xfrm>
-            <a:off x="10197998" y="1719072"/>
-            <a:ext cx="914400" cy="274320"/>
+            <a:off x="10216286" y="3291839"/>
+            <a:ext cx="1350873" cy="731520"/>
           </a:xfrm>
           <a:prstGeom prst="rect">
             <a:avLst/>
@@ -19942,33 +19968,68 @@
           <a:p>
             <a:pPr algn="l"/>
             <a:r>
-              <a:rPr sz="1400">
-                <a:solidFill>
-                  <a:srgbClr val="3D68EC"/>
+              <a:rPr sz="1100">
+                <a:solidFill>
+                  <a:srgbClr val="000000"/>
                 </a:solidFill>
                 <a:latin typeface="General Sans Semibold"/>
               </a:rPr>
-              <a:t>1:44</a:t>
-            </a:r>
-          </a:p>
-        </p:txBody>
-      </p:sp>
-      <p:sp>
-        <p:nvSpPr>
-          <p:cNvPr id="108" name="Rectangle 107"/>
-          <p:cNvSpPr/>
-          <p:nvPr/>
-        </p:nvSpPr>
-        <p:spPr>
-          <a:xfrm>
-            <a:off x="10197998" y="2103120"/>
-            <a:ext cx="1442313" cy="914400"/>
-          </a:xfrm>
-          <a:prstGeom prst="rect">
+              <a:t>Evaluatie en afsluiting</a:t>
+            </a:r>
+          </a:p>
+        </p:txBody>
+      </p:sp>
+      <p:sp>
+        <p:nvSpPr>
+          <p:cNvPr id="109" name="TextBox 108"/>
+          <p:cNvSpPr txBox="1"/>
+          <p:nvPr/>
+        </p:nvSpPr>
+        <p:spPr>
+          <a:xfrm>
+            <a:off x="10216286" y="4160520"/>
+            <a:ext cx="1350873" cy="822960"/>
+          </a:xfrm>
+          <a:prstGeom prst="rect">
+            <a:avLst/>
+          </a:prstGeom>
+          <a:noFill/>
+        </p:spPr>
+        <p:txBody>
+          <a:bodyPr wrap="square" lIns="0" rIns="0" tIns="0" bIns="0" anchor="t">
+            <a:spAutoFit/>
+          </a:bodyPr>
+          <a:lstStyle/>
+          <a:p>
+            <a:pPr algn="l"/>
+            <a:r>
+              <a:rPr sz="1200">
+                <a:solidFill>
+                  <a:srgbClr val="000000"/>
+                </a:solidFill>
+                <a:latin typeface="General Sans"/>
+              </a:rPr>
+              <a:t>Terugblik, peiling, rondje</a:t>
+            </a:r>
+          </a:p>
+        </p:txBody>
+      </p:sp>
+      <p:sp>
+        <p:nvSpPr>
+          <p:cNvPr id="110" name="Rounded Rectangle 109"/>
+          <p:cNvSpPr/>
+          <p:nvPr/>
+        </p:nvSpPr>
+        <p:spPr>
+          <a:xfrm>
+            <a:off x="10216286" y="5029200"/>
+            <a:ext cx="1405737" cy="310896"/>
+          </a:xfrm>
+          <a:prstGeom prst="roundRect">
             <a:avLst/>
           </a:prstGeom>
           <a:solidFill>
-            <a:srgbClr val="00AF81"/>
+            <a:srgbClr val="FFFFFF"/>
           </a:solidFill>
           <a:ln>
             <a:noFill/>
@@ -19990,38 +20051,73 @@
           </a:fontRef>
         </p:style>
         <p:txBody>
-          <a:bodyPr rtlCol="0" anchor="ctr" lIns="45720" rIns="45720" tIns="0" bIns="0" wrap="square"/>
+          <a:bodyPr rtlCol="0" anchor="ctr" lIns="0" rIns="0" tIns="0" bIns="0" wrap="none"/>
           <a:lstStyle/>
           <a:p>
             <a:pPr algn="ctr"/>
             <a:r>
-              <a:rPr sz="1800">
-                <a:solidFill>
-                  <a:srgbClr val="FFFFFF"/>
+              <a:rPr sz="900">
+                <a:solidFill>
+                  <a:srgbClr val="3D68EC"/>
                 </a:solidFill>
                 <a:latin typeface="General Sans Semibold"/>
               </a:rPr>
-              <a:t>16 min</a:t>
-            </a:r>
-          </a:p>
-        </p:txBody>
-      </p:sp>
-      <p:sp>
-        <p:nvSpPr>
-          <p:cNvPr id="109" name="Rectangle 108"/>
-          <p:cNvSpPr/>
-          <p:nvPr/>
-        </p:nvSpPr>
-        <p:spPr>
-          <a:xfrm>
-            <a:off x="10197998" y="3017520"/>
-            <a:ext cx="1442313" cy="45720"/>
+              <a:t>/workshop-reflectie</a:t>
+            </a:r>
+          </a:p>
+        </p:txBody>
+      </p:sp>
+      <p:sp>
+        <p:nvSpPr>
+          <p:cNvPr id="111" name="TextBox 110"/>
+          <p:cNvSpPr txBox="1"/>
+          <p:nvPr/>
+        </p:nvSpPr>
+        <p:spPr>
+          <a:xfrm>
+            <a:off x="10725912" y="1719072"/>
+            <a:ext cx="914400" cy="274320"/>
+          </a:xfrm>
+          <a:prstGeom prst="rect">
+            <a:avLst/>
+          </a:prstGeom>
+          <a:noFill/>
+        </p:spPr>
+        <p:txBody>
+          <a:bodyPr wrap="square" lIns="0" rIns="0" tIns="0" bIns="0" anchor="t">
+            <a:spAutoFit/>
+          </a:bodyPr>
+          <a:lstStyle/>
+          <a:p>
+            <a:pPr algn="r"/>
+            <a:r>
+              <a:rPr sz="1400">
+                <a:solidFill>
+                  <a:srgbClr val="3D68EC"/>
+                </a:solidFill>
+                <a:latin typeface="General Sans Semibold"/>
+              </a:rPr>
+              <a:t>2:00</a:t>
+            </a:r>
+          </a:p>
+        </p:txBody>
+      </p:sp>
+      <p:sp>
+        <p:nvSpPr>
+          <p:cNvPr id="112" name="Rectangle 111"/>
+          <p:cNvSpPr/>
+          <p:nvPr/>
+        </p:nvSpPr>
+        <p:spPr>
+          <a:xfrm>
+            <a:off x="548640" y="6025896"/>
+            <a:ext cx="201168" cy="201168"/>
           </a:xfrm>
           <a:prstGeom prst="rect">
             <a:avLst/>
           </a:prstGeom>
           <a:solidFill>
-            <a:srgbClr val="00AF81"/>
+            <a:srgbClr val="F4D74B"/>
           </a:solidFill>
           <a:ln>
             <a:noFill/>
@@ -20052,90 +20148,55 @@
       </p:sp>
       <p:sp>
         <p:nvSpPr>
-          <p:cNvPr id="110" name="TextBox 109"/>
+          <p:cNvPr id="113" name="TextBox 112"/>
           <p:cNvSpPr txBox="1"/>
           <p:nvPr/>
         </p:nvSpPr>
         <p:spPr>
           <a:xfrm>
-            <a:off x="10216286" y="3291839"/>
-            <a:ext cx="1350873" cy="731520"/>
-          </a:xfrm>
-          <a:prstGeom prst="rect">
-            <a:avLst/>
-          </a:prstGeom>
-          <a:noFill/>
-        </p:spPr>
-        <p:txBody>
-          <a:bodyPr wrap="square" lIns="0" rIns="0" tIns="0" bIns="0" anchor="t">
+            <a:off x="841247" y="5989320"/>
+            <a:ext cx="2194560" cy="274320"/>
+          </a:xfrm>
+          <a:prstGeom prst="rect">
+            <a:avLst/>
+          </a:prstGeom>
+          <a:noFill/>
+        </p:spPr>
+        <p:txBody>
+          <a:bodyPr wrap="square" lIns="0" rIns="0" tIns="0" bIns="0" anchor="ctr">
             <a:spAutoFit/>
           </a:bodyPr>
           <a:lstStyle/>
           <a:p>
             <a:pPr algn="l"/>
             <a:r>
-              <a:rPr sz="1100">
+              <a:rPr sz="1200">
                 <a:solidFill>
                   <a:srgbClr val="000000"/>
                 </a:solidFill>
-                <a:latin typeface="General Sans Semibold"/>
-              </a:rPr>
-              <a:t>Evaluatie en afsluiting</a:t>
-            </a:r>
-          </a:p>
-        </p:txBody>
-      </p:sp>
-      <p:sp>
-        <p:nvSpPr>
-          <p:cNvPr id="111" name="TextBox 110"/>
-          <p:cNvSpPr txBox="1"/>
-          <p:nvPr/>
-        </p:nvSpPr>
-        <p:spPr>
-          <a:xfrm>
-            <a:off x="10216286" y="4160520"/>
-            <a:ext cx="1350873" cy="822960"/>
-          </a:xfrm>
-          <a:prstGeom prst="rect">
-            <a:avLst/>
-          </a:prstGeom>
-          <a:noFill/>
-        </p:spPr>
-        <p:txBody>
-          <a:bodyPr wrap="square" lIns="0" rIns="0" tIns="0" bIns="0" anchor="t">
-            <a:spAutoFit/>
-          </a:bodyPr>
-          <a:lstStyle/>
-          <a:p>
-            <a:pPr algn="l"/>
-            <a:r>
-              <a:rPr sz="1200">
-                <a:solidFill>
-                  <a:srgbClr val="000000"/>
-                </a:solidFill>
                 <a:latin typeface="General Sans"/>
               </a:rPr>
-              <a:t>Terugblik, peiling, rondje</a:t>
-            </a:r>
-          </a:p>
-        </p:txBody>
-      </p:sp>
-      <p:sp>
-        <p:nvSpPr>
-          <p:cNvPr id="112" name="Rounded Rectangle 111"/>
-          <p:cNvSpPr/>
-          <p:nvPr/>
-        </p:nvSpPr>
-        <p:spPr>
-          <a:xfrm>
-            <a:off x="10216286" y="5029200"/>
-            <a:ext cx="1405737" cy="310896"/>
-          </a:xfrm>
-          <a:prstGeom prst="roundRect">
+              <a:t>Uitleg</a:t>
+            </a:r>
+          </a:p>
+        </p:txBody>
+      </p:sp>
+      <p:sp>
+        <p:nvSpPr>
+          <p:cNvPr id="114" name="Rectangle 113"/>
+          <p:cNvSpPr/>
+          <p:nvPr/>
+        </p:nvSpPr>
+        <p:spPr>
+          <a:xfrm>
+            <a:off x="1901952" y="6025896"/>
+            <a:ext cx="201168" cy="201168"/>
+          </a:xfrm>
+          <a:prstGeom prst="rect">
             <a:avLst/>
           </a:prstGeom>
           <a:solidFill>
-            <a:srgbClr val="FFFFFF"/>
+            <a:srgbClr val="3D68EC"/>
           </a:solidFill>
           <a:ln>
             <a:noFill/>
@@ -20157,73 +20218,64 @@
           </a:fontRef>
         </p:style>
         <p:txBody>
-          <a:bodyPr rtlCol="0" anchor="ctr" lIns="0" rIns="0" tIns="0" bIns="0" wrap="none"/>
+          <a:bodyPr rtlCol="0" anchor="ctr"/>
           <a:lstStyle/>
           <a:p>
             <a:pPr algn="ctr"/>
-            <a:r>
-              <a:rPr sz="900">
-                <a:solidFill>
-                  <a:srgbClr val="3D68EC"/>
-                </a:solidFill>
-                <a:latin typeface="General Sans Semibold"/>
-              </a:rPr>
-              <a:t>/workshop-reflectie</a:t>
-            </a:r>
-          </a:p>
-        </p:txBody>
-      </p:sp>
-      <p:sp>
-        <p:nvSpPr>
-          <p:cNvPr id="113" name="TextBox 112"/>
+          </a:p>
+        </p:txBody>
+      </p:sp>
+      <p:sp>
+        <p:nvSpPr>
+          <p:cNvPr id="115" name="TextBox 114"/>
           <p:cNvSpPr txBox="1"/>
           <p:nvPr/>
         </p:nvSpPr>
         <p:spPr>
           <a:xfrm>
-            <a:off x="10725912" y="1719072"/>
-            <a:ext cx="914400" cy="274320"/>
-          </a:xfrm>
-          <a:prstGeom prst="rect">
-            <a:avLst/>
-          </a:prstGeom>
-          <a:noFill/>
-        </p:spPr>
-        <p:txBody>
-          <a:bodyPr wrap="square" lIns="0" rIns="0" tIns="0" bIns="0" anchor="t">
+            <a:off x="2194560" y="5989320"/>
+            <a:ext cx="2194560" cy="274320"/>
+          </a:xfrm>
+          <a:prstGeom prst="rect">
+            <a:avLst/>
+          </a:prstGeom>
+          <a:noFill/>
+        </p:spPr>
+        <p:txBody>
+          <a:bodyPr wrap="square" lIns="0" rIns="0" tIns="0" bIns="0" anchor="ctr">
             <a:spAutoFit/>
           </a:bodyPr>
           <a:lstStyle/>
           <a:p>
-            <a:pPr algn="r"/>
-            <a:r>
-              <a:rPr sz="1400">
-                <a:solidFill>
-                  <a:srgbClr val="3D68EC"/>
-                </a:solidFill>
-                <a:latin typeface="General Sans Semibold"/>
-              </a:rPr>
-              <a:t>2:00</a:t>
-            </a:r>
-          </a:p>
-        </p:txBody>
-      </p:sp>
-      <p:sp>
-        <p:nvSpPr>
-          <p:cNvPr id="114" name="Rectangle 113"/>
-          <p:cNvSpPr/>
-          <p:nvPr/>
-        </p:nvSpPr>
-        <p:spPr>
-          <a:xfrm>
-            <a:off x="548640" y="6025896"/>
+            <a:pPr algn="l"/>
+            <a:r>
+              <a:rPr sz="1200">
+                <a:solidFill>
+                  <a:srgbClr val="000000"/>
+                </a:solidFill>
+                <a:latin typeface="General Sans"/>
+              </a:rPr>
+              <a:t>Werken in tweetallen</a:t>
+            </a:r>
+          </a:p>
+        </p:txBody>
+      </p:sp>
+      <p:sp>
+        <p:nvSpPr>
+          <p:cNvPr id="116" name="Rectangle 115"/>
+          <p:cNvSpPr/>
+          <p:nvPr/>
+        </p:nvSpPr>
+        <p:spPr>
+          <a:xfrm>
+            <a:off x="4663440" y="6025896"/>
             <a:ext cx="201168" cy="201168"/>
           </a:xfrm>
           <a:prstGeom prst="rect">
             <a:avLst/>
           </a:prstGeom>
           <a:solidFill>
-            <a:srgbClr val="F4D74B"/>
+            <a:srgbClr val="DD784B"/>
           </a:solidFill>
           <a:ln>
             <a:noFill/>
@@ -20254,13 +20306,13 @@
       </p:sp>
       <p:sp>
         <p:nvSpPr>
-          <p:cNvPr id="115" name="TextBox 114"/>
+          <p:cNvPr id="117" name="TextBox 116"/>
           <p:cNvSpPr txBox="1"/>
           <p:nvPr/>
         </p:nvSpPr>
         <p:spPr>
           <a:xfrm>
-            <a:off x="841247" y="5989320"/>
+            <a:off x="4956048" y="5989320"/>
             <a:ext cx="2194560" cy="274320"/>
           </a:xfrm>
           <a:prstGeom prst="rect">
@@ -20282,27 +20334,27 @@
                 </a:solidFill>
                 <a:latin typeface="General Sans"/>
               </a:rPr>
-              <a:t>Uitleg</a:t>
-            </a:r>
-          </a:p>
-        </p:txBody>
-      </p:sp>
-      <p:sp>
-        <p:nvSpPr>
-          <p:cNvPr id="116" name="Rectangle 115"/>
-          <p:cNvSpPr/>
-          <p:nvPr/>
-        </p:nvSpPr>
-        <p:spPr>
-          <a:xfrm>
-            <a:off x="1901952" y="6025896"/>
+              <a:t>Spiegelmoment</a:t>
+            </a:r>
+          </a:p>
+        </p:txBody>
+      </p:sp>
+      <p:sp>
+        <p:nvSpPr>
+          <p:cNvPr id="118" name="Rectangle 117"/>
+          <p:cNvSpPr/>
+          <p:nvPr/>
+        </p:nvSpPr>
+        <p:spPr>
+          <a:xfrm>
+            <a:off x="6720840" y="6025896"/>
             <a:ext cx="201168" cy="201168"/>
           </a:xfrm>
           <a:prstGeom prst="rect">
             <a:avLst/>
           </a:prstGeom>
           <a:solidFill>
-            <a:srgbClr val="3D68EC"/>
+            <a:srgbClr val="00AF81"/>
           </a:solidFill>
           <a:ln>
             <a:noFill/>
@@ -20333,13 +20385,13 @@
       </p:sp>
       <p:sp>
         <p:nvSpPr>
-          <p:cNvPr id="117" name="TextBox 116"/>
+          <p:cNvPr id="119" name="TextBox 118"/>
           <p:cNvSpPr txBox="1"/>
           <p:nvPr/>
         </p:nvSpPr>
         <p:spPr>
           <a:xfrm>
-            <a:off x="2194560" y="5989320"/>
+            <a:off x="7013448" y="5989320"/>
             <a:ext cx="2194560" cy="274320"/>
           </a:xfrm>
           <a:prstGeom prst="rect">
@@ -20361,164 +20413,6 @@
                 </a:solidFill>
                 <a:latin typeface="General Sans"/>
               </a:rPr>
-              <a:t>Werken in tweetallen</a:t>
-            </a:r>
-          </a:p>
-        </p:txBody>
-      </p:sp>
-      <p:sp>
-        <p:nvSpPr>
-          <p:cNvPr id="118" name="Rectangle 117"/>
-          <p:cNvSpPr/>
-          <p:nvPr/>
-        </p:nvSpPr>
-        <p:spPr>
-          <a:xfrm>
-            <a:off x="4663440" y="6025896"/>
-            <a:ext cx="201168" cy="201168"/>
-          </a:xfrm>
-          <a:prstGeom prst="rect">
-            <a:avLst/>
-          </a:prstGeom>
-          <a:solidFill>
-            <a:srgbClr val="DD784B"/>
-          </a:solidFill>
-          <a:ln>
-            <a:noFill/>
-          </a:ln>
-          <a:effectLst/>
-        </p:spPr>
-        <p:style>
-          <a:lnRef idx="1">
-            <a:schemeClr val="accent1"/>
-          </a:lnRef>
-          <a:fillRef idx="3">
-            <a:schemeClr val="accent1"/>
-          </a:fillRef>
-          <a:effectRef idx="2">
-            <a:schemeClr val="accent1"/>
-          </a:effectRef>
-          <a:fontRef idx="minor">
-            <a:schemeClr val="lt1"/>
-          </a:fontRef>
-        </p:style>
-        <p:txBody>
-          <a:bodyPr rtlCol="0" anchor="ctr"/>
-          <a:lstStyle/>
-          <a:p>
-            <a:pPr algn="ctr"/>
-          </a:p>
-        </p:txBody>
-      </p:sp>
-      <p:sp>
-        <p:nvSpPr>
-          <p:cNvPr id="119" name="TextBox 118"/>
-          <p:cNvSpPr txBox="1"/>
-          <p:nvPr/>
-        </p:nvSpPr>
-        <p:spPr>
-          <a:xfrm>
-            <a:off x="4956048" y="5989320"/>
-            <a:ext cx="2194560" cy="274320"/>
-          </a:xfrm>
-          <a:prstGeom prst="rect">
-            <a:avLst/>
-          </a:prstGeom>
-          <a:noFill/>
-        </p:spPr>
-        <p:txBody>
-          <a:bodyPr wrap="square" lIns="0" rIns="0" tIns="0" bIns="0" anchor="ctr">
-            <a:spAutoFit/>
-          </a:bodyPr>
-          <a:lstStyle/>
-          <a:p>
-            <a:pPr algn="l"/>
-            <a:r>
-              <a:rPr sz="1200">
-                <a:solidFill>
-                  <a:srgbClr val="000000"/>
-                </a:solidFill>
-                <a:latin typeface="General Sans"/>
-              </a:rPr>
-              <a:t>Spiegelmoment</a:t>
-            </a:r>
-          </a:p>
-        </p:txBody>
-      </p:sp>
-      <p:sp>
-        <p:nvSpPr>
-          <p:cNvPr id="120" name="Rectangle 119"/>
-          <p:cNvSpPr/>
-          <p:nvPr/>
-        </p:nvSpPr>
-        <p:spPr>
-          <a:xfrm>
-            <a:off x="6720840" y="6025896"/>
-            <a:ext cx="201168" cy="201168"/>
-          </a:xfrm>
-          <a:prstGeom prst="rect">
-            <a:avLst/>
-          </a:prstGeom>
-          <a:solidFill>
-            <a:srgbClr val="00AF81"/>
-          </a:solidFill>
-          <a:ln>
-            <a:noFill/>
-          </a:ln>
-          <a:effectLst/>
-        </p:spPr>
-        <p:style>
-          <a:lnRef idx="1">
-            <a:schemeClr val="accent1"/>
-          </a:lnRef>
-          <a:fillRef idx="3">
-            <a:schemeClr val="accent1"/>
-          </a:fillRef>
-          <a:effectRef idx="2">
-            <a:schemeClr val="accent1"/>
-          </a:effectRef>
-          <a:fontRef idx="minor">
-            <a:schemeClr val="lt1"/>
-          </a:fontRef>
-        </p:style>
-        <p:txBody>
-          <a:bodyPr rtlCol="0" anchor="ctr"/>
-          <a:lstStyle/>
-          <a:p>
-            <a:pPr algn="ctr"/>
-          </a:p>
-        </p:txBody>
-      </p:sp>
-      <p:sp>
-        <p:nvSpPr>
-          <p:cNvPr id="121" name="TextBox 120"/>
-          <p:cNvSpPr txBox="1"/>
-          <p:nvPr/>
-        </p:nvSpPr>
-        <p:spPr>
-          <a:xfrm>
-            <a:off x="7013448" y="5989320"/>
-            <a:ext cx="2194560" cy="274320"/>
-          </a:xfrm>
-          <a:prstGeom prst="rect">
-            <a:avLst/>
-          </a:prstGeom>
-          <a:noFill/>
-        </p:spPr>
-        <p:txBody>
-          <a:bodyPr wrap="square" lIns="0" rIns="0" tIns="0" bIns="0" anchor="ctr">
-            <a:spAutoFit/>
-          </a:bodyPr>
-          <a:lstStyle/>
-          <a:p>
-            <a:pPr algn="l"/>
-            <a:r>
-              <a:rPr sz="1200">
-                <a:solidFill>
-                  <a:srgbClr val="000000"/>
-                </a:solidFill>
-                <a:latin typeface="General Sans"/>
-              </a:rPr>
               <a:t>Evaluatie en afsluiting</a:t>
             </a:r>
           </a:p>
@@ -20526,7 +20420,7 @@
       </p:sp>
       <p:pic>
         <p:nvPicPr>
-          <p:cNvPr id="122" name="Npuls beeldmerk" descr="npuls-beeldmerk-zwart.png"/>
+          <p:cNvPr id="120" name="Npuls beeldmerk" descr="npuls-beeldmerk-zwart.png"/>
           <p:cNvPicPr>
             <a:picLocks noChangeAspect="1"/>
           </p:cNvPicPr>
@@ -21598,7 +21492,7 @@
                 <a:ea typeface="General Sans Semibold" pitchFamily="34" charset="-122"/>
                 <a:cs typeface="General Sans Semibold" pitchFamily="34" charset="-120"/>
               </a:rPr>
-              <a:t>De AI-taak</a:t>
+              <a:t>Met de agent</a:t>
             </a:r>
             <a:endParaRPr lang="en-US" sz="1200" dirty="0"/>
           </a:p>
@@ -21640,7 +21534,7 @@
                 <a:ea typeface="General Sans Semibold" pitchFamily="34" charset="-122"/>
                 <a:cs typeface="General Sans Semibold" pitchFamily="34" charset="-120"/>
               </a:rPr>
-              <a:t>Uitval per cohort</a:t>
+              <a:t>Uitval laten uitrekenen</a:t>
             </a:r>
             <a:endParaRPr lang="en-US" sz="2300" dirty="0"/>
           </a:p>
@@ -21682,7 +21576,7 @@
                 <a:ea typeface="General Sans" pitchFamily="34" charset="-122"/>
                 <a:cs typeface="General Sans" pitchFamily="34" charset="-120"/>
               </a:rPr>
-              <a:t>Uitval binnen 1 jaar per cohort berekenen en vergelijken naar sector, geslacht en opleiding.</a:t>
+              <a:t>Jullie laten de agent per jaar uitrekenen hoeveel eerstejaars stoppen, en dat vergelijken per sector.</a:t>
             </a:r>
             <a:endParaRPr lang="en-US" sz="1500" dirty="0"/>
           </a:p>
@@ -21830,7 +21724,7 @@
                 <a:ea typeface="General Sans Semibold" pitchFamily="34" charset="-122"/>
                 <a:cs typeface="General Sans Semibold" pitchFamily="34" charset="-120"/>
               </a:rPr>
-              <a:t>Het product</a:t>
+              <a:t>Wat je oplevert</a:t>
             </a:r>
             <a:endParaRPr lang="en-US" sz="1200" dirty="0"/>
           </a:p>
@@ -22116,7 +22010,7 @@
                 <a:ea typeface="General Sans Semibold" pitchFamily="34" charset="-122"/>
                 <a:cs typeface="General Sans Semibold" pitchFamily="34" charset="-120"/>
               </a:rPr>
-              <a:t>Bestuurder:</a:t>
+              <a:t>Prompter:</a:t>
             </a:r>
             <a:pPr algn="l" indent="0" marL="0">
               <a:lnSpc>
@@ -22133,7 +22027,7 @@
                 <a:ea typeface="General Sans" pitchFamily="34" charset="-122"/>
                 <a:cs typeface="General Sans" pitchFamily="34" charset="-120"/>
               </a:rPr>
-              <a:t> typt de instructies aan de agent</a:t>
+              <a:t> typt de opdrachten aan de agent</a:t>
             </a:r>
             <a:endParaRPr lang="en-US" sz="1900" dirty="0"/>
           </a:p>
@@ -22187,7 +22081,7 @@
               <a:buNone/>
             </a:pPr>
             <a:r>
-              <a:rPr lang="en-US" sz="1900" dirty="0">
+              <a:rPr lang="en-US" sz="1700" dirty="0">
                 <a:solidFill>
                   <a:srgbClr val="3D68EC"/>
                 </a:solidFill>
@@ -22195,7 +22089,7 @@
                 <a:ea typeface="General Sans Semibold" pitchFamily="34" charset="-122"/>
                 <a:cs typeface="General Sans Semibold" pitchFamily="34" charset="-120"/>
               </a:rPr>
-              <a:t>Navigator:</a:t>
+              <a:t>Checker:</a:t>
             </a:r>
             <a:pPr algn="l" indent="0" marL="0">
               <a:lnSpc>
@@ -22204,7 +22098,7 @@
               <a:buNone/>
             </a:pPr>
             <a:r>
-              <a:rPr lang="en-US" sz="1900" dirty="0">
+              <a:rPr lang="en-US" sz="1700" dirty="0">
                 <a:solidFill>
                   <a:srgbClr val="000000"/>
                 </a:solidFill>
@@ -22212,9 +22106,9 @@
                 <a:ea typeface="General Sans" pitchFamily="34" charset="-122"/>
                 <a:cs typeface="General Sans" pitchFamily="34" charset="-120"/>
               </a:rPr>
-              <a:t> leest de code en controleert de uitkomst</a:t>
-            </a:r>
-            <a:endParaRPr lang="en-US" sz="1900" dirty="0"/>
+              <a:t> leest wat de agent teruggeeft en vraagt: klopt dit, en kunnen we dit zo laten zien?</a:t>
+            </a:r>
+            <a:endParaRPr lang="en-US" sz="1700" dirty="0"/>
           </a:p>
         </p:txBody>
       </p:sp>
@@ -22353,7 +22247,7 @@
                 <a:ea typeface="General Sans Semibold" pitchFamily="34" charset="-122"/>
                 <a:cs typeface="General Sans Semibold" pitchFamily="34" charset="-120"/>
               </a:rPr>
-              <a:t>Vraag je iets?</a:t>
+              <a:t>Loop je vast?</a:t>
             </a:r>
             <a:pPr algn="l" indent="0" marL="0">
               <a:lnSpc>
@@ -22370,7 +22264,7 @@
                 <a:ea typeface="General Sans" pitchFamily="34" charset="-122"/>
                 <a:cs typeface="General Sans" pitchFamily="34" charset="-120"/>
               </a:rPr>
-              <a:t> Dan stel ik een wedervraag: wat zou de agent hier doen?</a:t>
+              <a:t> Vraag de agent: leg uit wat je net deed</a:t>
             </a:r>
             <a:endParaRPr lang="en-US" sz="1900" dirty="0"/>
           </a:p>
@@ -22492,7 +22386,7 @@
                 <a:ea typeface="General Sans Semibold" pitchFamily="34" charset="-122"/>
                 <a:cs typeface="General Sans Semibold" pitchFamily="34" charset="-120"/>
               </a:rPr>
-              <a:t>Prompt, skill, agent</a:t>
+              <a:t>Agent, prompt en skill</a:t>
             </a:r>
             <a:endParaRPr lang="en-US" sz="3400" dirty="0"/>
           </a:p>
@@ -22507,11 +22401,11 @@
         <p:spPr>
           <a:xfrm>
             <a:off x="548640" y="1371600"/>
-            <a:ext cx="3393338" cy="3817620"/>
+            <a:ext cx="3515258" cy="3817620"/>
           </a:xfrm>
           <a:prstGeom prst="roundRect">
             <a:avLst>
-              <a:gd name="adj" fmla="val 2033"/>
+              <a:gd name="adj" fmla="val 1895"/>
             </a:avLst>
           </a:prstGeom>
           <a:solidFill>
@@ -22529,7 +22423,7 @@
         <p:spPr>
           <a:xfrm>
             <a:off x="822960" y="1719072"/>
-            <a:ext cx="2844698" cy="402336"/>
+            <a:ext cx="2966618" cy="402336"/>
           </a:xfrm>
           <a:prstGeom prst="roundRect">
             <a:avLst>
@@ -22551,7 +22445,7 @@
         <p:spPr>
           <a:xfrm>
             <a:off x="914400" y="1719072"/>
-            <a:ext cx="2661818" cy="402336"/>
+            <a:ext cx="2783738" cy="402336"/>
           </a:xfrm>
           <a:prstGeom prst="rect">
             <a:avLst/>
@@ -22578,7 +22472,7 @@
                 <a:ea typeface="General Sans Semibold" pitchFamily="34" charset="-122"/>
                 <a:cs typeface="General Sans Semibold" pitchFamily="34" charset="-120"/>
               </a:rPr>
-              <a:t>Losse vraag</a:t>
+              <a:t>De uitvoerder</a:t>
             </a:r>
             <a:endParaRPr lang="en-US" sz="1200" dirty="0"/>
           </a:p>
@@ -22593,7 +22487,7 @@
         <p:spPr>
           <a:xfrm>
             <a:off x="822960" y="2423160"/>
-            <a:ext cx="2844698" cy="338328"/>
+            <a:ext cx="2966618" cy="338328"/>
           </a:xfrm>
           <a:prstGeom prst="rect">
             <a:avLst/>
@@ -22620,7 +22514,7 @@
                 <a:ea typeface="General Sans Semibold" pitchFamily="34" charset="-122"/>
                 <a:cs typeface="General Sans Semibold" pitchFamily="34" charset="-120"/>
               </a:rPr>
-              <a:t>Prompt</a:t>
+              <a:t>Agent</a:t>
             </a:r>
             <a:endParaRPr lang="en-US" sz="2200" dirty="0"/>
           </a:p>
@@ -22635,7 +22529,7 @@
         <p:spPr>
           <a:xfrm>
             <a:off x="822960" y="3035808"/>
-            <a:ext cx="2844698" cy="990600"/>
+            <a:ext cx="2966618" cy="990600"/>
           </a:xfrm>
           <a:prstGeom prst="rect">
             <a:avLst/>
@@ -22662,7 +22556,7 @@
                 <a:ea typeface="General Sans" pitchFamily="34" charset="-122"/>
                 <a:cs typeface="General Sans" pitchFamily="34" charset="-120"/>
               </a:rPr>
-              <a:t>Je typt wat je wilt. Elke keer anders, de kennis zit in jouw hoofd.</a:t>
+              <a:t>De AI die het werk doet. Hij leest je opdracht, schrijft en draait de code. Wij gebruiken Claude Code.</a:t>
             </a:r>
             <a:endParaRPr lang="en-US" sz="1500" dirty="0"/>
           </a:p>
@@ -22677,7 +22571,7 @@
         <p:spPr>
           <a:xfrm>
             <a:off x="822960" y="4163568"/>
-            <a:ext cx="2844698" cy="274320"/>
+            <a:ext cx="2966618" cy="274320"/>
           </a:xfrm>
           <a:prstGeom prst="rect">
             <a:avLst/>
@@ -22704,7 +22598,7 @@
                 <a:ea typeface="General Sans Semibold" pitchFamily="34" charset="-122"/>
                 <a:cs typeface="General Sans Semibold" pitchFamily="34" charset="-120"/>
               </a:rPr>
-              <a:t>LEVERT</a:t>
+              <a:t>VOORBEELD</a:t>
             </a:r>
             <a:endParaRPr lang="en-US" sz="1100" dirty="0"/>
           </a:p>
@@ -22719,7 +22613,7 @@
         <p:spPr>
           <a:xfrm>
             <a:off x="822960" y="4511040"/>
-            <a:ext cx="2844698" cy="541020"/>
+            <a:ext cx="2966618" cy="541020"/>
           </a:xfrm>
           <a:prstGeom prst="rect">
             <a:avLst/>
@@ -22746,7 +22640,7 @@
                 <a:ea typeface="General Sans Semibold" pitchFamily="34" charset="-122"/>
                 <a:cs typeface="General Sans Semibold" pitchFamily="34" charset="-120"/>
               </a:rPr>
-              <a:t>Eén antwoord</a:t>
+              <a:t>Claude Code in de terminal</a:t>
             </a:r>
             <a:endParaRPr lang="en-US" sz="1500" dirty="0"/>
           </a:p>
@@ -22760,11 +22654,13 @@
         </p:nvSpPr>
         <p:spPr>
           <a:xfrm>
-            <a:off x="4051706" y="3006090"/>
-            <a:ext cx="237744" cy="548640"/>
-          </a:xfrm>
-          <a:prstGeom prst="chevron">
-            <a:avLst/>
+            <a:off x="4338218" y="1371600"/>
+            <a:ext cx="3515258" cy="3817620"/>
+          </a:xfrm>
+          <a:prstGeom prst="roundRect">
+            <a:avLst>
+              <a:gd name="adj" fmla="val 1895"/>
+            </a:avLst>
           </a:prstGeom>
           <a:solidFill>
             <a:srgbClr val="F4D9DC"/>
@@ -22780,30 +22676,8 @@
         </p:nvSpPr>
         <p:spPr>
           <a:xfrm>
-            <a:off x="4399178" y="1371600"/>
-            <a:ext cx="3393338" cy="3817620"/>
-          </a:xfrm>
-          <a:prstGeom prst="roundRect">
-            <a:avLst>
-              <a:gd name="adj" fmla="val 2033"/>
-            </a:avLst>
-          </a:prstGeom>
-          <a:solidFill>
-            <a:srgbClr val="F4D9DC"/>
-          </a:solidFill>
-          <a:ln/>
-        </p:spPr>
-      </p:sp>
-      <p:sp>
-        <p:nvSpPr>
-          <p:cNvPr id="82" name="Shape 80"/>
-          <p:cNvSpPr/>
-          <p:nvPr/>
-        </p:nvSpPr>
-        <p:spPr>
-          <a:xfrm>
-            <a:off x="4673498" y="1719072"/>
-            <a:ext cx="2844698" cy="402336"/>
+            <a:off x="4612538" y="1719072"/>
+            <a:ext cx="2966618" cy="402336"/>
           </a:xfrm>
           <a:prstGeom prst="roundRect">
             <a:avLst>
@@ -22818,14 +22692,14 @@
       </p:sp>
       <p:sp>
         <p:nvSpPr>
-          <p:cNvPr id="83" name="Text 81"/>
-          <p:cNvSpPr/>
-          <p:nvPr/>
-        </p:nvSpPr>
-        <p:spPr>
-          <a:xfrm>
-            <a:off x="4764938" y="1719072"/>
-            <a:ext cx="2661818" cy="402336"/>
+          <p:cNvPr id="82" name="Text 80"/>
+          <p:cNvSpPr/>
+          <p:nvPr/>
+        </p:nvSpPr>
+        <p:spPr>
+          <a:xfrm>
+            <a:off x="4703978" y="1719072"/>
+            <a:ext cx="2783738" cy="402336"/>
           </a:xfrm>
           <a:prstGeom prst="rect">
             <a:avLst/>
@@ -22852,7 +22726,7 @@
                 <a:ea typeface="General Sans Semibold" pitchFamily="34" charset="-122"/>
                 <a:cs typeface="General Sans Semibold" pitchFamily="34" charset="-120"/>
               </a:rPr>
-              <a:t>Vastgelegd recept</a:t>
+              <a:t>Een losse opdracht</a:t>
             </a:r>
             <a:endParaRPr lang="en-US" sz="1200" dirty="0"/>
           </a:p>
@@ -22860,14 +22734,14 @@
       </p:sp>
       <p:sp>
         <p:nvSpPr>
-          <p:cNvPr id="84" name="Text 82"/>
-          <p:cNvSpPr/>
-          <p:nvPr/>
-        </p:nvSpPr>
-        <p:spPr>
-          <a:xfrm>
-            <a:off x="4673498" y="2423160"/>
-            <a:ext cx="2844698" cy="338328"/>
+          <p:cNvPr id="83" name="Text 81"/>
+          <p:cNvSpPr/>
+          <p:nvPr/>
+        </p:nvSpPr>
+        <p:spPr>
+          <a:xfrm>
+            <a:off x="4612538" y="2423160"/>
+            <a:ext cx="2966618" cy="338328"/>
           </a:xfrm>
           <a:prstGeom prst="rect">
             <a:avLst/>
@@ -22894,7 +22768,7 @@
                 <a:ea typeface="General Sans Semibold" pitchFamily="34" charset="-122"/>
                 <a:cs typeface="General Sans Semibold" pitchFamily="34" charset="-120"/>
               </a:rPr>
-              <a:t>Skill</a:t>
+              <a:t>Prompt</a:t>
             </a:r>
             <a:endParaRPr lang="en-US" sz="2200" dirty="0"/>
           </a:p>
@@ -22902,14 +22776,14 @@
       </p:sp>
       <p:sp>
         <p:nvSpPr>
-          <p:cNvPr id="85" name="Text 83"/>
-          <p:cNvSpPr/>
-          <p:nvPr/>
-        </p:nvSpPr>
-        <p:spPr>
-          <a:xfrm>
-            <a:off x="4673498" y="3035808"/>
-            <a:ext cx="2844698" cy="990600"/>
+          <p:cNvPr id="84" name="Text 82"/>
+          <p:cNvSpPr/>
+          <p:nvPr/>
+        </p:nvSpPr>
+        <p:spPr>
+          <a:xfrm>
+            <a:off x="4612538" y="3035808"/>
+            <a:ext cx="2966618" cy="990600"/>
           </a:xfrm>
           <a:prstGeom prst="rect">
             <a:avLst/>
@@ -22936,7 +22810,7 @@
                 <a:ea typeface="General Sans" pitchFamily="34" charset="-122"/>
                 <a:cs typeface="General Sans" pitchFamily="34" charset="-120"/>
               </a:rPr>
-              <a:t>Een map met een SKILL.md: instructies, voorbeelden, checks. Leesbaar en deelbaar.</a:t>
+              <a:t>Wat jij zelf typt. Elke keer anders, en het resultaat hangt af van hoe je het vraagt.</a:t>
             </a:r>
             <a:endParaRPr lang="en-US" sz="1500" dirty="0"/>
           </a:p>
@@ -22944,14 +22818,14 @@
       </p:sp>
       <p:sp>
         <p:nvSpPr>
-          <p:cNvPr id="86" name="Text 84"/>
-          <p:cNvSpPr/>
-          <p:nvPr/>
-        </p:nvSpPr>
-        <p:spPr>
-          <a:xfrm>
-            <a:off x="4673498" y="4163568"/>
-            <a:ext cx="2844698" cy="274320"/>
+          <p:cNvPr id="85" name="Text 83"/>
+          <p:cNvSpPr/>
+          <p:nvPr/>
+        </p:nvSpPr>
+        <p:spPr>
+          <a:xfrm>
+            <a:off x="4612538" y="4163568"/>
+            <a:ext cx="2966618" cy="274320"/>
           </a:xfrm>
           <a:prstGeom prst="rect">
             <a:avLst/>
@@ -22978,7 +22852,7 @@
                 <a:ea typeface="General Sans Semibold" pitchFamily="34" charset="-122"/>
                 <a:cs typeface="General Sans Semibold" pitchFamily="34" charset="-120"/>
               </a:rPr>
-              <a:t>LEVERT</a:t>
+              <a:t>VOORBEELD</a:t>
             </a:r>
             <a:endParaRPr lang="en-US" sz="1100" dirty="0"/>
           </a:p>
@@ -22986,14 +22860,14 @@
       </p:sp>
       <p:sp>
         <p:nvSpPr>
-          <p:cNvPr id="87" name="Text 85"/>
-          <p:cNvSpPr/>
-          <p:nvPr/>
-        </p:nvSpPr>
-        <p:spPr>
-          <a:xfrm>
-            <a:off x="4673498" y="4511040"/>
-            <a:ext cx="2844698" cy="541020"/>
+          <p:cNvPr id="86" name="Text 84"/>
+          <p:cNvSpPr/>
+          <p:nvPr/>
+        </p:nvSpPr>
+        <p:spPr>
+          <a:xfrm>
+            <a:off x="4612538" y="4511040"/>
+            <a:ext cx="2966618" cy="541020"/>
           </a:xfrm>
           <a:prstGeom prst="rect">
             <a:avLst/>
@@ -23020,7 +22894,7 @@
                 <a:ea typeface="General Sans Semibold" pitchFamily="34" charset="-122"/>
                 <a:cs typeface="General Sans Semibold" pitchFamily="34" charset="-120"/>
               </a:rPr>
-              <a:t>Herhaalbare werkwijze</a:t>
+              <a:t>"Laat zien wie er uitvalt"</a:t>
             </a:r>
             <a:endParaRPr lang="en-US" sz="1500" dirty="0"/>
           </a:p>
@@ -23028,38 +22902,18 @@
       </p:sp>
       <p:sp>
         <p:nvSpPr>
-          <p:cNvPr id="88" name="Shape 86"/>
-          <p:cNvSpPr/>
-          <p:nvPr/>
-        </p:nvSpPr>
-        <p:spPr>
-          <a:xfrm>
-            <a:off x="7902245" y="3006090"/>
-            <a:ext cx="237744" cy="548640"/>
-          </a:xfrm>
-          <a:prstGeom prst="chevron">
-            <a:avLst/>
-          </a:prstGeom>
-          <a:solidFill>
-            <a:srgbClr val="F4D9DC"/>
-          </a:solidFill>
-          <a:ln/>
-        </p:spPr>
-      </p:sp>
-      <p:sp>
-        <p:nvSpPr>
-          <p:cNvPr id="89" name="Shape 87"/>
-          <p:cNvSpPr/>
-          <p:nvPr/>
-        </p:nvSpPr>
-        <p:spPr>
-          <a:xfrm>
-            <a:off x="8249717" y="1371600"/>
-            <a:ext cx="3393338" cy="3817620"/>
+          <p:cNvPr id="87" name="Shape 85"/>
+          <p:cNvSpPr/>
+          <p:nvPr/>
+        </p:nvSpPr>
+        <p:spPr>
+          <a:xfrm>
+            <a:off x="8127797" y="1371600"/>
+            <a:ext cx="3515258" cy="3817620"/>
           </a:xfrm>
           <a:prstGeom prst="roundRect">
             <a:avLst>
-              <a:gd name="adj" fmla="val 2033"/>
+              <a:gd name="adj" fmla="val 1895"/>
             </a:avLst>
           </a:prstGeom>
           <a:solidFill>
@@ -23070,14 +22924,14 @@
       </p:sp>
       <p:sp>
         <p:nvSpPr>
-          <p:cNvPr id="90" name="Shape 88"/>
-          <p:cNvSpPr/>
-          <p:nvPr/>
-        </p:nvSpPr>
-        <p:spPr>
-          <a:xfrm>
-            <a:off x="8524037" y="1719072"/>
-            <a:ext cx="2844698" cy="402336"/>
+          <p:cNvPr id="88" name="Shape 86"/>
+          <p:cNvSpPr/>
+          <p:nvPr/>
+        </p:nvSpPr>
+        <p:spPr>
+          <a:xfrm>
+            <a:off x="8402117" y="1719072"/>
+            <a:ext cx="2966618" cy="402336"/>
           </a:xfrm>
           <a:prstGeom prst="roundRect">
             <a:avLst>
@@ -23092,14 +22946,14 @@
       </p:sp>
       <p:sp>
         <p:nvSpPr>
-          <p:cNvPr id="91" name="Text 89"/>
-          <p:cNvSpPr/>
-          <p:nvPr/>
-        </p:nvSpPr>
-        <p:spPr>
-          <a:xfrm>
-            <a:off x="8615477" y="1719072"/>
-            <a:ext cx="2661818" cy="402336"/>
+          <p:cNvPr id="89" name="Text 87"/>
+          <p:cNvSpPr/>
+          <p:nvPr/>
+        </p:nvSpPr>
+        <p:spPr>
+          <a:xfrm>
+            <a:off x="8493557" y="1719072"/>
+            <a:ext cx="2783738" cy="402336"/>
           </a:xfrm>
           <a:prstGeom prst="rect">
             <a:avLst/>
@@ -23126,7 +22980,7 @@
                 <a:ea typeface="General Sans Semibold" pitchFamily="34" charset="-122"/>
                 <a:cs typeface="General Sans Semibold" pitchFamily="34" charset="-120"/>
               </a:rPr>
-              <a:t>Voert uit</a:t>
+              <a:t>Een vast stappenplan</a:t>
             </a:r>
             <a:endParaRPr lang="en-US" sz="1200" dirty="0"/>
           </a:p>
@@ -23134,14 +22988,14 @@
       </p:sp>
       <p:sp>
         <p:nvSpPr>
-          <p:cNvPr id="92" name="Text 90"/>
-          <p:cNvSpPr/>
-          <p:nvPr/>
-        </p:nvSpPr>
-        <p:spPr>
-          <a:xfrm>
-            <a:off x="8524037" y="2423160"/>
-            <a:ext cx="2844698" cy="338328"/>
+          <p:cNvPr id="90" name="Text 88"/>
+          <p:cNvSpPr/>
+          <p:nvPr/>
+        </p:nvSpPr>
+        <p:spPr>
+          <a:xfrm>
+            <a:off x="8402117" y="2423160"/>
+            <a:ext cx="2966618" cy="338328"/>
           </a:xfrm>
           <a:prstGeom prst="rect">
             <a:avLst/>
@@ -23168,7 +23022,7 @@
                 <a:ea typeface="General Sans Semibold" pitchFamily="34" charset="-122"/>
                 <a:cs typeface="General Sans Semibold" pitchFamily="34" charset="-120"/>
               </a:rPr>
-              <a:t>Agent</a:t>
+              <a:t>Skill</a:t>
             </a:r>
             <a:endParaRPr lang="en-US" sz="2200" dirty="0"/>
           </a:p>
@@ -23176,14 +23030,14 @@
       </p:sp>
       <p:sp>
         <p:nvSpPr>
-          <p:cNvPr id="93" name="Text 91"/>
-          <p:cNvSpPr/>
-          <p:nvPr/>
-        </p:nvSpPr>
-        <p:spPr>
-          <a:xfrm>
-            <a:off x="8524037" y="3035808"/>
-            <a:ext cx="2844698" cy="990600"/>
+          <p:cNvPr id="91" name="Text 89"/>
+          <p:cNvSpPr/>
+          <p:nvPr/>
+        </p:nvSpPr>
+        <p:spPr>
+          <a:xfrm>
+            <a:off x="8402117" y="3035808"/>
+            <a:ext cx="2966618" cy="990600"/>
           </a:xfrm>
           <a:prstGeom prst="rect">
             <a:avLst/>
@@ -23210,7 +23064,7 @@
                 <a:ea typeface="General Sans" pitchFamily="34" charset="-122"/>
                 <a:cs typeface="General Sans" pitchFamily="34" charset="-120"/>
               </a:rPr>
-              <a:t>Claude Code leest de skill, draait de code en toetst aan de checks.</a:t>
+              <a:t>Een tekstbestand met stappen en checks dat de agent volgt. Elke keer dezelfde werkwijze.</a:t>
             </a:r>
             <a:endParaRPr lang="en-US" sz="1500" dirty="0"/>
           </a:p>
@@ -23218,14 +23072,14 @@
       </p:sp>
       <p:sp>
         <p:nvSpPr>
-          <p:cNvPr id="94" name="Text 92"/>
-          <p:cNvSpPr/>
-          <p:nvPr/>
-        </p:nvSpPr>
-        <p:spPr>
-          <a:xfrm>
-            <a:off x="8524037" y="4163568"/>
-            <a:ext cx="2844698" cy="274320"/>
+          <p:cNvPr id="92" name="Text 90"/>
+          <p:cNvSpPr/>
+          <p:nvPr/>
+        </p:nvSpPr>
+        <p:spPr>
+          <a:xfrm>
+            <a:off x="8402117" y="4163568"/>
+            <a:ext cx="2966618" cy="274320"/>
           </a:xfrm>
           <a:prstGeom prst="rect">
             <a:avLst/>
@@ -23252,7 +23106,7 @@
                 <a:ea typeface="General Sans Semibold" pitchFamily="34" charset="-122"/>
                 <a:cs typeface="General Sans Semibold" pitchFamily="34" charset="-120"/>
               </a:rPr>
-              <a:t>LEVERT</a:t>
+              <a:t>VOORBEELD</a:t>
             </a:r>
             <a:endParaRPr lang="en-US" sz="1100" dirty="0"/>
           </a:p>
@@ -23260,14 +23114,14 @@
       </p:sp>
       <p:sp>
         <p:nvSpPr>
-          <p:cNvPr id="95" name="Text 93"/>
-          <p:cNvSpPr/>
-          <p:nvPr/>
-        </p:nvSpPr>
-        <p:spPr>
-          <a:xfrm>
-            <a:off x="8524037" y="4511040"/>
-            <a:ext cx="2844698" cy="541020"/>
+          <p:cNvPr id="93" name="Text 91"/>
+          <p:cNvSpPr/>
+          <p:nvPr/>
+        </p:nvSpPr>
+        <p:spPr>
+          <a:xfrm>
+            <a:off x="8402117" y="4511040"/>
+            <a:ext cx="2966618" cy="541020"/>
           </a:xfrm>
           <a:prstGeom prst="rect">
             <a:avLst/>
@@ -23294,7 +23148,7 @@
                 <a:ea typeface="General Sans Semibold" pitchFamily="34" charset="-122"/>
                 <a:cs typeface="General Sans Semibold" pitchFamily="34" charset="-120"/>
               </a:rPr>
-              <a:t>Resultaat dat je kunt nalopen</a:t>
+              <a:t>Eerst profiel, dan definities, dan kleine groepen</a:t>
             </a:r>
             <a:endParaRPr lang="en-US" sz="1500" dirty="0"/>
           </a:p>
@@ -23302,7 +23156,7 @@
       </p:sp>
       <p:sp>
         <p:nvSpPr>
-          <p:cNvPr id="96" name="Text 94"/>
+          <p:cNvPr id="94" name="Text 92"/>
           <p:cNvSpPr/>
           <p:nvPr/>
         </p:nvSpPr>
@@ -23328,7 +23182,7 @@
               <a:buNone/>
             </a:pPr>
             <a:r>
-              <a:rPr lang="en-US" sz="1800" dirty="0">
+              <a:rPr lang="en-US" sz="1500" dirty="0">
                 <a:solidFill>
                   <a:srgbClr val="F4D9DC"/>
                 </a:solidFill>
@@ -23336,15 +23190,15 @@
                 <a:ea typeface="General Sans" pitchFamily="34" charset="-122"/>
                 <a:cs typeface="General Sans" pitchFamily="34" charset="-120"/>
               </a:rPr>
-              <a:t>Vuistregel: elke prompt die je drie keer typt, is een skill in wording.</a:t>
-            </a:r>
-            <a:endParaRPr lang="en-US" sz="1800" dirty="0"/>
+              <a:t>In de rondes prompten jullie zelf. Bij de spiegelmomenten laten wij zien hoe een skill hetzelfde doet.</a:t>
+            </a:r>
+            <a:endParaRPr lang="en-US" sz="1500" dirty="0"/>
           </a:p>
         </p:txBody>
       </p:sp>
       <p:pic>
         <p:nvPicPr>
-          <p:cNvPr id="97" name="Npuls beeldmerk" descr="npuls-beeldmerk-wit.png"/>
+          <p:cNvPr id="95" name="Npuls beeldmerk" descr="npuls-beeldmerk-wit.png"/>
           <p:cNvPicPr>
             <a:picLocks noChangeAspect="1"/>
           </p:cNvPicPr>
@@ -23434,7 +23288,7 @@
                 <a:ea typeface="General Sans Semibold" pitchFamily="34" charset="-122"/>
                 <a:cs typeface="General Sans Semibold" pitchFamily="34" charset="-120"/>
               </a:rPr>
-              <a:t>Drie skills voor vandaag</a:t>
+              <a:t>Drie skills die wij laten zien</a:t>
             </a:r>
             <a:endParaRPr lang="en-US" sz="3400" dirty="0"/>
           </a:p>
@@ -23582,7 +23436,7 @@
                 <a:ea typeface="General Sans Semibold" pitchFamily="34" charset="-122"/>
                 <a:cs typeface="General Sans Semibold" pitchFamily="34" charset="-120"/>
               </a:rPr>
-              <a:t>Ronde 1</a:t>
+              <a:t>Spiegelmoment 1</a:t>
             </a:r>
             <a:endParaRPr lang="en-US" sz="1200" dirty="0"/>
           </a:p>
@@ -23940,7 +23794,7 @@
                 <a:ea typeface="General Sans Semibold" pitchFamily="34" charset="-122"/>
                 <a:cs typeface="General Sans Semibold" pitchFamily="34" charset="-120"/>
               </a:rPr>
-              <a:t>Ronde 2</a:t>
+              <a:t>Spiegelmoment 2</a:t>
             </a:r>
             <a:endParaRPr lang="en-US" sz="1200" dirty="0"/>
           </a:p>
@@ -24542,7 +24396,7 @@
               <a:buNone/>
             </a:pPr>
             <a:r>
-              <a:rPr lang="en-US" sz="1800" dirty="0">
+              <a:rPr lang="en-US" sz="1600" dirty="0">
                 <a:solidFill>
                   <a:srgbClr val="000000"/>
                 </a:solidFill>
@@ -24550,9 +24404,9 @@
                 <a:ea typeface="General Sans" pitchFamily="34" charset="-122"/>
                 <a:cs typeface="General Sans" pitchFamily="34" charset="-120"/>
               </a:rPr>
-              <a:t>Je typt de naam van de skill, de agent leest het recept en voert het uit.</a:t>
-            </a:r>
-            <a:endParaRPr lang="en-US" sz="1800" dirty="0"/>
+              <a:t>Jullie prompten zelf in de rondes. Wij laten de skills live draaien bij de spiegelmomenten.</a:t>
+            </a:r>
+            <a:endParaRPr lang="en-US" sz="1600" dirty="0"/>
           </a:p>
         </p:txBody>
       </p:sp>

</xml_diff>

<commit_message>
docs(workshop): tijdmeting van de skills en vergelijking met een gewone prompt
Skill 1 duurt ongeveer 1 minuut, skill 2 ongeveer 2 tot 2,5 minuut (headless, Claude Code).
Een gewone prompt is korter maar mist definities, privacydrempel en tussenproducten en telt
de eerstejaars anders. Notities en draaiboek bijgewerkt.

Co-Authored-By: Claude Sonnet 5.5 <noreply@anthropic.com>
</commit_message>
<xml_diff>
--- a/workshop-rad/exports/261005_workshop_rad_uitvoering.pptx
+++ b/workshop-rad/exports/261005_workshop_rad_uitvoering.pptx
@@ -1127,7 +1127,7 @@
           <a:p>
             <a:r>
               <a:rPr lang="en-US" dirty="0"/>
-              <a:t>We kijken niet naar individuele schetsen, maar naar de skill. Vraag eerst twee tweetallen om één ding te noemen dat ze in ronde 1 tegenkwamen (één zin per tweetal). Loop daarna met de volgende twee dia's door de skill. Draai /workshop-verkennen live (zie docs/tijdmeting.md voor hoe lang dat duurt) en leg uit terwijl hij loopt. Zet daarnaast desgewenst één gewone prompt op hetzelfde scherm.</a:t>
+              <a:t>We kijken niet naar individuele schetsen, maar naar de skill. Vraag eerst twee tweetallen om één ding te noemen dat ze in ronde 1 tegenkwamen (één zin per tweetal). Loop daarna met de volgende twee dia's door de skill. Draai /workshop-verkennen live: dat duurt ongeveer 1 minuut (gemeten 58 tot 71 s, reken op een marge) en je legt uit terwijl hij loopt. Zet daarnaast desgewenst één gewone prompt op hetzelfde scherm.</a:t>
             </a:r>
             <a:endParaRPr lang="en-US" dirty="0"/>
           </a:p>
@@ -1655,7 +1655,7 @@
           <a:p>
             <a:r>
               <a:rPr lang="en-US" dirty="0"/>
-              <a:t>Ook nu geen individuele dashboards bekijken. Vraag twee tweetallen om één keuze te noemen die ze maakten (bijvoorbeeld de titel of de drempel). Loop daarna door de skill met de volgende dia's en sluit af met de onthulling van de uitkomst.</a:t>
+              <a:t>Ook nu geen individuele dashboards bekijken. Vraag twee tweetallen om één keuze te noemen die ze maakten (bijvoorbeeld de titel of de drempel). Draai /workshop-dashboard live: dat duurt ongeveer 2 tot 2,5 minuut (gemeten 124 tot 136 s). Loop daarna door de skill met de volgende dia's en sluit af met de onthulling van de uitkomst. Contrast: een gewone prompt telt de eerstejaars anders (2.449 in plaats van 2.809) en verbergt kleine groepen niet; zie docs/tijdmeting.md.</a:t>
             </a:r>
             <a:endParaRPr lang="en-US" dirty="0"/>
           </a:p>

</xml_diff>

<commit_message>
feat(workshop): voorstel en uitvoering als één verhaal
- Voorstel: rollen prompter en checker, drempel n<30, skills alleen door de leider getoond,
  juiste claims over de devcontainer, eerlijk over casus C, en open punten met PR en issues
- Uitvoering: voorbeeldprompt per ronde, geen claim meer dat DuckDB en Streamlit al klaarstaan

Co-Authored-By: Claude Sonnet 5.5 <noreply@anthropic.com>
</commit_message>
<xml_diff>
--- a/workshop-rad/exports/261005_workshop_rad_uitvoering.pptx
+++ b/workshop-rad/exports/261005_workshop_rad_uitvoering.pptx
@@ -4454,7 +4454,7 @@
                 <a:ea typeface="General Sans" pitchFamily="34" charset="-122"/>
                 <a:cs typeface="General Sans" pitchFamily="34" charset="-120"/>
               </a:rPr>
-              <a:t>Alles staat klaar: Python, DuckDB, Streamlit, de data en de skills</a:t>
+              <a:t>Alles staat klaar: Claude Code, Python en de data</a:t>
             </a:r>
             <a:endParaRPr lang="en-US" sz="1400" dirty="0"/>
           </a:p>
@@ -6124,7 +6124,7 @@
               <a:buNone/>
             </a:pPr>
             <a:r>
-              <a:rPr lang="en-US" sz="1800" dirty="0">
+              <a:rPr lang="en-US" sz="1500" dirty="0">
                 <a:solidFill>
                   <a:srgbClr val="DD784B"/>
                 </a:solidFill>
@@ -6132,7 +6132,7 @@
                 <a:ea typeface="General Sans Semibold" pitchFamily="34" charset="-122"/>
                 <a:cs typeface="General Sans Semibold" pitchFamily="34" charset="-120"/>
               </a:rPr>
-              <a:t>Oplevering:</a:t>
+              <a:t>Probeer:</a:t>
             </a:r>
             <a:pPr algn="l" indent="0" marL="0">
               <a:lnSpc>
@@ -6141,7 +6141,7 @@
               <a:buNone/>
             </a:pPr>
             <a:r>
-              <a:rPr lang="en-US" sz="1800" dirty="0">
+              <a:rPr lang="en-US" sz="1500" dirty="0">
                 <a:solidFill>
                   <a:srgbClr val="000000"/>
                 </a:solidFill>
@@ -6149,9 +6149,43 @@
                 <a:ea typeface="General Sans" pitchFamily="34" charset="-122"/>
                 <a:cs typeface="General Sans" pitchFamily="34" charset="-120"/>
               </a:rPr>
+              <a:t> "Vertel in gewone taal wat er in data/synthetisch_1cho.csv zit." </a:t>
+            </a:r>
+            <a:pPr algn="l" indent="0" marL="0">
+              <a:lnSpc>
+                <a:spcPct val="105000"/>
+              </a:lnSpc>
+              <a:buNone/>
+            </a:pPr>
+            <a:r>
+              <a:rPr lang="en-US" sz="1500" dirty="0">
+                <a:solidFill>
+                  <a:srgbClr val="DD784B"/>
+                </a:solidFill>
+                <a:latin typeface="General Sans Semibold" pitchFamily="34" charset="0"/>
+                <a:ea typeface="General Sans Semibold" pitchFamily="34" charset="-122"/>
+                <a:cs typeface="General Sans Semibold" pitchFamily="34" charset="-120"/>
+              </a:rPr>
+              <a:t>Oplevering:</a:t>
+            </a:r>
+            <a:pPr algn="l" indent="0" marL="0">
+              <a:lnSpc>
+                <a:spcPct val="105000"/>
+              </a:lnSpc>
+              <a:buNone/>
+            </a:pPr>
+            <a:r>
+              <a:rPr lang="en-US" sz="1500" dirty="0">
+                <a:solidFill>
+                  <a:srgbClr val="000000"/>
+                </a:solidFill>
+                <a:latin typeface="General Sans" pitchFamily="34" charset="0"/>
+                <a:ea typeface="General Sans" pitchFamily="34" charset="-122"/>
+                <a:cs typeface="General Sans" pitchFamily="34" charset="-120"/>
+              </a:rPr>
               <a:t> begrip van de data, een schets en een eerste privacy-check.</a:t>
             </a:r>
-            <a:endParaRPr lang="en-US" sz="1800" dirty="0"/>
+            <a:endParaRPr lang="en-US" sz="1500" dirty="0"/>
           </a:p>
         </p:txBody>
       </p:sp>
@@ -9996,7 +10030,24 @@
               <a:buNone/>
             </a:pPr>
             <a:r>
-              <a:rPr lang="en-US" sz="1800" dirty="0">
+              <a:rPr lang="en-US" sz="1500" dirty="0">
+                <a:solidFill>
+                  <a:srgbClr val="00AF81"/>
+                </a:solidFill>
+                <a:latin typeface="General Sans Semibold" pitchFamily="34" charset="0"/>
+                <a:ea typeface="General Sans Semibold" pitchFamily="34" charset="-122"/>
+                <a:cs typeface="General Sans Semibold" pitchFamily="34" charset="-120"/>
+              </a:rPr>
+              <a:t>Probeer:</a:t>
+            </a:r>
+            <a:pPr algn="l" indent="0" marL="0">
+              <a:lnSpc>
+                <a:spcPct val="105000"/>
+              </a:lnSpc>
+              <a:buNone/>
+            </a:pPr>
+            <a:r>
+              <a:rPr lang="en-US" sz="1500" dirty="0">
                 <a:solidFill>
                   <a:srgbClr val="000000"/>
                 </a:solidFill>
@@ -10004,9 +10055,9 @@
                 <a:ea typeface="General Sans" pitchFamily="34" charset="-122"/>
                 <a:cs typeface="General Sans" pitchFamily="34" charset="-120"/>
               </a:rPr>
-              <a:t>Het dashboard is het middel, de casusvraag het doel.</a:t>
-            </a:r>
-            <a:endParaRPr lang="en-US" sz="1800" dirty="0"/>
+              <a:t> "Bouw een Streamlit-dashboard dat laat zien welke eerstejaars binnen een jaar stoppen, per sector." Het dashboard is het middel, de casusvraag het doel.</a:t>
+            </a:r>
+            <a:endParaRPr lang="en-US" sz="1500" dirty="0"/>
           </a:p>
         </p:txBody>
       </p:sp>

</xml_diff>

<commit_message>
refactor(workshop): haal de reflectie-skill uit skills, decks en docs
De evaluatie gaat via de peiling en een rondje. De vragen staan in docs/evaluatievragen.md.

Co-Authored-By: Claude Sonnet 5.5 <noreply@anthropic.com>
</commit_message>
<xml_diff>
--- a/workshop-rad/exports/261005_workshop_rad_uitvoering.pptx
+++ b/workshop-rad/exports/261005_workshop_rad_uitvoering.pptx
@@ -32,10 +32,9 @@
     <p:sldId id="280" r:id="rId26"/>
     <p:sldId id="281" r:id="rId27"/>
     <p:sldId id="282" r:id="rId28"/>
-    <p:sldId id="283" r:id="rId29"/>
   </p:sldIdLst>
   <p:notesMasterIdLst>
-    <p:notesMasterId r:id="rId30"/>
+    <p:notesMasterId r:id="rId29"/>
   </p:notesMasterIdLst>
   <p:sldSz cx="12192000" cy="6858000"/>
   <p:notesSz cx="6858000" cy="12192000"/>
@@ -2095,7 +2094,7 @@
           <a:p>
             <a:r>
               <a:rPr lang="en-US" dirty="0"/>
-              <a:t>Evaluatie en afsluiting zijn één blok van 16 minuten. Vraag eerst toestemming: de antwoorden zijn anoniem en gebruiken we om te bepalen of er een vervolg komt. Terugblik via /workshop-reflectie of de peiling (QR-code). Houd de tijd: loopt het uit, kort dan de afsluiting in, niet de peiling.</a:t>
+              <a:t>Evaluatie en afsluiting zijn één blok van 16 minuten. Vraag eerst toestemming: de antwoorden zijn anoniem en gebruiken we om te bepalen of er een vervolg komt. Terugblik via de peiling (QR-code) of een kort rondje. Houd de tijd: loopt het uit, kort dan de afsluiting in, niet de peiling.</a:t>
             </a:r>
             <a:endParaRPr lang="en-US" dirty="0"/>
           </a:p>
@@ -2183,7 +2182,7 @@
           <a:p>
             <a:r>
               <a:rPr lang="en-US" dirty="0"/>
-              <a:t>Dit is de opbouw van /workshop-reflectie/SKILL.md: afgeleid van de teamskill sessie-terugblik, zonder GitHub-koppeling. Principes: één vraag per keer, een dun antwoord is een antwoord, niet doorvragen. Deelnemers mogen kiezen: via de skill of via de peiling.</a:t>
+              <a:t>Laat de peiling lopen, twee minuten. Als de peiling-tool nog niet gekozen is, tel handopsteking en noteer de aantallen. Voeg de QR-code hier toe zodra de tool bekend is.</a:t>
             </a:r>
             <a:endParaRPr lang="en-US" dirty="0"/>
           </a:p>
@@ -2271,7 +2270,7 @@
           <a:p>
             <a:r>
               <a:rPr lang="en-US" dirty="0"/>
-              <a:t>Laat de peiling lopen, twee minuten. Als de peiling-tool nog niet gekozen is, tel handopsteking en noteer de aantallen. Voeg de QR-code hier toe zodra de tool bekend is.</a:t>
+              <a:t>Open vraag, vier minuten. Alleen voor wie bij de vorige vraag niet "nee" koos. Vraag om concreet gedrag, niet om een onderwerp als "AI". Eén of twee zinnen is genoeg.</a:t>
             </a:r>
             <a:endParaRPr lang="en-US" dirty="0"/>
           </a:p>
@@ -2359,7 +2358,7 @@
           <a:p>
             <a:r>
               <a:rPr lang="en-US" dirty="0"/>
-              <a:t>Open vraag, vier minuten. Alleen voor wie bij de vorige vraag niet "nee" koos. Vraag om concreet gedrag, niet om een onderwerp als "AI". Eén of twee zinnen is genoeg.</a:t>
+              <a:t>Rondje door de groep, één zin per persoon of op een kaartje (circa 6 minuten). Sluit af met de contactslide. Verwijs voor echte data naar het CEDA-pakket eencijferho.</a:t>
             </a:r>
             <a:endParaRPr lang="en-US" dirty="0"/>
           </a:p>
@@ -2447,7 +2446,7 @@
           <a:p>
             <a:r>
               <a:rPr lang="en-US" dirty="0"/>
-              <a:t>Rondje door de groep, één zin per persoon of op een kaartje (circa 6 minuten). Sluit af met de contactslide. Verwijs voor echte data naar het CEDA-pakket eencijferho.</a:t>
+              <a:t>Vaste afsluitslide: laat deze staan tijdens de vragen, zodat iedereen de links ziet.</a:t>
             </a:r>
             <a:endParaRPr lang="en-US" dirty="0"/>
           </a:p>
@@ -2471,94 +2470,6 @@
             <a:fld id="{F7021451-1387-4CA6-816F-3879F97B5CBC}" type="slidenum">
               <a:rPr lang="en-US"/>
               <a:t>27</a:t>
-            </a:fld>
-            <a:endParaRPr lang="en-US"/>
-          </a:p>
-        </p:txBody>
-      </p:sp>
-    </p:spTree>
-    <p:extLst>
-      <p:ext uri="{BB962C8B-B14F-4D97-AF65-F5344CB8AC3E}">
-        <p14:creationId xmlns:p14="http://schemas.microsoft.com/office/powerpoint/2010/main" val="1024086991"/>
-      </p:ext>
-    </p:extLst>
-  </p:cSld>
-  <p:clrMapOvr>
-    <a:masterClrMapping/>
-  </p:clrMapOvr>
-</p:notes>
-</file>
-
-<file path=ppt/notesSlides/notesSlide28.xml><?xml version="1.0" encoding="utf-8"?>
-<p:notes xmlns:a="http://schemas.openxmlformats.org/drawingml/2006/main" xmlns:r="http://schemas.openxmlformats.org/officeDocument/2006/relationships" xmlns:p="http://schemas.openxmlformats.org/presentationml/2006/main">
-  <p:cSld>
-    <p:spTree>
-      <p:nvGrpSpPr>
-        <p:cNvPr id="1" name=""/>
-        <p:cNvGrpSpPr/>
-        <p:nvPr/>
-      </p:nvGrpSpPr>
-      <p:grpSpPr>
-        <a:xfrm>
-          <a:off x="0" y="0"/>
-          <a:ext cx="0" cy="0"/>
-          <a:chOff x="0" y="0"/>
-          <a:chExt cx="0" cy="0"/>
-        </a:xfrm>
-      </p:grpSpPr>
-      <p:sp>
-        <p:nvSpPr>
-          <p:cNvPr id="2" name="Slide Image Placeholder 1"/>
-          <p:cNvSpPr>
-            <a:spLocks noGrp="1" noRot="1" noChangeAspect="1"/>
-          </p:cNvSpPr>
-          <p:nvPr>
-            <p:ph type="sldImg"/>
-          </p:nvPr>
-        </p:nvSpPr>
-        <p:spPr/>
-      </p:sp>
-      <p:sp>
-        <p:nvSpPr>
-          <p:cNvPr id="3" name="Notes Placeholder 2"/>
-          <p:cNvSpPr>
-            <a:spLocks noGrp="1"/>
-          </p:cNvSpPr>
-          <p:nvPr>
-            <p:ph type="body" idx="1"/>
-          </p:nvPr>
-        </p:nvSpPr>
-        <p:spPr/>
-        <p:txBody>
-          <a:bodyPr/>
-          <a:lstStyle/>
-          <a:p>
-            <a:r>
-              <a:rPr lang="en-US" dirty="0"/>
-              <a:t>Vaste afsluitslide: laat deze staan tijdens de vragen, zodat iedereen de links ziet.</a:t>
-            </a:r>
-            <a:endParaRPr lang="en-US" dirty="0"/>
-          </a:p>
-        </p:txBody>
-      </p:sp>
-      <p:sp>
-        <p:nvSpPr>
-          <p:cNvPr id="4" name="Slide Number Placeholder 3"/>
-          <p:cNvSpPr>
-            <a:spLocks noGrp="1"/>
-          </p:cNvSpPr>
-          <p:nvPr>
-            <p:ph type="sldNum" sz="quarter" idx="10"/>
-          </p:nvPr>
-        </p:nvSpPr>
-        <p:spPr/>
-        <p:txBody>
-          <a:bodyPr/>
-          <a:lstStyle/>
-          <a:p>
-            <a:fld id="{F7021451-1387-4CA6-816F-3879F97B5CBC}" type="slidenum">
-              <a:rPr lang="en-US"/>
-              <a:t>28</a:t>
             </a:fld>
             <a:endParaRPr lang="en-US"/>
           </a:p>
@@ -3151,7 +3062,7 @@
           <a:p>
             <a:r>
               <a:rPr lang="en-US" dirty="0"/>
-              <a:t>Noem de drie skills bij naam: /workshop-verkennen, /workshop-dashboard en /workshop-reflectie. De deelnemers gebruiken ze niet zelf in de rondes: de leider laat ze draaien bij de spiegelmomenten en legt dan uit wat erin staat en wat de skill afdwingt.</a:t>
+              <a:t>Noem de twee skills bij naam: /workshop-verkennen en /workshop-dashboard. De deelnemers gebruiken ze niet zelf in de rondes: de leider laat ze draaien bij de spiegelmomenten en legt dan uit wat erin staat en wat de skill afdwingt.</a:t>
             </a:r>
             <a:endParaRPr lang="en-US" dirty="0"/>
           </a:p>
@@ -15309,1151 +15220,6 @@
     <p:bg>
       <p:bgPr>
         <a:solidFill>
-          <a:srgbClr val="CCEEE6"/>
-        </a:solidFill>
-      </p:bgPr>
-    </p:bg>
-    <p:spTree>
-      <p:nvGrpSpPr>
-        <p:cNvPr id="1" name=""/>
-        <p:cNvGrpSpPr/>
-        <p:nvPr/>
-      </p:nvGrpSpPr>
-      <p:grpSpPr>
-        <a:xfrm>
-          <a:off x="0" y="0"/>
-          <a:ext cx="0" cy="0"/>
-          <a:chOff x="0" y="0"/>
-          <a:chExt cx="0" cy="0"/>
-        </a:xfrm>
-      </p:grpSpPr>
-      <p:sp>
-        <p:nvSpPr>
-          <p:cNvPr id="72" name="Text 70"/>
-          <p:cNvSpPr/>
-          <p:nvPr/>
-        </p:nvSpPr>
-        <p:spPr>
-          <a:xfrm>
-            <a:off x="548640" y="411480"/>
-            <a:ext cx="10088575" cy="777240"/>
-          </a:xfrm>
-          <a:prstGeom prst="rect">
-            <a:avLst/>
-          </a:prstGeom>
-          <a:noFill/>
-          <a:ln/>
-        </p:spPr>
-        <p:txBody>
-          <a:bodyPr wrap="square" lIns="0" tIns="0" rIns="0" bIns="0" rtlCol="0" anchor="ctr"/>
-          <a:lstStyle/>
-          <a:p>
-            <a:pPr algn="l" indent="0" marL="0">
-              <a:lnSpc>
-                <a:spcPct val="105000"/>
-              </a:lnSpc>
-              <a:buNone/>
-            </a:pPr>
-            <a:r>
-              <a:rPr lang="en-US" sz="3400" dirty="0">
-                <a:solidFill>
-                  <a:srgbClr val="3D68EC"/>
-                </a:solidFill>
-                <a:latin typeface="General Sans Semibold" pitchFamily="34" charset="0"/>
-                <a:ea typeface="General Sans Semibold" pitchFamily="34" charset="-122"/>
-                <a:cs typeface="General Sans Semibold" pitchFamily="34" charset="-120"/>
-              </a:rPr>
-              <a:t>/workshop-reflectie: wat de skill doet</a:t>
-            </a:r>
-            <a:endParaRPr lang="en-US" sz="3400" dirty="0"/>
-          </a:p>
-        </p:txBody>
-      </p:sp>
-      <p:sp>
-        <p:nvSpPr>
-          <p:cNvPr id="73" name="Shape 71"/>
-          <p:cNvSpPr/>
-          <p:nvPr/>
-        </p:nvSpPr>
-        <p:spPr>
-          <a:xfrm>
-            <a:off x="548640" y="1371600"/>
-            <a:ext cx="2430704" cy="3016758"/>
-          </a:xfrm>
-          <a:prstGeom prst="roundRect">
-            <a:avLst>
-              <a:gd name="adj" fmla="val 3962"/>
-            </a:avLst>
-          </a:prstGeom>
-          <a:solidFill>
-            <a:srgbClr val="3D68EC"/>
-          </a:solidFill>
-          <a:ln/>
-        </p:spPr>
-      </p:sp>
-      <p:sp>
-        <p:nvSpPr>
-          <p:cNvPr id="74" name="Shape 72"/>
-          <p:cNvSpPr/>
-          <p:nvPr/>
-        </p:nvSpPr>
-        <p:spPr>
-          <a:xfrm>
-            <a:off x="822960" y="1645920"/>
-            <a:ext cx="548640" cy="548640"/>
-          </a:xfrm>
-          <a:prstGeom prst="ellipse">
-            <a:avLst/>
-          </a:prstGeom>
-          <a:solidFill>
-            <a:srgbClr val="F4D74B"/>
-          </a:solidFill>
-          <a:ln/>
-        </p:spPr>
-      </p:sp>
-      <p:sp>
-        <p:nvSpPr>
-          <p:cNvPr id="75" name="Text 73"/>
-          <p:cNvSpPr/>
-          <p:nvPr/>
-        </p:nvSpPr>
-        <p:spPr>
-          <a:xfrm>
-            <a:off x="822960" y="1645920"/>
-            <a:ext cx="548640" cy="548640"/>
-          </a:xfrm>
-          <a:prstGeom prst="rect">
-            <a:avLst/>
-          </a:prstGeom>
-          <a:noFill/>
-          <a:ln/>
-        </p:spPr>
-        <p:txBody>
-          <a:bodyPr wrap="square" lIns="0" tIns="0" rIns="0" bIns="0" rtlCol="0" anchor="ctr"/>
-          <a:lstStyle/>
-          <a:p>
-            <a:pPr algn="ctr" indent="0" marL="0">
-              <a:lnSpc>
-                <a:spcPct val="105000"/>
-              </a:lnSpc>
-              <a:buNone/>
-            </a:pPr>
-            <a:r>
-              <a:rPr lang="en-US" sz="2000" dirty="0">
-                <a:solidFill>
-                  <a:srgbClr val="3D68EC"/>
-                </a:solidFill>
-                <a:latin typeface="General Sans Semibold" pitchFamily="34" charset="0"/>
-                <a:ea typeface="General Sans Semibold" pitchFamily="34" charset="-122"/>
-                <a:cs typeface="General Sans Semibold" pitchFamily="34" charset="-120"/>
-              </a:rPr>
-              <a:t>1</a:t>
-            </a:r>
-            <a:endParaRPr lang="en-US" sz="2000" dirty="0"/>
-          </a:p>
-        </p:txBody>
-      </p:sp>
-      <p:sp>
-        <p:nvSpPr>
-          <p:cNvPr id="76" name="Shape 74"/>
-          <p:cNvSpPr/>
-          <p:nvPr/>
-        </p:nvSpPr>
-        <p:spPr>
-          <a:xfrm>
-            <a:off x="1508760" y="1719072"/>
-            <a:ext cx="1196264" cy="402336"/>
-          </a:xfrm>
-          <a:prstGeom prst="roundRect">
-            <a:avLst>
-              <a:gd name="adj" fmla="val 113636"/>
-            </a:avLst>
-          </a:prstGeom>
-          <a:solidFill>
-            <a:srgbClr val="F4D74B"/>
-          </a:solidFill>
-          <a:ln/>
-        </p:spPr>
-      </p:sp>
-      <p:sp>
-        <p:nvSpPr>
-          <p:cNvPr id="77" name="Text 75"/>
-          <p:cNvSpPr/>
-          <p:nvPr/>
-        </p:nvSpPr>
-        <p:spPr>
-          <a:xfrm>
-            <a:off x="1600200" y="1719072"/>
-            <a:ext cx="1013384" cy="402336"/>
-          </a:xfrm>
-          <a:prstGeom prst="rect">
-            <a:avLst/>
-          </a:prstGeom>
-          <a:noFill/>
-          <a:ln/>
-        </p:spPr>
-        <p:txBody>
-          <a:bodyPr wrap="square" lIns="0" tIns="0" rIns="0" bIns="0" rtlCol="0" anchor="ctr"/>
-          <a:lstStyle/>
-          <a:p>
-            <a:pPr algn="ctr" indent="0" marL="0">
-              <a:lnSpc>
-                <a:spcPct val="105000"/>
-              </a:lnSpc>
-              <a:buNone/>
-            </a:pPr>
-            <a:r>
-              <a:rPr lang="en-US" sz="1200" dirty="0">
-                <a:solidFill>
-                  <a:srgbClr val="3D68EC"/>
-                </a:solidFill>
-                <a:latin typeface="General Sans Semibold" pitchFamily="34" charset="0"/>
-                <a:ea typeface="General Sans Semibold" pitchFamily="34" charset="-122"/>
-                <a:cs typeface="General Sans Semibold" pitchFamily="34" charset="-120"/>
-              </a:rPr>
-              <a:t>Toestemming</a:t>
-            </a:r>
-            <a:endParaRPr lang="en-US" sz="1200" dirty="0"/>
-          </a:p>
-        </p:txBody>
-      </p:sp>
-      <p:sp>
-        <p:nvSpPr>
-          <p:cNvPr id="78" name="Text 76"/>
-          <p:cNvSpPr/>
-          <p:nvPr/>
-        </p:nvSpPr>
-        <p:spPr>
-          <a:xfrm>
-            <a:off x="822960" y="2423160"/>
-            <a:ext cx="1882064" cy="338328"/>
-          </a:xfrm>
-          <a:prstGeom prst="rect">
-            <a:avLst/>
-          </a:prstGeom>
-          <a:noFill/>
-          <a:ln/>
-        </p:spPr>
-        <p:txBody>
-          <a:bodyPr wrap="square" lIns="0" tIns="0" rIns="0" bIns="0" rtlCol="0" anchor="t"/>
-          <a:lstStyle/>
-          <a:p>
-            <a:pPr algn="l" indent="0" marL="0">
-              <a:lnSpc>
-                <a:spcPct val="105000"/>
-              </a:lnSpc>
-              <a:buNone/>
-            </a:pPr>
-            <a:r>
-              <a:rPr lang="en-US" sz="2000" dirty="0">
-                <a:solidFill>
-                  <a:srgbClr val="F4D9DC"/>
-                </a:solidFill>
-                <a:latin typeface="General Sans Semibold" pitchFamily="34" charset="0"/>
-                <a:ea typeface="General Sans Semibold" pitchFamily="34" charset="-122"/>
-                <a:cs typeface="General Sans Semibold" pitchFamily="34" charset="-120"/>
-              </a:rPr>
-              <a:t>Eén zin</a:t>
-            </a:r>
-            <a:endParaRPr lang="en-US" sz="2000" dirty="0"/>
-          </a:p>
-        </p:txBody>
-      </p:sp>
-      <p:sp>
-        <p:nvSpPr>
-          <p:cNvPr id="79" name="Text 77"/>
-          <p:cNvSpPr/>
-          <p:nvPr/>
-        </p:nvSpPr>
-        <p:spPr>
-          <a:xfrm>
-            <a:off x="822960" y="3035808"/>
-            <a:ext cx="1882064" cy="1215390"/>
-          </a:xfrm>
-          <a:prstGeom prst="rect">
-            <a:avLst/>
-          </a:prstGeom>
-          <a:noFill/>
-          <a:ln/>
-        </p:spPr>
-        <p:txBody>
-          <a:bodyPr wrap="square" lIns="0" tIns="0" rIns="0" bIns="0" rtlCol="0" anchor="t"/>
-          <a:lstStyle/>
-          <a:p>
-            <a:pPr algn="l" indent="0" marL="0">
-              <a:lnSpc>
-                <a:spcPct val="105000"/>
-              </a:lnSpc>
-              <a:buNone/>
-            </a:pPr>
-            <a:r>
-              <a:rPr lang="en-US" sz="1500" dirty="0">
-                <a:solidFill>
-                  <a:srgbClr val="F4D9DC"/>
-                </a:solidFill>
-                <a:latin typeface="General Sans" pitchFamily="34" charset="0"/>
-                <a:ea typeface="General Sans" pitchFamily="34" charset="-122"/>
-                <a:cs typeface="General Sans" pitchFamily="34" charset="-120"/>
-              </a:rPr>
-              <a:t>Anoniem, om te bepalen of er een vervolg komt. Zonder ja wordt niets bewaard.</a:t>
-            </a:r>
-            <a:endParaRPr lang="en-US" sz="1500" dirty="0"/>
-          </a:p>
-        </p:txBody>
-      </p:sp>
-      <p:sp>
-        <p:nvSpPr>
-          <p:cNvPr id="80" name="Shape 78"/>
-          <p:cNvSpPr/>
-          <p:nvPr/>
-        </p:nvSpPr>
-        <p:spPr>
-          <a:xfrm>
-            <a:off x="3089072" y="2605659"/>
-            <a:ext cx="237744" cy="548640"/>
-          </a:xfrm>
-          <a:prstGeom prst="chevron">
-            <a:avLst/>
-          </a:prstGeom>
-          <a:solidFill>
-            <a:srgbClr val="3D68EC"/>
-          </a:solidFill>
-          <a:ln/>
-        </p:spPr>
-      </p:sp>
-      <p:sp>
-        <p:nvSpPr>
-          <p:cNvPr id="81" name="Shape 79"/>
-          <p:cNvSpPr/>
-          <p:nvPr/>
-        </p:nvSpPr>
-        <p:spPr>
-          <a:xfrm>
-            <a:off x="3436544" y="1371600"/>
-            <a:ext cx="2430704" cy="3016758"/>
-          </a:xfrm>
-          <a:prstGeom prst="roundRect">
-            <a:avLst>
-              <a:gd name="adj" fmla="val 3962"/>
-            </a:avLst>
-          </a:prstGeom>
-          <a:solidFill>
-            <a:srgbClr val="DD784B"/>
-          </a:solidFill>
-          <a:ln/>
-        </p:spPr>
-      </p:sp>
-      <p:sp>
-        <p:nvSpPr>
-          <p:cNvPr id="82" name="Shape 80"/>
-          <p:cNvSpPr/>
-          <p:nvPr/>
-        </p:nvSpPr>
-        <p:spPr>
-          <a:xfrm>
-            <a:off x="3710864" y="1645920"/>
-            <a:ext cx="548640" cy="548640"/>
-          </a:xfrm>
-          <a:prstGeom prst="ellipse">
-            <a:avLst/>
-          </a:prstGeom>
-          <a:solidFill>
-            <a:srgbClr val="F4D9DC"/>
-          </a:solidFill>
-          <a:ln/>
-        </p:spPr>
-      </p:sp>
-      <p:sp>
-        <p:nvSpPr>
-          <p:cNvPr id="83" name="Text 81"/>
-          <p:cNvSpPr/>
-          <p:nvPr/>
-        </p:nvSpPr>
-        <p:spPr>
-          <a:xfrm>
-            <a:off x="3710864" y="1645920"/>
-            <a:ext cx="548640" cy="548640"/>
-          </a:xfrm>
-          <a:prstGeom prst="rect">
-            <a:avLst/>
-          </a:prstGeom>
-          <a:noFill/>
-          <a:ln/>
-        </p:spPr>
-        <p:txBody>
-          <a:bodyPr wrap="square" lIns="0" tIns="0" rIns="0" bIns="0" rtlCol="0" anchor="ctr"/>
-          <a:lstStyle/>
-          <a:p>
-            <a:pPr algn="ctr" indent="0" marL="0">
-              <a:lnSpc>
-                <a:spcPct val="105000"/>
-              </a:lnSpc>
-              <a:buNone/>
-            </a:pPr>
-            <a:r>
-              <a:rPr lang="en-US" sz="2000" dirty="0">
-                <a:solidFill>
-                  <a:srgbClr val="000000"/>
-                </a:solidFill>
-                <a:latin typeface="General Sans Semibold" pitchFamily="34" charset="0"/>
-                <a:ea typeface="General Sans Semibold" pitchFamily="34" charset="-122"/>
-                <a:cs typeface="General Sans Semibold" pitchFamily="34" charset="-120"/>
-              </a:rPr>
-              <a:t>2</a:t>
-            </a:r>
-            <a:endParaRPr lang="en-US" sz="2000" dirty="0"/>
-          </a:p>
-        </p:txBody>
-      </p:sp>
-      <p:sp>
-        <p:nvSpPr>
-          <p:cNvPr id="84" name="Shape 82"/>
-          <p:cNvSpPr/>
-          <p:nvPr/>
-        </p:nvSpPr>
-        <p:spPr>
-          <a:xfrm>
-            <a:off x="4396664" y="1719072"/>
-            <a:ext cx="1196264" cy="402336"/>
-          </a:xfrm>
-          <a:prstGeom prst="roundRect">
-            <a:avLst>
-              <a:gd name="adj" fmla="val 113636"/>
-            </a:avLst>
-          </a:prstGeom>
-          <a:solidFill>
-            <a:srgbClr val="F4D9DC"/>
-          </a:solidFill>
-          <a:ln/>
-        </p:spPr>
-      </p:sp>
-      <p:sp>
-        <p:nvSpPr>
-          <p:cNvPr id="85" name="Text 83"/>
-          <p:cNvSpPr/>
-          <p:nvPr/>
-        </p:nvSpPr>
-        <p:spPr>
-          <a:xfrm>
-            <a:off x="4488104" y="1719072"/>
-            <a:ext cx="1013384" cy="402336"/>
-          </a:xfrm>
-          <a:prstGeom prst="rect">
-            <a:avLst/>
-          </a:prstGeom>
-          <a:noFill/>
-          <a:ln/>
-        </p:spPr>
-        <p:txBody>
-          <a:bodyPr wrap="square" lIns="0" tIns="0" rIns="0" bIns="0" rtlCol="0" anchor="ctr"/>
-          <a:lstStyle/>
-          <a:p>
-            <a:pPr algn="ctr" indent="0" marL="0">
-              <a:lnSpc>
-                <a:spcPct val="105000"/>
-              </a:lnSpc>
-              <a:buNone/>
-            </a:pPr>
-            <a:r>
-              <a:rPr lang="en-US" sz="1200" dirty="0">
-                <a:solidFill>
-                  <a:srgbClr val="000000"/>
-                </a:solidFill>
-                <a:latin typeface="General Sans Semibold" pitchFamily="34" charset="0"/>
-                <a:ea typeface="General Sans Semibold" pitchFamily="34" charset="-122"/>
-                <a:cs typeface="General Sans Semibold" pitchFamily="34" charset="-120"/>
-              </a:rPr>
-              <a:t>Terugblik</a:t>
-            </a:r>
-            <a:endParaRPr lang="en-US" sz="1200" dirty="0"/>
-          </a:p>
-        </p:txBody>
-      </p:sp>
-      <p:sp>
-        <p:nvSpPr>
-          <p:cNvPr id="86" name="Text 84"/>
-          <p:cNvSpPr/>
-          <p:nvPr/>
-        </p:nvSpPr>
-        <p:spPr>
-          <a:xfrm>
-            <a:off x="3710864" y="2423160"/>
-            <a:ext cx="1882064" cy="338328"/>
-          </a:xfrm>
-          <a:prstGeom prst="rect">
-            <a:avLst/>
-          </a:prstGeom>
-          <a:noFill/>
-          <a:ln/>
-        </p:spPr>
-        <p:txBody>
-          <a:bodyPr wrap="square" lIns="0" tIns="0" rIns="0" bIns="0" rtlCol="0" anchor="t"/>
-          <a:lstStyle/>
-          <a:p>
-            <a:pPr algn="l" indent="0" marL="0">
-              <a:lnSpc>
-                <a:spcPct val="105000"/>
-              </a:lnSpc>
-              <a:buNone/>
-            </a:pPr>
-            <a:r>
-              <a:rPr lang="en-US" sz="2000" dirty="0">
-                <a:solidFill>
-                  <a:srgbClr val="000000"/>
-                </a:solidFill>
-                <a:latin typeface="General Sans Semibold" pitchFamily="34" charset="0"/>
-                <a:ea typeface="General Sans Semibold" pitchFamily="34" charset="-122"/>
-                <a:cs typeface="General Sans Semibold" pitchFamily="34" charset="-120"/>
-              </a:rPr>
-              <a:t>Drie vragen</a:t>
-            </a:r>
-            <a:endParaRPr lang="en-US" sz="2000" dirty="0"/>
-          </a:p>
-        </p:txBody>
-      </p:sp>
-      <p:sp>
-        <p:nvSpPr>
-          <p:cNvPr id="87" name="Text 85"/>
-          <p:cNvSpPr/>
-          <p:nvPr/>
-        </p:nvSpPr>
-        <p:spPr>
-          <a:xfrm>
-            <a:off x="3710864" y="3035808"/>
-            <a:ext cx="1882064" cy="1215390"/>
-          </a:xfrm>
-          <a:prstGeom prst="rect">
-            <a:avLst/>
-          </a:prstGeom>
-          <a:noFill/>
-          <a:ln/>
-        </p:spPr>
-        <p:txBody>
-          <a:bodyPr wrap="square" lIns="0" tIns="0" rIns="0" bIns="0" rtlCol="0" anchor="t"/>
-          <a:lstStyle/>
-          <a:p>
-            <a:pPr algn="l" indent="0" marL="0">
-              <a:lnSpc>
-                <a:spcPct val="105000"/>
-              </a:lnSpc>
-              <a:buNone/>
-            </a:pPr>
-            <a:r>
-              <a:rPr lang="en-US" sz="1500" dirty="0">
-                <a:solidFill>
-                  <a:srgbClr val="000000"/>
-                </a:solidFill>
-                <a:latin typeface="General Sans" pitchFamily="34" charset="0"/>
-                <a:ea typeface="General Sans" pitchFamily="34" charset="-122"/>
-                <a:cs typeface="General Sans" pitchFamily="34" charset="-120"/>
-              </a:rPr>
-              <a:t>Werkwijze, wat ging goed en wat zie je nu pas. Eén vraag per keer.</a:t>
-            </a:r>
-            <a:endParaRPr lang="en-US" sz="1500" dirty="0"/>
-          </a:p>
-        </p:txBody>
-      </p:sp>
-      <p:sp>
-        <p:nvSpPr>
-          <p:cNvPr id="88" name="Shape 86"/>
-          <p:cNvSpPr/>
-          <p:nvPr/>
-        </p:nvSpPr>
-        <p:spPr>
-          <a:xfrm>
-            <a:off x="5976976" y="2605659"/>
-            <a:ext cx="237744" cy="548640"/>
-          </a:xfrm>
-          <a:prstGeom prst="chevron">
-            <a:avLst/>
-          </a:prstGeom>
-          <a:solidFill>
-            <a:srgbClr val="3D68EC"/>
-          </a:solidFill>
-          <a:ln/>
-        </p:spPr>
-      </p:sp>
-      <p:sp>
-        <p:nvSpPr>
-          <p:cNvPr id="89" name="Shape 87"/>
-          <p:cNvSpPr/>
-          <p:nvPr/>
-        </p:nvSpPr>
-        <p:spPr>
-          <a:xfrm>
-            <a:off x="6324448" y="1371600"/>
-            <a:ext cx="2430704" cy="3016758"/>
-          </a:xfrm>
-          <a:prstGeom prst="roundRect">
-            <a:avLst>
-              <a:gd name="adj" fmla="val 3962"/>
-            </a:avLst>
-          </a:prstGeom>
-          <a:solidFill>
-            <a:srgbClr val="00AF81"/>
-          </a:solidFill>
-          <a:ln/>
-        </p:spPr>
-      </p:sp>
-      <p:sp>
-        <p:nvSpPr>
-          <p:cNvPr id="90" name="Shape 88"/>
-          <p:cNvSpPr/>
-          <p:nvPr/>
-        </p:nvSpPr>
-        <p:spPr>
-          <a:xfrm>
-            <a:off x="6598768" y="1645920"/>
-            <a:ext cx="548640" cy="548640"/>
-          </a:xfrm>
-          <a:prstGeom prst="ellipse">
-            <a:avLst/>
-          </a:prstGeom>
-          <a:solidFill>
-            <a:srgbClr val="F4D9DC"/>
-          </a:solidFill>
-          <a:ln/>
-        </p:spPr>
-      </p:sp>
-      <p:sp>
-        <p:nvSpPr>
-          <p:cNvPr id="91" name="Text 89"/>
-          <p:cNvSpPr/>
-          <p:nvPr/>
-        </p:nvSpPr>
-        <p:spPr>
-          <a:xfrm>
-            <a:off x="6598768" y="1645920"/>
-            <a:ext cx="548640" cy="548640"/>
-          </a:xfrm>
-          <a:prstGeom prst="rect">
-            <a:avLst/>
-          </a:prstGeom>
-          <a:noFill/>
-          <a:ln/>
-        </p:spPr>
-        <p:txBody>
-          <a:bodyPr wrap="square" lIns="0" tIns="0" rIns="0" bIns="0" rtlCol="0" anchor="ctr"/>
-          <a:lstStyle/>
-          <a:p>
-            <a:pPr algn="ctr" indent="0" marL="0">
-              <a:lnSpc>
-                <a:spcPct val="105000"/>
-              </a:lnSpc>
-              <a:buNone/>
-            </a:pPr>
-            <a:r>
-              <a:rPr lang="en-US" sz="2000" dirty="0">
-                <a:solidFill>
-                  <a:srgbClr val="000000"/>
-                </a:solidFill>
-                <a:latin typeface="General Sans Semibold" pitchFamily="34" charset="0"/>
-                <a:ea typeface="General Sans Semibold" pitchFamily="34" charset="-122"/>
-                <a:cs typeface="General Sans Semibold" pitchFamily="34" charset="-120"/>
-              </a:rPr>
-              <a:t>3</a:t>
-            </a:r>
-            <a:endParaRPr lang="en-US" sz="2000" dirty="0"/>
-          </a:p>
-        </p:txBody>
-      </p:sp>
-      <p:sp>
-        <p:nvSpPr>
-          <p:cNvPr id="92" name="Shape 90"/>
-          <p:cNvSpPr/>
-          <p:nvPr/>
-        </p:nvSpPr>
-        <p:spPr>
-          <a:xfrm>
-            <a:off x="7284568" y="1719072"/>
-            <a:ext cx="1196264" cy="402336"/>
-          </a:xfrm>
-          <a:prstGeom prst="roundRect">
-            <a:avLst>
-              <a:gd name="adj" fmla="val 113636"/>
-            </a:avLst>
-          </a:prstGeom>
-          <a:solidFill>
-            <a:srgbClr val="F4D9DC"/>
-          </a:solidFill>
-          <a:ln/>
-        </p:spPr>
-      </p:sp>
-      <p:sp>
-        <p:nvSpPr>
-          <p:cNvPr id="93" name="Text 91"/>
-          <p:cNvSpPr/>
-          <p:nvPr/>
-        </p:nvSpPr>
-        <p:spPr>
-          <a:xfrm>
-            <a:off x="7376008" y="1719072"/>
-            <a:ext cx="1013384" cy="402336"/>
-          </a:xfrm>
-          <a:prstGeom prst="rect">
-            <a:avLst/>
-          </a:prstGeom>
-          <a:noFill/>
-          <a:ln/>
-        </p:spPr>
-        <p:txBody>
-          <a:bodyPr wrap="square" lIns="0" tIns="0" rIns="0" bIns="0" rtlCol="0" anchor="ctr"/>
-          <a:lstStyle/>
-          <a:p>
-            <a:pPr algn="ctr" indent="0" marL="0">
-              <a:lnSpc>
-                <a:spcPct val="105000"/>
-              </a:lnSpc>
-              <a:buNone/>
-            </a:pPr>
-            <a:r>
-              <a:rPr lang="en-US" sz="1200" dirty="0">
-                <a:solidFill>
-                  <a:srgbClr val="000000"/>
-                </a:solidFill>
-                <a:latin typeface="General Sans Semibold" pitchFamily="34" charset="0"/>
-                <a:ea typeface="General Sans Semibold" pitchFamily="34" charset="-122"/>
-                <a:cs typeface="General Sans Semibold" pitchFamily="34" charset="-120"/>
-              </a:rPr>
-              <a:t>Peiling</a:t>
-            </a:r>
-            <a:endParaRPr lang="en-US" sz="1200" dirty="0"/>
-          </a:p>
-        </p:txBody>
-      </p:sp>
-      <p:sp>
-        <p:nvSpPr>
-          <p:cNvPr id="94" name="Text 92"/>
-          <p:cNvSpPr/>
-          <p:nvPr/>
-        </p:nvSpPr>
-        <p:spPr>
-          <a:xfrm>
-            <a:off x="6598768" y="2423160"/>
-            <a:ext cx="1882064" cy="338328"/>
-          </a:xfrm>
-          <a:prstGeom prst="rect">
-            <a:avLst/>
-          </a:prstGeom>
-          <a:noFill/>
-          <a:ln/>
-        </p:spPr>
-        <p:txBody>
-          <a:bodyPr wrap="square" lIns="0" tIns="0" rIns="0" bIns="0" rtlCol="0" anchor="t"/>
-          <a:lstStyle/>
-          <a:p>
-            <a:pPr algn="l" indent="0" marL="0">
-              <a:lnSpc>
-                <a:spcPct val="105000"/>
-              </a:lnSpc>
-              <a:buNone/>
-            </a:pPr>
-            <a:r>
-              <a:rPr lang="en-US" sz="2000" dirty="0">
-                <a:solidFill>
-                  <a:srgbClr val="000000"/>
-                </a:solidFill>
-                <a:latin typeface="General Sans Semibold" pitchFamily="34" charset="0"/>
-                <a:ea typeface="General Sans Semibold" pitchFamily="34" charset="-122"/>
-                <a:cs typeface="General Sans Semibold" pitchFamily="34" charset="-120"/>
-              </a:rPr>
-              <a:t>Meerkeuze</a:t>
-            </a:r>
-            <a:endParaRPr lang="en-US" sz="2000" dirty="0"/>
-          </a:p>
-        </p:txBody>
-      </p:sp>
-      <p:sp>
-        <p:nvSpPr>
-          <p:cNvPr id="95" name="Text 93"/>
-          <p:cNvSpPr/>
-          <p:nvPr/>
-        </p:nvSpPr>
-        <p:spPr>
-          <a:xfrm>
-            <a:off x="6598768" y="3035808"/>
-            <a:ext cx="1882064" cy="1215390"/>
-          </a:xfrm>
-          <a:prstGeom prst="rect">
-            <a:avLst/>
-          </a:prstGeom>
-          <a:noFill/>
-          <a:ln/>
-        </p:spPr>
-        <p:txBody>
-          <a:bodyPr wrap="square" lIns="0" tIns="0" rIns="0" bIns="0" rtlCol="0" anchor="t"/>
-          <a:lstStyle/>
-          <a:p>
-            <a:pPr algn="l" indent="0" marL="0">
-              <a:lnSpc>
-                <a:spcPct val="105000"/>
-              </a:lnSpc>
-              <a:buNone/>
-            </a:pPr>
-            <a:r>
-              <a:rPr lang="en-US" sz="1500" dirty="0">
-                <a:solidFill>
-                  <a:srgbClr val="000000"/>
-                </a:solidFill>
-                <a:latin typeface="General Sans" pitchFamily="34" charset="0"/>
-                <a:ea typeface="General Sans" pitchFamily="34" charset="-122"/>
-                <a:cs typeface="General Sans" pitchFamily="34" charset="-120"/>
-              </a:rPr>
-              <a:t>Interesse in een training, van nee tot 4 uur per week voor een semester.</a:t>
-            </a:r>
-            <a:endParaRPr lang="en-US" sz="1500" dirty="0"/>
-          </a:p>
-        </p:txBody>
-      </p:sp>
-      <p:sp>
-        <p:nvSpPr>
-          <p:cNvPr id="96" name="Shape 94"/>
-          <p:cNvSpPr/>
-          <p:nvPr/>
-        </p:nvSpPr>
-        <p:spPr>
-          <a:xfrm>
-            <a:off x="8864879" y="2605659"/>
-            <a:ext cx="237744" cy="548640"/>
-          </a:xfrm>
-          <a:prstGeom prst="chevron">
-            <a:avLst/>
-          </a:prstGeom>
-          <a:solidFill>
-            <a:srgbClr val="3D68EC"/>
-          </a:solidFill>
-          <a:ln/>
-        </p:spPr>
-      </p:sp>
-      <p:sp>
-        <p:nvSpPr>
-          <p:cNvPr id="97" name="Shape 95"/>
-          <p:cNvSpPr/>
-          <p:nvPr/>
-        </p:nvSpPr>
-        <p:spPr>
-          <a:xfrm>
-            <a:off x="9212351" y="1371600"/>
-            <a:ext cx="2430704" cy="3016758"/>
-          </a:xfrm>
-          <a:prstGeom prst="roundRect">
-            <a:avLst>
-              <a:gd name="adj" fmla="val 3962"/>
-            </a:avLst>
-          </a:prstGeom>
-          <a:solidFill>
-            <a:srgbClr val="F4D74B"/>
-          </a:solidFill>
-          <a:ln/>
-        </p:spPr>
-      </p:sp>
-      <p:sp>
-        <p:nvSpPr>
-          <p:cNvPr id="98" name="Shape 96"/>
-          <p:cNvSpPr/>
-          <p:nvPr/>
-        </p:nvSpPr>
-        <p:spPr>
-          <a:xfrm>
-            <a:off x="9486671" y="1645920"/>
-            <a:ext cx="548640" cy="548640"/>
-          </a:xfrm>
-          <a:prstGeom prst="ellipse">
-            <a:avLst/>
-          </a:prstGeom>
-          <a:solidFill>
-            <a:srgbClr val="3D68EC"/>
-          </a:solidFill>
-          <a:ln/>
-        </p:spPr>
-      </p:sp>
-      <p:sp>
-        <p:nvSpPr>
-          <p:cNvPr id="99" name="Text 97"/>
-          <p:cNvSpPr/>
-          <p:nvPr/>
-        </p:nvSpPr>
-        <p:spPr>
-          <a:xfrm>
-            <a:off x="9486671" y="1645920"/>
-            <a:ext cx="548640" cy="548640"/>
-          </a:xfrm>
-          <a:prstGeom prst="rect">
-            <a:avLst/>
-          </a:prstGeom>
-          <a:noFill/>
-          <a:ln/>
-        </p:spPr>
-        <p:txBody>
-          <a:bodyPr wrap="square" lIns="0" tIns="0" rIns="0" bIns="0" rtlCol="0" anchor="ctr"/>
-          <a:lstStyle/>
-          <a:p>
-            <a:pPr algn="ctr" indent="0" marL="0">
-              <a:lnSpc>
-                <a:spcPct val="105000"/>
-              </a:lnSpc>
-              <a:buNone/>
-            </a:pPr>
-            <a:r>
-              <a:rPr lang="en-US" sz="2000" dirty="0">
-                <a:solidFill>
-                  <a:srgbClr val="F4D74B"/>
-                </a:solidFill>
-                <a:latin typeface="General Sans Semibold" pitchFamily="34" charset="0"/>
-                <a:ea typeface="General Sans Semibold" pitchFamily="34" charset="-122"/>
-                <a:cs typeface="General Sans Semibold" pitchFamily="34" charset="-120"/>
-              </a:rPr>
-              <a:t>4</a:t>
-            </a:r>
-            <a:endParaRPr lang="en-US" sz="2000" dirty="0"/>
-          </a:p>
-        </p:txBody>
-      </p:sp>
-      <p:sp>
-        <p:nvSpPr>
-          <p:cNvPr id="100" name="Shape 98"/>
-          <p:cNvSpPr/>
-          <p:nvPr/>
-        </p:nvSpPr>
-        <p:spPr>
-          <a:xfrm>
-            <a:off x="10172471" y="1719072"/>
-            <a:ext cx="1196264" cy="402336"/>
-          </a:xfrm>
-          <a:prstGeom prst="roundRect">
-            <a:avLst>
-              <a:gd name="adj" fmla="val 113636"/>
-            </a:avLst>
-          </a:prstGeom>
-          <a:solidFill>
-            <a:srgbClr val="3D68EC"/>
-          </a:solidFill>
-          <a:ln/>
-        </p:spPr>
-      </p:sp>
-      <p:sp>
-        <p:nvSpPr>
-          <p:cNvPr id="101" name="Text 99"/>
-          <p:cNvSpPr/>
-          <p:nvPr/>
-        </p:nvSpPr>
-        <p:spPr>
-          <a:xfrm>
-            <a:off x="10263911" y="1719072"/>
-            <a:ext cx="1013384" cy="402336"/>
-          </a:xfrm>
-          <a:prstGeom prst="rect">
-            <a:avLst/>
-          </a:prstGeom>
-          <a:noFill/>
-          <a:ln/>
-        </p:spPr>
-        <p:txBody>
-          <a:bodyPr wrap="square" lIns="0" tIns="0" rIns="0" bIns="0" rtlCol="0" anchor="ctr"/>
-          <a:lstStyle/>
-          <a:p>
-            <a:pPr algn="ctr" indent="0" marL="0">
-              <a:lnSpc>
-                <a:spcPct val="105000"/>
-              </a:lnSpc>
-              <a:buNone/>
-            </a:pPr>
-            <a:r>
-              <a:rPr lang="en-US" sz="1200" dirty="0">
-                <a:solidFill>
-                  <a:srgbClr val="F4D74B"/>
-                </a:solidFill>
-                <a:latin typeface="General Sans Semibold" pitchFamily="34" charset="0"/>
-                <a:ea typeface="General Sans Semibold" pitchFamily="34" charset="-122"/>
-                <a:cs typeface="General Sans Semibold" pitchFamily="34" charset="-120"/>
-              </a:rPr>
-              <a:t>Open vraag</a:t>
-            </a:r>
-            <a:endParaRPr lang="en-US" sz="1200" dirty="0"/>
-          </a:p>
-        </p:txBody>
-      </p:sp>
-      <p:sp>
-        <p:nvSpPr>
-          <p:cNvPr id="102" name="Text 100"/>
-          <p:cNvSpPr/>
-          <p:nvPr/>
-        </p:nvSpPr>
-        <p:spPr>
-          <a:xfrm>
-            <a:off x="9486671" y="2423160"/>
-            <a:ext cx="1882064" cy="338328"/>
-          </a:xfrm>
-          <a:prstGeom prst="rect">
-            <a:avLst/>
-          </a:prstGeom>
-          <a:noFill/>
-          <a:ln/>
-        </p:spPr>
-        <p:txBody>
-          <a:bodyPr wrap="square" lIns="0" tIns="0" rIns="0" bIns="0" rtlCol="0" anchor="t"/>
-          <a:lstStyle/>
-          <a:p>
-            <a:pPr algn="l" indent="0" marL="0">
-              <a:lnSpc>
-                <a:spcPct val="105000"/>
-              </a:lnSpc>
-              <a:buNone/>
-            </a:pPr>
-            <a:r>
-              <a:rPr lang="en-US" sz="2000" dirty="0">
-                <a:solidFill>
-                  <a:srgbClr val="3D68EC"/>
-                </a:solidFill>
-                <a:latin typeface="General Sans Semibold" pitchFamily="34" charset="0"/>
-                <a:ea typeface="General Sans Semibold" pitchFamily="34" charset="-122"/>
-                <a:cs typeface="General Sans Semibold" pitchFamily="34" charset="-120"/>
-              </a:rPr>
-              <a:t>Wat leren?</a:t>
-            </a:r>
-            <a:endParaRPr lang="en-US" sz="2000" dirty="0"/>
-          </a:p>
-        </p:txBody>
-      </p:sp>
-      <p:sp>
-        <p:nvSpPr>
-          <p:cNvPr id="103" name="Text 101"/>
-          <p:cNvSpPr/>
-          <p:nvPr/>
-        </p:nvSpPr>
-        <p:spPr>
-          <a:xfrm>
-            <a:off x="9486671" y="3035808"/>
-            <a:ext cx="1882064" cy="1215390"/>
-          </a:xfrm>
-          <a:prstGeom prst="rect">
-            <a:avLst/>
-          </a:prstGeom>
-          <a:noFill/>
-          <a:ln/>
-        </p:spPr>
-        <p:txBody>
-          <a:bodyPr wrap="square" lIns="0" tIns="0" rIns="0" bIns="0" rtlCol="0" anchor="t"/>
-          <a:lstStyle/>
-          <a:p>
-            <a:pPr algn="l" indent="0" marL="0">
-              <a:lnSpc>
-                <a:spcPct val="105000"/>
-              </a:lnSpc>
-              <a:buNone/>
-            </a:pPr>
-            <a:r>
-              <a:rPr lang="en-US" sz="1500" dirty="0">
-                <a:solidFill>
-                  <a:srgbClr val="000000"/>
-                </a:solidFill>
-                <a:latin typeface="General Sans" pitchFamily="34" charset="0"/>
-                <a:ea typeface="General Sans" pitchFamily="34" charset="-122"/>
-                <a:cs typeface="General Sans" pitchFamily="34" charset="-120"/>
-              </a:rPr>
-              <a:t>Alleen als het antwoord niet nee was. Kort en concreet.</a:t>
-            </a:r>
-            <a:endParaRPr lang="en-US" sz="1500" dirty="0"/>
-          </a:p>
-        </p:txBody>
-      </p:sp>
-      <p:sp>
-        <p:nvSpPr>
-          <p:cNvPr id="104" name="Text 102"/>
-          <p:cNvSpPr/>
-          <p:nvPr/>
-        </p:nvSpPr>
-        <p:spPr>
-          <a:xfrm>
-            <a:off x="548640" y="4571238"/>
-            <a:ext cx="11094415" cy="457200"/>
-          </a:xfrm>
-          <a:prstGeom prst="rect">
-            <a:avLst/>
-          </a:prstGeom>
-          <a:noFill/>
-          <a:ln/>
-        </p:spPr>
-        <p:txBody>
-          <a:bodyPr wrap="square" lIns="0" tIns="0" rIns="0" bIns="0" rtlCol="0" anchor="t"/>
-          <a:lstStyle/>
-          <a:p>
-            <a:pPr algn="l" indent="0" marL="0">
-              <a:lnSpc>
-                <a:spcPct val="105000"/>
-              </a:lnSpc>
-              <a:buNone/>
-            </a:pPr>
-            <a:r>
-              <a:rPr lang="en-US" sz="1800" dirty="0">
-                <a:solidFill>
-                  <a:srgbClr val="00AF81"/>
-                </a:solidFill>
-                <a:latin typeface="General Sans Semibold" pitchFamily="34" charset="0"/>
-                <a:ea typeface="General Sans Semibold" pitchFamily="34" charset="-122"/>
-                <a:cs typeface="General Sans Semibold" pitchFamily="34" charset="-120"/>
-              </a:rPr>
-              <a:t>Uit:</a:t>
-            </a:r>
-            <a:pPr algn="l" indent="0" marL="0">
-              <a:lnSpc>
-                <a:spcPct val="105000"/>
-              </a:lnSpc>
-              <a:buNone/>
-            </a:pPr>
-            <a:r>
-              <a:rPr lang="en-US" sz="1800" dirty="0">
-                <a:solidFill>
-                  <a:srgbClr val="000000"/>
-                </a:solidFill>
-                <a:latin typeface="General Sans" pitchFamily="34" charset="0"/>
-                <a:ea typeface="General Sans" pitchFamily="34" charset="-122"/>
-                <a:cs typeface="General Sans" pitchFamily="34" charset="-120"/>
-              </a:rPr>
-              <a:t> reflectie-naam.md, in jouw eigen woorden. De skill vult niets voor je in.</a:t>
-            </a:r>
-            <a:endParaRPr lang="en-US" sz="1800" dirty="0"/>
-          </a:p>
-        </p:txBody>
-      </p:sp>
-      <p:pic>
-        <p:nvPicPr>
-          <p:cNvPr id="105" name="Npuls beeldmerk" descr="npuls-beeldmerk-zwart.png"/>
-          <p:cNvPicPr>
-            <a:picLocks noChangeAspect="1"/>
-          </p:cNvPicPr>
-          <p:nvPr/>
-        </p:nvPicPr>
-        <p:blipFill>
-          <a:blip r:embed="rId3"/>
-          <a:stretch>
-            <a:fillRect/>
-          </a:stretch>
-        </p:blipFill>
-        <p:spPr>
-          <a:xfrm>
-            <a:off x="11036757" y="417830"/>
-            <a:ext cx="572516" cy="572516"/>
-          </a:xfrm>
-          <a:prstGeom prst="rect">
-            <a:avLst/>
-          </a:prstGeom>
-        </p:spPr>
-      </p:pic>
-    </p:spTree>
-  </p:cSld>
-  <p:clrMapOvr>
-    <a:masterClrMapping/>
-  </p:clrMapOvr>
-</p:sld>
-</file>
-
-<file path=ppt/slides/slide25.xml><?xml version="1.0" encoding="utf-8"?>
-<p:sld xmlns:a="http://schemas.openxmlformats.org/drawingml/2006/main" xmlns:r="http://schemas.openxmlformats.org/officeDocument/2006/relationships" xmlns:p="http://schemas.openxmlformats.org/presentationml/2006/main">
-  <p:cSld name="Slide 25">
-    <p:bg>
-      <p:bgPr>
-        <a:solidFill>
           <a:srgbClr val="D6E2FD"/>
         </a:solidFill>
       </p:bgPr>
@@ -17268,9 +16034,9 @@
 </p:sld>
 </file>
 
-<file path=ppt/slides/slide26.xml><?xml version="1.0" encoding="utf-8"?>
+<file path=ppt/slides/slide25.xml><?xml version="1.0" encoding="utf-8"?>
 <p:sld xmlns:a="http://schemas.openxmlformats.org/drawingml/2006/main" xmlns:r="http://schemas.openxmlformats.org/officeDocument/2006/relationships" xmlns:p="http://schemas.openxmlformats.org/presentationml/2006/main">
-  <p:cSld name="Slide 26">
+  <p:cSld name="Slide 25">
     <p:bg>
       <p:bgPr>
         <a:solidFill>
@@ -17432,9 +16198,9 @@
 </p:sld>
 </file>
 
-<file path=ppt/slides/slide27.xml><?xml version="1.0" encoding="utf-8"?>
+<file path=ppt/slides/slide26.xml><?xml version="1.0" encoding="utf-8"?>
 <p:sld xmlns:a="http://schemas.openxmlformats.org/drawingml/2006/main" xmlns:r="http://schemas.openxmlformats.org/officeDocument/2006/relationships" xmlns:p="http://schemas.openxmlformats.org/presentationml/2006/main">
-  <p:cSld name="Slide 27">
+  <p:cSld name="Slide 26">
     <p:bg>
       <p:bgPr>
         <a:solidFill>
@@ -17746,7 +16512,7 @@
                 <a:ea typeface="General Sans" pitchFamily="34" charset="-122"/>
                 <a:cs typeface="General Sans" pitchFamily="34" charset="-120"/>
               </a:rPr>
-              <a:t>De drie skills staan in de repo, je kunt ze zelf aanpassen.</a:t>
+              <a:t>De twee skills staan in de repo, je kunt ze zelf aanpassen.</a:t>
             </a:r>
             <a:endParaRPr lang="en-US" sz="1500" dirty="0"/>
           </a:p>
@@ -17912,9 +16678,9 @@
 </p:sld>
 </file>
 
-<file path=ppt/slides/slide28.xml><?xml version="1.0" encoding="utf-8"?>
+<file path=ppt/slides/slide27.xml><?xml version="1.0" encoding="utf-8"?>
 <p:sld xmlns:a="http://schemas.openxmlformats.org/drawingml/2006/main" xmlns:r="http://schemas.openxmlformats.org/officeDocument/2006/relationships" xmlns:p="http://schemas.openxmlformats.org/presentationml/2006/main">
-  <p:cSld name="Slide 28">
+  <p:cSld name="Slide 27">
     <p:bg>
       <p:bgPr>
         <a:blipFill dpi="0" rotWithShape="1">
@@ -20067,20 +18833,55 @@
       </p:sp>
       <p:sp>
         <p:nvSpPr>
-          <p:cNvPr id="110" name="Rounded Rectangle 109"/>
-          <p:cNvSpPr/>
-          <p:nvPr/>
-        </p:nvSpPr>
-        <p:spPr>
-          <a:xfrm>
-            <a:off x="10216286" y="5029200"/>
-            <a:ext cx="1405737" cy="310896"/>
-          </a:xfrm>
-          <a:prstGeom prst="roundRect">
+          <p:cNvPr id="110" name="TextBox 109"/>
+          <p:cNvSpPr txBox="1"/>
+          <p:nvPr/>
+        </p:nvSpPr>
+        <p:spPr>
+          <a:xfrm>
+            <a:off x="10725912" y="1719072"/>
+            <a:ext cx="914400" cy="274320"/>
+          </a:xfrm>
+          <a:prstGeom prst="rect">
+            <a:avLst/>
+          </a:prstGeom>
+          <a:noFill/>
+        </p:spPr>
+        <p:txBody>
+          <a:bodyPr wrap="square" lIns="0" rIns="0" tIns="0" bIns="0" anchor="t">
+            <a:spAutoFit/>
+          </a:bodyPr>
+          <a:lstStyle/>
+          <a:p>
+            <a:pPr algn="r"/>
+            <a:r>
+              <a:rPr sz="1400">
+                <a:solidFill>
+                  <a:srgbClr val="3D68EC"/>
+                </a:solidFill>
+                <a:latin typeface="General Sans Semibold"/>
+              </a:rPr>
+              <a:t>2:00</a:t>
+            </a:r>
+          </a:p>
+        </p:txBody>
+      </p:sp>
+      <p:sp>
+        <p:nvSpPr>
+          <p:cNvPr id="111" name="Rectangle 110"/>
+          <p:cNvSpPr/>
+          <p:nvPr/>
+        </p:nvSpPr>
+        <p:spPr>
+          <a:xfrm>
+            <a:off x="548640" y="6025896"/>
+            <a:ext cx="201168" cy="201168"/>
+          </a:xfrm>
+          <a:prstGeom prst="rect">
             <a:avLst/>
           </a:prstGeom>
           <a:solidFill>
-            <a:srgbClr val="FFFFFF"/>
+            <a:srgbClr val="F4D74B"/>
           </a:solidFill>
           <a:ln>
             <a:noFill/>
@@ -20102,73 +18903,64 @@
           </a:fontRef>
         </p:style>
         <p:txBody>
-          <a:bodyPr rtlCol="0" anchor="ctr" lIns="0" rIns="0" tIns="0" bIns="0" wrap="none"/>
+          <a:bodyPr rtlCol="0" anchor="ctr"/>
           <a:lstStyle/>
           <a:p>
             <a:pPr algn="ctr"/>
-            <a:r>
-              <a:rPr sz="900">
-                <a:solidFill>
-                  <a:srgbClr val="3D68EC"/>
-                </a:solidFill>
-                <a:latin typeface="General Sans Semibold"/>
-              </a:rPr>
-              <a:t>/workshop-reflectie</a:t>
-            </a:r>
-          </a:p>
-        </p:txBody>
-      </p:sp>
-      <p:sp>
-        <p:nvSpPr>
-          <p:cNvPr id="111" name="TextBox 110"/>
+          </a:p>
+        </p:txBody>
+      </p:sp>
+      <p:sp>
+        <p:nvSpPr>
+          <p:cNvPr id="112" name="TextBox 111"/>
           <p:cNvSpPr txBox="1"/>
           <p:nvPr/>
         </p:nvSpPr>
         <p:spPr>
           <a:xfrm>
-            <a:off x="10725912" y="1719072"/>
-            <a:ext cx="914400" cy="274320"/>
-          </a:xfrm>
-          <a:prstGeom prst="rect">
-            <a:avLst/>
-          </a:prstGeom>
-          <a:noFill/>
-        </p:spPr>
-        <p:txBody>
-          <a:bodyPr wrap="square" lIns="0" rIns="0" tIns="0" bIns="0" anchor="t">
+            <a:off x="841247" y="5989320"/>
+            <a:ext cx="2194560" cy="274320"/>
+          </a:xfrm>
+          <a:prstGeom prst="rect">
+            <a:avLst/>
+          </a:prstGeom>
+          <a:noFill/>
+        </p:spPr>
+        <p:txBody>
+          <a:bodyPr wrap="square" lIns="0" rIns="0" tIns="0" bIns="0" anchor="ctr">
             <a:spAutoFit/>
           </a:bodyPr>
           <a:lstStyle/>
           <a:p>
-            <a:pPr algn="r"/>
-            <a:r>
-              <a:rPr sz="1400">
-                <a:solidFill>
-                  <a:srgbClr val="3D68EC"/>
-                </a:solidFill>
-                <a:latin typeface="General Sans Semibold"/>
-              </a:rPr>
-              <a:t>2:00</a:t>
-            </a:r>
-          </a:p>
-        </p:txBody>
-      </p:sp>
-      <p:sp>
-        <p:nvSpPr>
-          <p:cNvPr id="112" name="Rectangle 111"/>
-          <p:cNvSpPr/>
-          <p:nvPr/>
-        </p:nvSpPr>
-        <p:spPr>
-          <a:xfrm>
-            <a:off x="548640" y="6025896"/>
+            <a:pPr algn="l"/>
+            <a:r>
+              <a:rPr sz="1200">
+                <a:solidFill>
+                  <a:srgbClr val="000000"/>
+                </a:solidFill>
+                <a:latin typeface="General Sans"/>
+              </a:rPr>
+              <a:t>Uitleg</a:t>
+            </a:r>
+          </a:p>
+        </p:txBody>
+      </p:sp>
+      <p:sp>
+        <p:nvSpPr>
+          <p:cNvPr id="113" name="Rectangle 112"/>
+          <p:cNvSpPr/>
+          <p:nvPr/>
+        </p:nvSpPr>
+        <p:spPr>
+          <a:xfrm>
+            <a:off x="1901952" y="6025896"/>
             <a:ext cx="201168" cy="201168"/>
           </a:xfrm>
           <a:prstGeom prst="rect">
             <a:avLst/>
           </a:prstGeom>
           <a:solidFill>
-            <a:srgbClr val="F4D74B"/>
+            <a:srgbClr val="3D68EC"/>
           </a:solidFill>
           <a:ln>
             <a:noFill/>
@@ -20199,13 +18991,13 @@
       </p:sp>
       <p:sp>
         <p:nvSpPr>
-          <p:cNvPr id="113" name="TextBox 112"/>
+          <p:cNvPr id="114" name="TextBox 113"/>
           <p:cNvSpPr txBox="1"/>
           <p:nvPr/>
         </p:nvSpPr>
         <p:spPr>
           <a:xfrm>
-            <a:off x="841247" y="5989320"/>
+            <a:off x="2194560" y="5989320"/>
             <a:ext cx="2194560" cy="274320"/>
           </a:xfrm>
           <a:prstGeom prst="rect">
@@ -20227,27 +19019,27 @@
                 </a:solidFill>
                 <a:latin typeface="General Sans"/>
               </a:rPr>
-              <a:t>Uitleg</a:t>
-            </a:r>
-          </a:p>
-        </p:txBody>
-      </p:sp>
-      <p:sp>
-        <p:nvSpPr>
-          <p:cNvPr id="114" name="Rectangle 113"/>
-          <p:cNvSpPr/>
-          <p:nvPr/>
-        </p:nvSpPr>
-        <p:spPr>
-          <a:xfrm>
-            <a:off x="1901952" y="6025896"/>
+              <a:t>Werken in tweetallen</a:t>
+            </a:r>
+          </a:p>
+        </p:txBody>
+      </p:sp>
+      <p:sp>
+        <p:nvSpPr>
+          <p:cNvPr id="115" name="Rectangle 114"/>
+          <p:cNvSpPr/>
+          <p:nvPr/>
+        </p:nvSpPr>
+        <p:spPr>
+          <a:xfrm>
+            <a:off x="4663440" y="6025896"/>
             <a:ext cx="201168" cy="201168"/>
           </a:xfrm>
           <a:prstGeom prst="rect">
             <a:avLst/>
           </a:prstGeom>
           <a:solidFill>
-            <a:srgbClr val="3D68EC"/>
+            <a:srgbClr val="DD784B"/>
           </a:solidFill>
           <a:ln>
             <a:noFill/>
@@ -20278,13 +19070,13 @@
       </p:sp>
       <p:sp>
         <p:nvSpPr>
-          <p:cNvPr id="115" name="TextBox 114"/>
+          <p:cNvPr id="116" name="TextBox 115"/>
           <p:cNvSpPr txBox="1"/>
           <p:nvPr/>
         </p:nvSpPr>
         <p:spPr>
           <a:xfrm>
-            <a:off x="2194560" y="5989320"/>
+            <a:off x="4956048" y="5989320"/>
             <a:ext cx="2194560" cy="274320"/>
           </a:xfrm>
           <a:prstGeom prst="rect">
@@ -20306,27 +19098,27 @@
                 </a:solidFill>
                 <a:latin typeface="General Sans"/>
               </a:rPr>
-              <a:t>Werken in tweetallen</a:t>
-            </a:r>
-          </a:p>
-        </p:txBody>
-      </p:sp>
-      <p:sp>
-        <p:nvSpPr>
-          <p:cNvPr id="116" name="Rectangle 115"/>
-          <p:cNvSpPr/>
-          <p:nvPr/>
-        </p:nvSpPr>
-        <p:spPr>
-          <a:xfrm>
-            <a:off x="4663440" y="6025896"/>
+              <a:t>Spiegelmoment</a:t>
+            </a:r>
+          </a:p>
+        </p:txBody>
+      </p:sp>
+      <p:sp>
+        <p:nvSpPr>
+          <p:cNvPr id="117" name="Rectangle 116"/>
+          <p:cNvSpPr/>
+          <p:nvPr/>
+        </p:nvSpPr>
+        <p:spPr>
+          <a:xfrm>
+            <a:off x="6720840" y="6025896"/>
             <a:ext cx="201168" cy="201168"/>
           </a:xfrm>
           <a:prstGeom prst="rect">
             <a:avLst/>
           </a:prstGeom>
           <a:solidFill>
-            <a:srgbClr val="DD784B"/>
+            <a:srgbClr val="00AF81"/>
           </a:solidFill>
           <a:ln>
             <a:noFill/>
@@ -20357,13 +19149,13 @@
       </p:sp>
       <p:sp>
         <p:nvSpPr>
-          <p:cNvPr id="117" name="TextBox 116"/>
+          <p:cNvPr id="118" name="TextBox 117"/>
           <p:cNvSpPr txBox="1"/>
           <p:nvPr/>
         </p:nvSpPr>
         <p:spPr>
           <a:xfrm>
-            <a:off x="4956048" y="5989320"/>
+            <a:off x="7013448" y="5989320"/>
             <a:ext cx="2194560" cy="274320"/>
           </a:xfrm>
           <a:prstGeom prst="rect">
@@ -20385,85 +19177,6 @@
                 </a:solidFill>
                 <a:latin typeface="General Sans"/>
               </a:rPr>
-              <a:t>Spiegelmoment</a:t>
-            </a:r>
-          </a:p>
-        </p:txBody>
-      </p:sp>
-      <p:sp>
-        <p:nvSpPr>
-          <p:cNvPr id="118" name="Rectangle 117"/>
-          <p:cNvSpPr/>
-          <p:nvPr/>
-        </p:nvSpPr>
-        <p:spPr>
-          <a:xfrm>
-            <a:off x="6720840" y="6025896"/>
-            <a:ext cx="201168" cy="201168"/>
-          </a:xfrm>
-          <a:prstGeom prst="rect">
-            <a:avLst/>
-          </a:prstGeom>
-          <a:solidFill>
-            <a:srgbClr val="00AF81"/>
-          </a:solidFill>
-          <a:ln>
-            <a:noFill/>
-          </a:ln>
-          <a:effectLst/>
-        </p:spPr>
-        <p:style>
-          <a:lnRef idx="1">
-            <a:schemeClr val="accent1"/>
-          </a:lnRef>
-          <a:fillRef idx="3">
-            <a:schemeClr val="accent1"/>
-          </a:fillRef>
-          <a:effectRef idx="2">
-            <a:schemeClr val="accent1"/>
-          </a:effectRef>
-          <a:fontRef idx="minor">
-            <a:schemeClr val="lt1"/>
-          </a:fontRef>
-        </p:style>
-        <p:txBody>
-          <a:bodyPr rtlCol="0" anchor="ctr"/>
-          <a:lstStyle/>
-          <a:p>
-            <a:pPr algn="ctr"/>
-          </a:p>
-        </p:txBody>
-      </p:sp>
-      <p:sp>
-        <p:nvSpPr>
-          <p:cNvPr id="119" name="TextBox 118"/>
-          <p:cNvSpPr txBox="1"/>
-          <p:nvPr/>
-        </p:nvSpPr>
-        <p:spPr>
-          <a:xfrm>
-            <a:off x="7013448" y="5989320"/>
-            <a:ext cx="2194560" cy="274320"/>
-          </a:xfrm>
-          <a:prstGeom prst="rect">
-            <a:avLst/>
-          </a:prstGeom>
-          <a:noFill/>
-        </p:spPr>
-        <p:txBody>
-          <a:bodyPr wrap="square" lIns="0" rIns="0" tIns="0" bIns="0" anchor="ctr">
-            <a:spAutoFit/>
-          </a:bodyPr>
-          <a:lstStyle/>
-          <a:p>
-            <a:pPr algn="l"/>
-            <a:r>
-              <a:rPr sz="1200">
-                <a:solidFill>
-                  <a:srgbClr val="000000"/>
-                </a:solidFill>
-                <a:latin typeface="General Sans"/>
-              </a:rPr>
               <a:t>Evaluatie en afsluiting</a:t>
             </a:r>
           </a:p>
@@ -20471,7 +19184,7 @@
       </p:sp>
       <p:pic>
         <p:nvPicPr>
-          <p:cNvPr id="120" name="Npuls beeldmerk" descr="npuls-beeldmerk-zwart.png"/>
+          <p:cNvPr id="119" name="Npuls beeldmerk" descr="npuls-beeldmerk-zwart.png"/>
           <p:cNvPicPr>
             <a:picLocks noChangeAspect="1"/>
           </p:cNvPicPr>
@@ -23339,7 +22052,7 @@
                 <a:ea typeface="General Sans Semibold" pitchFamily="34" charset="-122"/>
                 <a:cs typeface="General Sans Semibold" pitchFamily="34" charset="-120"/>
               </a:rPr>
-              <a:t>Drie skills die wij laten zien</a:t>
+              <a:t>Twee skills die wij laten zien</a:t>
             </a:r>
             <a:endParaRPr lang="en-US" sz="3400" dirty="0"/>
           </a:p>
@@ -23354,11 +22067,11 @@
         <p:spPr>
           <a:xfrm>
             <a:off x="548640" y="1371600"/>
-            <a:ext cx="3515258" cy="4069080"/>
+            <a:ext cx="5410048" cy="3490722"/>
           </a:xfrm>
           <a:prstGeom prst="roundRect">
             <a:avLst>
-              <a:gd name="adj" fmla="val 1895"/>
+              <a:gd name="adj" fmla="val 1921"/>
             </a:avLst>
           </a:prstGeom>
           <a:solidFill>
@@ -23438,7 +22151,7 @@
         <p:spPr>
           <a:xfrm>
             <a:off x="1508760" y="1719072"/>
-            <a:ext cx="2280818" cy="402336"/>
+            <a:ext cx="4175608" cy="402336"/>
           </a:xfrm>
           <a:prstGeom prst="roundRect">
             <a:avLst>
@@ -23460,7 +22173,7 @@
         <p:spPr>
           <a:xfrm>
             <a:off x="1600200" y="1719072"/>
-            <a:ext cx="2097938" cy="402336"/>
+            <a:ext cx="3992728" cy="402336"/>
           </a:xfrm>
           <a:prstGeom prst="rect">
             <a:avLst/>
@@ -23502,7 +22215,7 @@
         <p:spPr>
           <a:xfrm>
             <a:off x="822960" y="2423160"/>
-            <a:ext cx="2966618" cy="691896"/>
+            <a:ext cx="4861408" cy="338328"/>
           </a:xfrm>
           <a:prstGeom prst="rect">
             <a:avLst/>
@@ -23521,7 +22234,7 @@
               <a:buNone/>
             </a:pPr>
             <a:r>
-              <a:rPr lang="en-US" sz="2300" dirty="0">
+              <a:rPr lang="en-US" sz="2200" dirty="0">
                 <a:solidFill>
                   <a:srgbClr val="F4D9DC"/>
                 </a:solidFill>
@@ -23531,7 +22244,7 @@
               </a:rPr>
               <a:t>/workshop-verkennen</a:t>
             </a:r>
-            <a:endParaRPr lang="en-US" sz="2300" dirty="0"/>
+            <a:endParaRPr lang="en-US" sz="2200" dirty="0"/>
           </a:p>
         </p:txBody>
       </p:sp>
@@ -23543,8 +22256,8 @@
         </p:nvSpPr>
         <p:spPr>
           <a:xfrm>
-            <a:off x="822960" y="3389376"/>
-            <a:ext cx="2966618" cy="274320"/>
+            <a:off x="822960" y="3035808"/>
+            <a:ext cx="4861408" cy="274320"/>
           </a:xfrm>
           <a:prstGeom prst="rect">
             <a:avLst/>
@@ -23585,8 +22298,8 @@
         </p:nvSpPr>
         <p:spPr>
           <a:xfrm>
-            <a:off x="822960" y="3736848"/>
-            <a:ext cx="2966618" cy="541020"/>
+            <a:off x="822960" y="3383280"/>
+            <a:ext cx="4861408" cy="541020"/>
           </a:xfrm>
           <a:prstGeom prst="rect">
             <a:avLst/>
@@ -23627,8 +22340,8 @@
         </p:nvSpPr>
         <p:spPr>
           <a:xfrm>
-            <a:off x="822960" y="4415028"/>
-            <a:ext cx="2966618" cy="274320"/>
+            <a:off x="822960" y="4061460"/>
+            <a:ext cx="4861408" cy="274320"/>
           </a:xfrm>
           <a:prstGeom prst="rect">
             <a:avLst/>
@@ -23669,8 +22382,8 @@
         </p:nvSpPr>
         <p:spPr>
           <a:xfrm>
-            <a:off x="822960" y="4762500"/>
-            <a:ext cx="2966618" cy="541020"/>
+            <a:off x="822960" y="4408932"/>
+            <a:ext cx="4861408" cy="316230"/>
           </a:xfrm>
           <a:prstGeom prst="rect">
             <a:avLst/>
@@ -23711,12 +22424,12 @@
         </p:nvSpPr>
         <p:spPr>
           <a:xfrm>
-            <a:off x="4338218" y="1371600"/>
-            <a:ext cx="3515258" cy="4069080"/>
+            <a:off x="6233008" y="1371600"/>
+            <a:ext cx="5410048" cy="3490722"/>
           </a:xfrm>
           <a:prstGeom prst="roundRect">
             <a:avLst>
-              <a:gd name="adj" fmla="val 1895"/>
+              <a:gd name="adj" fmla="val 1921"/>
             </a:avLst>
           </a:prstGeom>
           <a:solidFill>
@@ -23733,7 +22446,7 @@
         </p:nvSpPr>
         <p:spPr>
           <a:xfrm>
-            <a:off x="4612538" y="1645920"/>
+            <a:off x="6507328" y="1645920"/>
             <a:ext cx="548640" cy="548640"/>
           </a:xfrm>
           <a:prstGeom prst="ellipse">
@@ -23753,7 +22466,7 @@
         </p:nvSpPr>
         <p:spPr>
           <a:xfrm>
-            <a:off x="4612538" y="1645920"/>
+            <a:off x="6507328" y="1645920"/>
             <a:ext cx="548640" cy="548640"/>
           </a:xfrm>
           <a:prstGeom prst="rect">
@@ -23795,8 +22508,8 @@
         </p:nvSpPr>
         <p:spPr>
           <a:xfrm>
-            <a:off x="5298338" y="1719072"/>
-            <a:ext cx="2280818" cy="402336"/>
+            <a:off x="7193128" y="1719072"/>
+            <a:ext cx="4175608" cy="402336"/>
           </a:xfrm>
           <a:prstGeom prst="roundRect">
             <a:avLst>
@@ -23817,8 +22530,8 @@
         </p:nvSpPr>
         <p:spPr>
           <a:xfrm>
-            <a:off x="5389778" y="1719072"/>
-            <a:ext cx="2097938" cy="402336"/>
+            <a:off x="7284568" y="1719072"/>
+            <a:ext cx="3992728" cy="402336"/>
           </a:xfrm>
           <a:prstGeom prst="rect">
             <a:avLst/>
@@ -23859,8 +22572,8 @@
         </p:nvSpPr>
         <p:spPr>
           <a:xfrm>
-            <a:off x="4612538" y="2423160"/>
-            <a:ext cx="2966618" cy="691896"/>
+            <a:off x="6507328" y="2423160"/>
+            <a:ext cx="4861408" cy="338328"/>
           </a:xfrm>
           <a:prstGeom prst="rect">
             <a:avLst/>
@@ -23879,7 +22592,7 @@
               <a:buNone/>
             </a:pPr>
             <a:r>
-              <a:rPr lang="en-US" sz="2300" dirty="0">
+              <a:rPr lang="en-US" sz="2200" dirty="0">
                 <a:solidFill>
                   <a:srgbClr val="000000"/>
                 </a:solidFill>
@@ -23889,7 +22602,7 @@
               </a:rPr>
               <a:t>/workshop-dashboard</a:t>
             </a:r>
-            <a:endParaRPr lang="en-US" sz="2300" dirty="0"/>
+            <a:endParaRPr lang="en-US" sz="2200" dirty="0"/>
           </a:p>
         </p:txBody>
       </p:sp>
@@ -23901,8 +22614,8 @@
         </p:nvSpPr>
         <p:spPr>
           <a:xfrm>
-            <a:off x="4612538" y="3389376"/>
-            <a:ext cx="2966618" cy="274320"/>
+            <a:off x="6507328" y="3035808"/>
+            <a:ext cx="4861408" cy="274320"/>
           </a:xfrm>
           <a:prstGeom prst="rect">
             <a:avLst/>
@@ -23943,8 +22656,8 @@
         </p:nvSpPr>
         <p:spPr>
           <a:xfrm>
-            <a:off x="4612538" y="3736848"/>
-            <a:ext cx="2966618" cy="541020"/>
+            <a:off x="6507328" y="3383280"/>
+            <a:ext cx="4861408" cy="541020"/>
           </a:xfrm>
           <a:prstGeom prst="rect">
             <a:avLst/>
@@ -23985,8 +22698,8 @@
         </p:nvSpPr>
         <p:spPr>
           <a:xfrm>
-            <a:off x="4612538" y="4415028"/>
-            <a:ext cx="2966618" cy="274320"/>
+            <a:off x="6507328" y="4061460"/>
+            <a:ext cx="4861408" cy="274320"/>
           </a:xfrm>
           <a:prstGeom prst="rect">
             <a:avLst/>
@@ -24027,8 +22740,8 @@
         </p:nvSpPr>
         <p:spPr>
           <a:xfrm>
-            <a:off x="4612538" y="4762500"/>
-            <a:ext cx="2966618" cy="541020"/>
+            <a:off x="6507328" y="4408932"/>
+            <a:ext cx="4861408" cy="316230"/>
           </a:xfrm>
           <a:prstGeom prst="rect">
             <a:avLst/>
@@ -24063,162 +22776,14 @@
       </p:sp>
       <p:sp>
         <p:nvSpPr>
-          <p:cNvPr id="93" name="Shape 91"/>
-          <p:cNvSpPr/>
-          <p:nvPr/>
-        </p:nvSpPr>
-        <p:spPr>
-          <a:xfrm>
-            <a:off x="8127797" y="1371600"/>
-            <a:ext cx="3515258" cy="4069080"/>
-          </a:xfrm>
-          <a:prstGeom prst="roundRect">
-            <a:avLst>
-              <a:gd name="adj" fmla="val 1895"/>
-            </a:avLst>
-          </a:prstGeom>
-          <a:solidFill>
-            <a:srgbClr val="00AF81"/>
-          </a:solidFill>
-          <a:ln/>
-        </p:spPr>
-      </p:sp>
-      <p:sp>
-        <p:nvSpPr>
-          <p:cNvPr id="94" name="Shape 92"/>
-          <p:cNvSpPr/>
-          <p:nvPr/>
-        </p:nvSpPr>
-        <p:spPr>
-          <a:xfrm>
-            <a:off x="8402117" y="1645920"/>
-            <a:ext cx="548640" cy="548640"/>
-          </a:xfrm>
-          <a:prstGeom prst="ellipse">
-            <a:avLst/>
-          </a:prstGeom>
-          <a:solidFill>
-            <a:srgbClr val="F4D9DC"/>
-          </a:solidFill>
-          <a:ln/>
-        </p:spPr>
-      </p:sp>
-      <p:sp>
-        <p:nvSpPr>
-          <p:cNvPr id="95" name="Text 93"/>
-          <p:cNvSpPr/>
-          <p:nvPr/>
-        </p:nvSpPr>
-        <p:spPr>
-          <a:xfrm>
-            <a:off x="8402117" y="1645920"/>
-            <a:ext cx="548640" cy="548640"/>
-          </a:xfrm>
-          <a:prstGeom prst="rect">
-            <a:avLst/>
-          </a:prstGeom>
-          <a:noFill/>
-          <a:ln/>
-        </p:spPr>
-        <p:txBody>
-          <a:bodyPr wrap="square" lIns="0" tIns="0" rIns="0" bIns="0" rtlCol="0" anchor="ctr"/>
-          <a:lstStyle/>
-          <a:p>
-            <a:pPr algn="ctr" indent="0" marL="0">
-              <a:lnSpc>
-                <a:spcPct val="105000"/>
-              </a:lnSpc>
-              <a:buNone/>
-            </a:pPr>
-            <a:r>
-              <a:rPr lang="en-US" sz="2000" dirty="0">
-                <a:solidFill>
-                  <a:srgbClr val="000000"/>
-                </a:solidFill>
-                <a:latin typeface="General Sans Semibold" pitchFamily="34" charset="0"/>
-                <a:ea typeface="General Sans Semibold" pitchFamily="34" charset="-122"/>
-                <a:cs typeface="General Sans Semibold" pitchFamily="34" charset="-120"/>
-              </a:rPr>
-              <a:t>3</a:t>
-            </a:r>
-            <a:endParaRPr lang="en-US" sz="2000" dirty="0"/>
-          </a:p>
-        </p:txBody>
-      </p:sp>
-      <p:sp>
-        <p:nvSpPr>
-          <p:cNvPr id="96" name="Shape 94"/>
-          <p:cNvSpPr/>
-          <p:nvPr/>
-        </p:nvSpPr>
-        <p:spPr>
-          <a:xfrm>
-            <a:off x="9087917" y="1719072"/>
-            <a:ext cx="2280818" cy="402336"/>
-          </a:xfrm>
-          <a:prstGeom prst="roundRect">
-            <a:avLst>
-              <a:gd name="adj" fmla="val 113636"/>
-            </a:avLst>
-          </a:prstGeom>
-          <a:solidFill>
-            <a:srgbClr val="F4D9DC"/>
-          </a:solidFill>
-          <a:ln/>
-        </p:spPr>
-      </p:sp>
-      <p:sp>
-        <p:nvSpPr>
-          <p:cNvPr id="97" name="Text 95"/>
-          <p:cNvSpPr/>
-          <p:nvPr/>
-        </p:nvSpPr>
-        <p:spPr>
-          <a:xfrm>
-            <a:off x="9179357" y="1719072"/>
-            <a:ext cx="2097938" cy="402336"/>
-          </a:xfrm>
-          <a:prstGeom prst="rect">
-            <a:avLst/>
-          </a:prstGeom>
-          <a:noFill/>
-          <a:ln/>
-        </p:spPr>
-        <p:txBody>
-          <a:bodyPr wrap="square" lIns="0" tIns="0" rIns="0" bIns="0" rtlCol="0" anchor="ctr"/>
-          <a:lstStyle/>
-          <a:p>
-            <a:pPr algn="ctr" indent="0" marL="0">
-              <a:lnSpc>
-                <a:spcPct val="105000"/>
-              </a:lnSpc>
-              <a:buNone/>
-            </a:pPr>
-            <a:r>
-              <a:rPr lang="en-US" sz="1200" dirty="0">
-                <a:solidFill>
-                  <a:srgbClr val="000000"/>
-                </a:solidFill>
-                <a:latin typeface="General Sans Semibold" pitchFamily="34" charset="0"/>
-                <a:ea typeface="General Sans Semibold" pitchFamily="34" charset="-122"/>
-                <a:cs typeface="General Sans Semibold" pitchFamily="34" charset="-120"/>
-              </a:rPr>
-              <a:t>Evaluatie</a:t>
-            </a:r>
-            <a:endParaRPr lang="en-US" sz="1200" dirty="0"/>
-          </a:p>
-        </p:txBody>
-      </p:sp>
-      <p:sp>
-        <p:nvSpPr>
-          <p:cNvPr id="98" name="Text 96"/>
-          <p:cNvSpPr/>
-          <p:nvPr/>
-        </p:nvSpPr>
-        <p:spPr>
-          <a:xfrm>
-            <a:off x="8402117" y="2423160"/>
-            <a:ext cx="2966618" cy="691896"/>
+          <p:cNvPr id="93" name="Text 91"/>
+          <p:cNvSpPr/>
+          <p:nvPr/>
+        </p:nvSpPr>
+        <p:spPr>
+          <a:xfrm>
+            <a:off x="548640" y="5045202"/>
+            <a:ext cx="11094415" cy="457200"/>
           </a:xfrm>
           <a:prstGeom prst="rect">
             <a:avLst/>
@@ -24237,91 +22802,7 @@
               <a:buNone/>
             </a:pPr>
             <a:r>
-              <a:rPr lang="en-US" sz="2300" dirty="0">
-                <a:solidFill>
-                  <a:srgbClr val="000000"/>
-                </a:solidFill>
-                <a:latin typeface="General Sans Semibold" pitchFamily="34" charset="0"/>
-                <a:ea typeface="General Sans Semibold" pitchFamily="34" charset="-122"/>
-                <a:cs typeface="General Sans Semibold" pitchFamily="34" charset="-120"/>
-              </a:rPr>
-              <a:t>/workshop-reflectie</a:t>
-            </a:r>
-            <a:endParaRPr lang="en-US" sz="2300" dirty="0"/>
-          </a:p>
-        </p:txBody>
-      </p:sp>
-      <p:sp>
-        <p:nvSpPr>
-          <p:cNvPr id="99" name="Text 97"/>
-          <p:cNvSpPr/>
-          <p:nvPr/>
-        </p:nvSpPr>
-        <p:spPr>
-          <a:xfrm>
-            <a:off x="8402117" y="3389376"/>
-            <a:ext cx="2966618" cy="274320"/>
-          </a:xfrm>
-          <a:prstGeom prst="rect">
-            <a:avLst/>
-          </a:prstGeom>
-          <a:noFill/>
-          <a:ln/>
-        </p:spPr>
-        <p:txBody>
-          <a:bodyPr wrap="square" lIns="0" tIns="0" rIns="0" bIns="0" rtlCol="0" anchor="t"/>
-          <a:lstStyle/>
-          <a:p>
-            <a:pPr algn="l" indent="0" marL="0">
-              <a:lnSpc>
-                <a:spcPct val="105000"/>
-              </a:lnSpc>
-              <a:buNone/>
-            </a:pPr>
-            <a:r>
-              <a:rPr lang="en-US" sz="1100" spc="300" kern="0" dirty="0">
-                <a:solidFill>
-                  <a:srgbClr val="000000"/>
-                </a:solidFill>
-                <a:latin typeface="General Sans Semibold" pitchFamily="34" charset="0"/>
-                <a:ea typeface="General Sans Semibold" pitchFamily="34" charset="-122"/>
-                <a:cs typeface="General Sans Semibold" pitchFamily="34" charset="-120"/>
-              </a:rPr>
-              <a:t>DOET</a:t>
-            </a:r>
-            <a:endParaRPr lang="en-US" sz="1100" dirty="0"/>
-          </a:p>
-        </p:txBody>
-      </p:sp>
-      <p:sp>
-        <p:nvSpPr>
-          <p:cNvPr id="100" name="Text 98"/>
-          <p:cNvSpPr/>
-          <p:nvPr/>
-        </p:nvSpPr>
-        <p:spPr>
-          <a:xfrm>
-            <a:off x="8402117" y="3736848"/>
-            <a:ext cx="2966618" cy="541020"/>
-          </a:xfrm>
-          <a:prstGeom prst="rect">
-            <a:avLst/>
-          </a:prstGeom>
-          <a:noFill/>
-          <a:ln/>
-        </p:spPr>
-        <p:txBody>
-          <a:bodyPr wrap="square" lIns="0" tIns="0" rIns="0" bIns="0" rtlCol="0" anchor="t"/>
-          <a:lstStyle/>
-          <a:p>
-            <a:pPr algn="l" indent="0" marL="0">
-              <a:lnSpc>
-                <a:spcPct val="105000"/>
-              </a:lnSpc>
-              <a:buNone/>
-            </a:pPr>
-            <a:r>
-              <a:rPr lang="en-US" sz="1500" dirty="0">
+              <a:rPr lang="en-US" sz="1600" dirty="0">
                 <a:solidFill>
                   <a:srgbClr val="000000"/>
                 </a:solidFill>
@@ -24329,132 +22810,6 @@
                 <a:ea typeface="General Sans" pitchFamily="34" charset="-122"/>
                 <a:cs typeface="General Sans" pitchFamily="34" charset="-120"/>
               </a:rPr>
-              <a:t>Terugblik en vervolgwensen in je eigen woorden.</a:t>
-            </a:r>
-            <a:endParaRPr lang="en-US" sz="1500" dirty="0"/>
-          </a:p>
-        </p:txBody>
-      </p:sp>
-      <p:sp>
-        <p:nvSpPr>
-          <p:cNvPr id="101" name="Text 99"/>
-          <p:cNvSpPr/>
-          <p:nvPr/>
-        </p:nvSpPr>
-        <p:spPr>
-          <a:xfrm>
-            <a:off x="8402117" y="4415028"/>
-            <a:ext cx="2966618" cy="274320"/>
-          </a:xfrm>
-          <a:prstGeom prst="rect">
-            <a:avLst/>
-          </a:prstGeom>
-          <a:noFill/>
-          <a:ln/>
-        </p:spPr>
-        <p:txBody>
-          <a:bodyPr wrap="square" lIns="0" tIns="0" rIns="0" bIns="0" rtlCol="0" anchor="t"/>
-          <a:lstStyle/>
-          <a:p>
-            <a:pPr algn="l" indent="0" marL="0">
-              <a:lnSpc>
-                <a:spcPct val="105000"/>
-              </a:lnSpc>
-              <a:buNone/>
-            </a:pPr>
-            <a:r>
-              <a:rPr lang="en-US" sz="1100" spc="300" kern="0" dirty="0">
-                <a:solidFill>
-                  <a:srgbClr val="000000"/>
-                </a:solidFill>
-                <a:latin typeface="General Sans Semibold" pitchFamily="34" charset="0"/>
-                <a:ea typeface="General Sans Semibold" pitchFamily="34" charset="-122"/>
-                <a:cs typeface="General Sans Semibold" pitchFamily="34" charset="-120"/>
-              </a:rPr>
-              <a:t>LEVERT</a:t>
-            </a:r>
-            <a:endParaRPr lang="en-US" sz="1100" dirty="0"/>
-          </a:p>
-        </p:txBody>
-      </p:sp>
-      <p:sp>
-        <p:nvSpPr>
-          <p:cNvPr id="102" name="Text 100"/>
-          <p:cNvSpPr/>
-          <p:nvPr/>
-        </p:nvSpPr>
-        <p:spPr>
-          <a:xfrm>
-            <a:off x="8402117" y="4762500"/>
-            <a:ext cx="2966618" cy="541020"/>
-          </a:xfrm>
-          <a:prstGeom prst="rect">
-            <a:avLst/>
-          </a:prstGeom>
-          <a:noFill/>
-          <a:ln/>
-        </p:spPr>
-        <p:txBody>
-          <a:bodyPr wrap="square" lIns="0" tIns="0" rIns="0" bIns="0" rtlCol="0" anchor="t"/>
-          <a:lstStyle/>
-          <a:p>
-            <a:pPr algn="l" indent="0" marL="0">
-              <a:lnSpc>
-                <a:spcPct val="105000"/>
-              </a:lnSpc>
-              <a:buNone/>
-            </a:pPr>
-            <a:r>
-              <a:rPr lang="en-US" sz="1500" dirty="0">
-                <a:solidFill>
-                  <a:srgbClr val="000000"/>
-                </a:solidFill>
-                <a:latin typeface="General Sans Semibold" pitchFamily="34" charset="0"/>
-                <a:ea typeface="General Sans Semibold" pitchFamily="34" charset="-122"/>
-                <a:cs typeface="General Sans Semibold" pitchFamily="34" charset="-120"/>
-              </a:rPr>
-              <a:t>reflectie-naam.md</a:t>
-            </a:r>
-            <a:endParaRPr lang="en-US" sz="1500" dirty="0"/>
-          </a:p>
-        </p:txBody>
-      </p:sp>
-      <p:sp>
-        <p:nvSpPr>
-          <p:cNvPr id="103" name="Text 101"/>
-          <p:cNvSpPr/>
-          <p:nvPr/>
-        </p:nvSpPr>
-        <p:spPr>
-          <a:xfrm>
-            <a:off x="548640" y="5623560"/>
-            <a:ext cx="11094415" cy="457200"/>
-          </a:xfrm>
-          <a:prstGeom prst="rect">
-            <a:avLst/>
-          </a:prstGeom>
-          <a:noFill/>
-          <a:ln/>
-        </p:spPr>
-        <p:txBody>
-          <a:bodyPr wrap="square" lIns="0" tIns="0" rIns="0" bIns="0" rtlCol="0" anchor="t"/>
-          <a:lstStyle/>
-          <a:p>
-            <a:pPr algn="l" indent="0" marL="0">
-              <a:lnSpc>
-                <a:spcPct val="105000"/>
-              </a:lnSpc>
-              <a:buNone/>
-            </a:pPr>
-            <a:r>
-              <a:rPr lang="en-US" sz="1600" dirty="0">
-                <a:solidFill>
-                  <a:srgbClr val="000000"/>
-                </a:solidFill>
-                <a:latin typeface="General Sans" pitchFamily="34" charset="0"/>
-                <a:ea typeface="General Sans" pitchFamily="34" charset="-122"/>
-                <a:cs typeface="General Sans" pitchFamily="34" charset="-120"/>
-              </a:rPr>
               <a:t>Jullie prompten zelf in de rondes. Wij laten de skills live draaien bij de spiegelmomenten.</a:t>
             </a:r>
             <a:endParaRPr lang="en-US" sz="1600" dirty="0"/>
@@ -24463,7 +22818,7 @@
       </p:sp>
       <p:pic>
         <p:nvPicPr>
-          <p:cNvPr id="104" name="Npuls beeldmerk" descr="npuls-beeldmerk-zwart.png"/>
+          <p:cNvPr id="94" name="Npuls beeldmerk" descr="npuls-beeldmerk-zwart.png"/>
           <p:cNvPicPr>
             <a:picLocks noChangeAspect="1"/>
           </p:cNvPicPr>

</xml_diff>